<commit_message>
docs: split Phase 2 into F1–F3 epics on the board map
Keep remaining work sequenced by Detect backends, org-scale Prove, and adjacent non-pitch items so the catch-all Future epic is no longer the source of truth.

Co-authored-by: Cursor <cursoragent@cursor.com>
</commit_message>
<xml_diff>
--- a/docs/pitch/TokenForge-Pitch.pptx
+++ b/docs/pitch/TokenForge-Pitch.pptx
@@ -3202,7 +3202,7 @@
               <a:defRPr sz="2000"/>
             </a:pPr>
             <a:r>
-              <a:t>Hybrid scan backends: Ollama, OpenAI-compat, Anthropic</a:t>
+              <a:t>Shipped: heuristic default, Ollama hybrid, dashboard LLM boards</a:t>
             </a:r>
           </a:p>
           <a:p>
@@ -3210,7 +3210,7 @@
               <a:defRPr sz="1800"/>
             </a:pPr>
             <a:r>
-              <a:t>Dashboard LLM finding badges</a:t>
+              <a:t>F1 Hybrid Detect: OpenAI-compat + Anthropic enrichers, then extension hook</a:t>
             </a:r>
           </a:p>
           <a:p>
@@ -3218,7 +3218,7 @@
               <a:defRPr sz="1800"/>
             </a:pPr>
             <a:r>
-              <a:t>Extension enricher on instruction paths</a:t>
+              <a:t>F2 Org scale: live usage/billing (per provider) → org policy apply</a:t>
             </a:r>
           </a:p>
           <a:p>
@@ -3226,7 +3226,7 @@
               <a:defRPr sz="1800"/>
             </a:pPr>
             <a:r>
-              <a:t>Chat compaction · model routing · live billing sync</a:t>
+              <a:t>F3 Adjacent (do not pitch): chat compaction · model routing</a:t>
             </a:r>
           </a:p>
         </p:txBody>

</xml_diff>

<commit_message>
docs: refresh exec pitch deck, FAQ, and demo runbook
Position TokenForge for board review with competition landscape,
per-team Prove beats, and honest F2/F3 thin-slice roadmap language.

Co-authored-by: Cursor <cursoragent@cursor.com>
</commit_message>
<xml_diff>
--- a/docs/pitch/TokenForge-Pitch.pptx
+++ b/docs/pitch/TokenForge-Pitch.pptx
@@ -3178,7 +3178,7 @@
           <a:lstStyle/>
           <a:p>
             <a:r>
-              <a:t>Roadmap (Phase 2)</a:t>
+              <a:t>Ask</a:t>
             </a:r>
           </a:p>
         </p:txBody>
@@ -3202,7 +3202,7 @@
               <a:defRPr sz="2000"/>
             </a:pPr>
             <a:r>
-              <a:t>Shipped: heuristic default, Ollama hybrid, dashboard LLM boards</a:t>
+              <a:t>Category: AI Coding FinOps for metered coding agents.</a:t>
             </a:r>
           </a:p>
           <a:p>
@@ -3210,7 +3210,7 @@
               <a:defRPr sz="1800"/>
             </a:pPr>
             <a:r>
-              <a:t>F1 Hybrid Detect: OpenAI-compat + Anthropic enrichers, then extension hook</a:t>
+              <a:t>Next proof: pilot on one business unit.</a:t>
             </a:r>
           </a:p>
           <a:p>
@@ -3218,7 +3218,7 @@
               <a:defRPr sz="1800"/>
             </a:pPr>
             <a:r>
-              <a:t>F2 Org scale: live usage/billing (per provider) → org policy apply</a:t>
+              <a:t>They help the agent remember.</a:t>
             </a:r>
           </a:p>
           <a:p>
@@ -3226,7 +3226,7 @@
               <a:defRPr sz="1800"/>
             </a:pPr>
             <a:r>
-              <a:t>F3 Adjacent (do not pitch): chat compaction · model routing</a:t>
+              <a:t>We help the organisation stop bleeding tokens.</a:t>
             </a:r>
           </a:p>
         </p:txBody>
@@ -3368,7 +3368,7 @@
           <a:lstStyle/>
           <a:p>
             <a:r>
-              <a:t>Who it's for</a:t>
+              <a:t>Market landscape</a:t>
             </a:r>
           </a:p>
         </p:txBody>
@@ -3392,7 +3392,7 @@
               <a:defRPr sz="2000"/>
             </a:pPr>
             <a:r>
-              <a:t>Eng Manager / FinOps — buyer (ROI, team waste, projected $)</a:t>
+              <a:t>Agent memory (Auto Memory, Cursor Memories) — continuity, not $ waste</a:t>
             </a:r>
           </a:p>
           <a:p>
@@ -3400,7 +3400,7 @@
               <a:defRPr sz="1800"/>
             </a:pPr>
             <a:r>
-              <a:t>Developer — user (IDE risk signal + one-click repo fix)</a:t>
+              <a:t>Cloud / infra FinOps — blind to IDE/repo AI-context waste</a:t>
             </a:r>
           </a:p>
           <a:p>
@@ -3408,7 +3408,15 @@
               <a:defRPr sz="1800"/>
             </a:pPr>
             <a:r>
-              <a:t>Platform / DevEx — rollout (CLI + policy pack at scale)</a:t>
+              <a:t>LLM ops / prompt observability — API traces, not coding-agent hygiene</a:t>
+            </a:r>
+          </a:p>
+          <a:p>
+            <a:pPr>
+              <a:defRPr sz="1800"/>
+            </a:pPr>
+            <a:r>
+              <a:t>Vendor usage dashboards — show spend; do not Detect → Fix waste</a:t>
             </a:r>
           </a:p>
         </p:txBody>
@@ -3447,7 +3455,7 @@
           <a:lstStyle/>
           <a:p>
             <a:r>
-              <a:t>Core loop</a:t>
+              <a:t>Why TokenForge is different</a:t>
             </a:r>
           </a:p>
         </p:txBody>
@@ -3471,7 +3479,7 @@
               <a:defRPr sz="2000"/>
             </a:pPr>
             <a:r>
-              <a:t>1. Detect — score risky context (provider-agnostic)</a:t>
+              <a:t>Auto Memory: enriches continuity for one agent</a:t>
             </a:r>
           </a:p>
           <a:p>
@@ -3479,7 +3487,7 @@
               <a:defRPr sz="1800"/>
             </a:pPr>
             <a:r>
-              <a:t>2. Fix — lean instructions + exclusions via adapters</a:t>
+              <a:t>TokenForge: cuts billable waste for the enterprise</a:t>
             </a:r>
           </a:p>
           <a:p>
@@ -3487,7 +3495,31 @@
               <a:defRPr sz="1800"/>
             </a:pPr>
             <a:r>
-              <a:t>3. Prove — Tokens Saved dashboard ($ / credits / tokens)</a:t>
+              <a:t>Unique: Token Risk → policy pack → $ proof</a:t>
+            </a:r>
+          </a:p>
+          <a:p>
+            <a:pPr>
+              <a:defRPr sz="1800"/>
+            </a:pPr>
+            <a:r>
+              <a:t>  + global BU and per-team/repo Prove across architectures</a:t>
+            </a:r>
+          </a:p>
+          <a:p>
+            <a:pPr>
+              <a:defRPr sz="1800"/>
+            </a:pPr>
+            <a:r>
+              <a:t>Sound bite: They help the agent remember.</a:t>
+            </a:r>
+          </a:p>
+          <a:p>
+            <a:pPr>
+              <a:defRPr sz="1800"/>
+            </a:pPr>
+            <a:r>
+              <a:t>  We help the organisation stop bleeding tokens.</a:t>
             </a:r>
           </a:p>
         </p:txBody>
@@ -3526,7 +3558,7 @@
           <a:lstStyle/>
           <a:p>
             <a:r>
-              <a:t>Detect: two layers</a:t>
+              <a:t>Who it's for</a:t>
             </a:r>
           </a:p>
         </p:txBody>
@@ -3550,7 +3582,7 @@
               <a:defRPr sz="2000"/>
             </a:pPr>
             <a:r>
-              <a:t>Default: heuristic scan (fast, offline, deterministic)</a:t>
+              <a:t>Eng Manager / FinOps — buyer (ROI, team waste, projected $)</a:t>
             </a:r>
           </a:p>
           <a:p>
@@ -3558,7 +3590,7 @@
               <a:defRPr sz="1800"/>
             </a:pPr>
             <a:r>
-              <a:t>• file size × inactivity × filetype class</a:t>
+              <a:t>Developer — user (IDE risk signal + one-click repo fix)</a:t>
             </a:r>
           </a:p>
           <a:p>
@@ -3566,36 +3598,7 @@
               <a:defRPr sz="1800"/>
             </a:pPr>
             <a:r>
-              <a:t>• estTokens ≈ ceil(bytes / 4)</a:t>
-            </a:r>
-          </a:p>
-          <a:p>
-            <a:pPr>
-              <a:defRPr sz="1800"/>
-            </a:pPr>
-          </a:p>
-          <a:p>
-            <a:pPr>
-              <a:defRPr sz="1800"/>
-            </a:pPr>
-            <a:r>
-              <a:t>Optional Phase 2: hybrid enrichment</a:t>
-            </a:r>
-          </a:p>
-          <a:p>
-            <a:pPr>
-              <a:defRPr sz="1800"/>
-            </a:pPr>
-            <a:r>
-              <a:t>• same baseline + LLM semantic pass on bounded candidates</a:t>
-            </a:r>
-          </a:p>
-          <a:p>
-            <a:pPr>
-              <a:defRPr sz="1800"/>
-            </a:pPr>
-            <a:r>
-              <a:t>• local (Ollama / Qwen) or external (OpenAI, Anthropic, …)</a:t>
+              <a:t>Platform / DevEx — rollout (CLI + org policy pack at scale)</a:t>
             </a:r>
           </a:p>
         </p:txBody>
@@ -3634,7 +3637,7 @@
           <a:lstStyle/>
           <a:p>
             <a:r>
-              <a:t>Hybrid scan honesty</a:t>
+              <a:t>Core loop</a:t>
             </a:r>
           </a:p>
         </p:txBody>
@@ -3658,7 +3661,7 @@
               <a:defRPr sz="2000"/>
             </a:pPr>
             <a:r>
-              <a:t>Default scan does NOT use AI.</a:t>
+              <a:t>1. Detect — score risky context (provider-agnostic; hybrid optional)</a:t>
             </a:r>
           </a:p>
           <a:p>
@@ -3666,7 +3669,7 @@
               <a:defRPr sz="1800"/>
             </a:pPr>
             <a:r>
-              <a:t>Hybrid is opt-in (--mode hybrid).</a:t>
+              <a:t>2. Fix — lean instructions + exclusions via adapters</a:t>
             </a:r>
           </a:p>
           <a:p>
@@ -3674,7 +3677,7 @@
               <a:defRPr sz="1800"/>
             </a:pPr>
             <a:r>
-              <a:t>Token math stays heuristic — not model guesses.</a:t>
+              <a:t>   (Copilot, Cursor, Claude, generic) + org-pack aggregation</a:t>
             </a:r>
           </a:p>
           <a:p>
@@ -3682,7 +3685,7 @@
               <a:defRPr sz="1800"/>
             </a:pPr>
             <a:r>
-              <a:t>External enrichers may send candidate excerpts off-machine.</a:t>
+              <a:t>3. Prove — global BU + per-team dashboards</a:t>
             </a:r>
           </a:p>
           <a:p>
@@ -3690,7 +3693,7 @@
               <a:defRPr sz="1800"/>
             </a:pPr>
             <a:r>
-              <a:t>We advise / exclude — we do not intercept agent pipelines.</a:t>
+              <a:t>   (microservices / serverless / data platforms)</a:t>
             </a:r>
           </a:p>
         </p:txBody>
@@ -3729,7 +3732,7 @@
           <a:lstStyle/>
           <a:p>
             <a:r>
-              <a:t>Architecture</a:t>
+              <a:t>Live demo (≤5 min)</a:t>
             </a:r>
           </a:p>
         </p:txBody>
@@ -3753,7 +3756,7 @@
               <a:defRPr sz="2000"/>
             </a:pPr>
             <a:r>
-              <a:t>Ports &amp; adapters (hexagonal)</a:t>
+              <a:t>Noisy IDE tabs → Context Guard risk drops</a:t>
             </a:r>
           </a:p>
           <a:p>
@@ -3761,7 +3764,7 @@
               <a:defRPr sz="1800"/>
             </a:pPr>
             <a:r>
-              <a:t>Kernel: packages/risk-core</a:t>
+              <a:t>CLI scan → apply policy pack</a:t>
             </a:r>
           </a:p>
           <a:p>
@@ -3769,7 +3772,7 @@
               <a:defRPr sz="1800"/>
             </a:pPr>
             <a:r>
-              <a:t>Edges: extension (Detect), CLI adapters (Fix + LLM enrichers), dashboard (Prove)</a:t>
+              <a:t>Dashboard Global → team drill-down → architecture mix</a:t>
             </a:r>
           </a:p>
           <a:p>
@@ -3777,7 +3780,15 @@
               <a:defRPr sz="1800"/>
             </a:pPr>
             <a:r>
-              <a:t>Integration: .tokenforge/scan-report.json</a:t>
+              <a:t>Assumptions → ~30% scenario · imported usage badge</a:t>
+            </a:r>
+          </a:p>
+          <a:p>
+            <a:pPr>
+              <a:defRPr sz="1800"/>
+            </a:pPr>
+            <a:r>
+              <a:t>Close: memory products ≠ FinOps control loop</a:t>
             </a:r>
           </a:p>
         </p:txBody>
@@ -3816,7 +3827,7 @@
           <a:lstStyle/>
           <a:p>
             <a:r>
-              <a:t>MVP demo (≤5 min)</a:t>
+              <a:t>Honesty &amp; trust</a:t>
             </a:r>
           </a:p>
         </p:txBody>
@@ -3840,7 +3851,7 @@
               <a:defRPr sz="2000"/>
             </a:pPr>
             <a:r>
-              <a:t>Noisy IDE tabs → extension risk drops</a:t>
+              <a:t>We advise / exclude — we do not intercept agent pipelines.</a:t>
             </a:r>
           </a:p>
           <a:p>
@@ -3848,7 +3859,7 @@
               <a:defRPr sz="1800"/>
             </a:pPr>
             <a:r>
-              <a:t>CLI tokenforge init → policy pack</a:t>
+              <a:t>Default scan is heuristic (no AI); hybrid is opt-in.</a:t>
             </a:r>
           </a:p>
           <a:p>
@@ -3856,7 +3867,7 @@
               <a:defRPr sz="1800"/>
             </a:pPr>
             <a:r>
-              <a:t>Dashboard → ~30% scenario on demo seed</a:t>
+              <a:t>~30% = editable assumptions × scan totals — not a universal SLA.</a:t>
             </a:r>
           </a:p>
           <a:p>
@@ -3864,7 +3875,15 @@
               <a:defRPr sz="1800"/>
             </a:pPr>
             <a:r>
-              <a:t>Sound bite: They help the agent remember. We help the org stop bleeding tokens.</a:t>
+              <a:t>Usage metrics = file/demo import — not live vendor billing APIs.</a:t>
+            </a:r>
+          </a:p>
+          <a:p>
+            <a:pPr>
+              <a:defRPr sz="1800"/>
+            </a:pPr>
+            <a:r>
+              <a:t>Pitch Chat/Agent metering — not unlimited completions.</a:t>
             </a:r>
           </a:p>
         </p:txBody>
@@ -3903,7 +3922,7 @@
           <a:lstStyle/>
           <a:p>
             <a:r>
-              <a:t>Not Auto Memory</a:t>
+              <a:t>Roadmap</a:t>
             </a:r>
           </a:p>
         </p:txBody>
@@ -3927,7 +3946,7 @@
               <a:defRPr sz="2000"/>
             </a:pPr>
             <a:r>
-              <a:t>Auto Memory: enriches continuity for one agent</a:t>
+              <a:t>Shipped (demo): per-team Prove, usage import, org-pack,</a:t>
             </a:r>
           </a:p>
           <a:p>
@@ -3935,7 +3954,7 @@
               <a:defRPr sz="1800"/>
             </a:pPr>
             <a:r>
-              <a:t>TokenForge: cuts billable waste for the enterprise</a:t>
+              <a:t>  Cursor/Claude adapters, compaction/routing advisories</a:t>
             </a:r>
           </a:p>
           <a:p>
@@ -3943,7 +3962,23 @@
               <a:defRPr sz="1800"/>
             </a:pPr>
             <a:r>
-              <a:t>Metric: tokens avoided / AI credits / $ — not memory quality</a:t>
+              <a:t>Next (true org scale): live billing sync per provider;</a:t>
+            </a:r>
+          </a:p>
+          <a:p>
+            <a:pPr>
+              <a:defRPr sz="1800"/>
+            </a:pPr>
+            <a:r>
+              <a:t>  remote org exclusion apply APIs</a:t>
+            </a:r>
+          </a:p>
+          <a:p>
+            <a:pPr>
+              <a:defRPr sz="1800"/>
+            </a:pPr>
+            <a:r>
+              <a:t>Do not lead pitch: chat compaction · model routing as products</a:t>
             </a:r>
           </a:p>
         </p:txBody>

</xml_diff>

<commit_message>
fix(pitch): repair deck layout and reframe as hackathon pitch
Reserve title bands on cards to stop text overlap, and drop C-level /
board-audience copy so the deck reads as a hackathon pitch.

Co-authored-by: Cursor <cursoragent@cursor.com>
</commit_message>
<xml_diff>
--- a/docs/pitch/TokenForge-Pitch.pptx
+++ b/docs/pitch/TokenForge-Pitch.pptx
@@ -3191,8 +3191,8 @@
         </p:nvSpPr>
         <p:spPr>
           <a:xfrm>
-            <a:off x="164592" y="5394960"/>
-            <a:ext cx="12027103" cy="1463040"/>
+            <a:off x="164592" y="5440680"/>
+            <a:ext cx="12027103" cy="1417320"/>
           </a:xfrm>
           <a:prstGeom prst="rect">
             <a:avLst/>
@@ -3234,8 +3234,8 @@
         </p:nvSpPr>
         <p:spPr>
           <a:xfrm>
-            <a:off x="640080" y="1463040"/>
-            <a:ext cx="10058400" cy="365760"/>
+            <a:off x="640080" y="1554480"/>
+            <a:ext cx="10058400" cy="320040"/>
           </a:xfrm>
           <a:prstGeom prst="rect">
             <a:avLst/>
@@ -3265,7 +3265,7 @@
                 <a:ea typeface="Calibri"/>
                 <a:cs typeface="Calibri"/>
               </a:rPr>
-              <a:t>BOARD BRIEF</a:t>
+              <a:t>HACKATHON PITCH</a:t>
             </a:r>
           </a:p>
         </p:txBody>
@@ -3278,8 +3278,8 @@
         </p:nvSpPr>
         <p:spPr>
           <a:xfrm>
-            <a:off x="640080" y="1920240"/>
-            <a:ext cx="10515600" cy="1005840"/>
+            <a:off x="640080" y="1965960"/>
+            <a:ext cx="10515600" cy="868680"/>
           </a:xfrm>
           <a:prstGeom prst="rect">
             <a:avLst/>
@@ -3301,7 +3301,7 @@
               </a:spcAft>
             </a:pPr>
             <a:r>
-              <a:rPr sz="6000" b="1">
+              <a:rPr sz="5600" b="1">
                 <a:solidFill>
                   <a:srgbClr val="FFFFFF"/>
                 </a:solidFill>
@@ -3322,8 +3322,8 @@
         </p:nvSpPr>
         <p:spPr>
           <a:xfrm>
-            <a:off x="640080" y="3017520"/>
-            <a:ext cx="10058400" cy="1097280"/>
+            <a:off x="640080" y="2971800"/>
+            <a:ext cx="10515600" cy="1188720"/>
           </a:xfrm>
           <a:prstGeom prst="rect">
             <a:avLst/>
@@ -3341,11 +3341,11 @@
                 <a:spcPts val="0"/>
               </a:spcBef>
               <a:spcAft>
-                <a:spcPts val="800"/>
+                <a:spcPts val="1000"/>
               </a:spcAft>
             </a:pPr>
             <a:r>
-              <a:rPr sz="2800" b="1">
+              <a:rPr sz="2600" b="1">
                 <a:solidFill>
                   <a:srgbClr val="FFFFFF"/>
                 </a:solidFill>
@@ -3366,7 +3366,7 @@
               </a:spcAft>
             </a:pPr>
             <a:r>
-              <a:rPr sz="1800" b="0">
+              <a:rPr sz="1700" b="0">
                 <a:solidFill>
                   <a:srgbClr val="C5D0D8"/>
                 </a:solidFill>
@@ -3388,7 +3388,7 @@
         <p:spPr>
           <a:xfrm>
             <a:off x="640080" y="5715000"/>
-            <a:ext cx="10972800" cy="731520"/>
+            <a:ext cx="10972800" cy="777240"/>
           </a:xfrm>
           <a:prstGeom prst="rect">
             <a:avLst/>
@@ -3406,7 +3406,7 @@
                 <a:spcPts val="0"/>
               </a:spcBef>
               <a:spcAft>
-                <a:spcPts val="400"/>
+                <a:spcPts val="600"/>
               </a:spcAft>
             </a:pPr>
             <a:r>
@@ -3418,7 +3418,7 @@
                 <a:ea typeface="Calibri"/>
                 <a:cs typeface="Calibri"/>
               </a:rPr>
-              <a:t>For CEO · CTO · Presidents · Global Directors</a:t>
+              <a:t>Detect → Fix → Prove for metered AI coding agents</a:t>
             </a:r>
           </a:p>
           <a:p>
@@ -3439,7 +3439,7 @@
                 <a:ea typeface="Calibri"/>
                 <a:cs typeface="Calibri"/>
               </a:rPr>
-              <a:t>Category ownership: stop bleeding tokens on metered coding agents</a:t>
+              <a:t>Stop bleeding tokens on low-value context</a:t>
             </a:r>
           </a:p>
         </p:txBody>
@@ -3556,8 +3556,8 @@
         </p:nvSpPr>
         <p:spPr>
           <a:xfrm>
-            <a:off x="640080" y="1371600"/>
-            <a:ext cx="10058400" cy="365760"/>
+            <a:off x="640080" y="1554480"/>
+            <a:ext cx="10058400" cy="320040"/>
           </a:xfrm>
           <a:prstGeom prst="rect">
             <a:avLst/>
@@ -3587,7 +3587,7 @@
                 <a:ea typeface="Calibri"/>
                 <a:cs typeface="Calibri"/>
               </a:rPr>
-              <a:t>THE ASK</a:t>
+              <a:t>TAKEAWAY</a:t>
             </a:r>
           </a:p>
         </p:txBody>
@@ -3600,8 +3600,8 @@
         </p:nvSpPr>
         <p:spPr>
           <a:xfrm>
-            <a:off x="640080" y="1828800"/>
-            <a:ext cx="10972800" cy="1097280"/>
+            <a:off x="640080" y="2011680"/>
+            <a:ext cx="10972800" cy="1371600"/>
           </a:xfrm>
           <a:prstGeom prst="rect">
             <a:avLst/>
@@ -3619,11 +3619,11 @@
                 <a:spcPts val="0"/>
               </a:spcBef>
               <a:spcAft>
-                <a:spcPts val="1200"/>
+                <a:spcPts val="1400"/>
               </a:spcAft>
             </a:pPr>
             <a:r>
-              <a:rPr sz="3600" b="1">
+              <a:rPr sz="3200" b="1">
                 <a:solidFill>
                   <a:srgbClr val="FFFFFF"/>
                 </a:solidFill>
@@ -3631,7 +3631,7 @@
                 <a:ea typeface="Calibri"/>
                 <a:cs typeface="Calibri"/>
               </a:rPr>
-              <a:t>Own the category: AI Coding FinOps.</a:t>
+              <a:t>AI Coding FinOps — Detect → Fix → Prove.</a:t>
             </a:r>
           </a:p>
           <a:p>
@@ -3644,7 +3644,7 @@
               </a:spcAft>
             </a:pPr>
             <a:r>
-              <a:rPr sz="2200" b="0">
+              <a:rPr sz="1800" b="0">
                 <a:solidFill>
                   <a:srgbClr val="C5D0D8"/>
                 </a:solidFill>
@@ -3652,7 +3652,7 @@
                 <a:ea typeface="Calibri"/>
                 <a:cs typeface="Calibri"/>
               </a:rPr>
-              <a:t>Next proof: pilot on one business unit.</a:t>
+              <a:t>FinOps for AI coding context waste — works across agents, not one brand.</a:t>
             </a:r>
           </a:p>
         </p:txBody>
@@ -3665,8 +3665,8 @@
         </p:nvSpPr>
         <p:spPr>
           <a:xfrm>
-            <a:off x="640080" y="4023360"/>
-            <a:ext cx="10972800" cy="1280160"/>
+            <a:off x="640080" y="3931920"/>
+            <a:ext cx="10972800" cy="1371600"/>
           </a:xfrm>
           <a:prstGeom prst="rect">
             <a:avLst/>
@@ -3684,11 +3684,11 @@
                 <a:spcPts val="0"/>
               </a:spcBef>
               <a:spcAft>
-                <a:spcPts val="800"/>
+                <a:spcPts val="1000"/>
               </a:spcAft>
             </a:pPr>
             <a:r>
-              <a:rPr sz="2600" b="0">
+              <a:rPr sz="2400" b="0">
                 <a:solidFill>
                   <a:srgbClr val="B7E0DC"/>
                 </a:solidFill>
@@ -3709,7 +3709,7 @@
               </a:spcAft>
             </a:pPr>
             <a:r>
-              <a:rPr sz="2600" b="1">
+              <a:rPr sz="2400" b="1">
                 <a:solidFill>
                   <a:srgbClr val="FFFFFF"/>
                 </a:solidFill>
@@ -3730,8 +3730,8 @@
         </p:nvSpPr>
         <p:spPr>
           <a:xfrm>
-            <a:off x="640080" y="6035040"/>
-            <a:ext cx="10972800" cy="365760"/>
+            <a:off x="640080" y="5943600"/>
+            <a:ext cx="10972800" cy="320040"/>
           </a:xfrm>
           <a:prstGeom prst="rect">
             <a:avLst/>
@@ -3761,7 +3761,7 @@
                 <a:ea typeface="Calibri"/>
                 <a:cs typeface="Calibri"/>
               </a:rPr>
-              <a:t>TokenForge  ·  Detect → Fix → Prove</a:t>
+              <a:t>TokenForge  ·  Hackathon pitch</a:t>
             </a:r>
           </a:p>
         </p:txBody>
@@ -3878,8 +3878,8 @@
         </p:nvSpPr>
         <p:spPr>
           <a:xfrm>
-            <a:off x="640080" y="502920"/>
-            <a:ext cx="10972800" cy="320040"/>
+            <a:off x="640080" y="457200"/>
+            <a:ext cx="10972800" cy="274320"/>
           </a:xfrm>
           <a:prstGeom prst="rect">
             <a:avLst/>
@@ -3922,8 +3922,8 @@
         </p:nvSpPr>
         <p:spPr>
           <a:xfrm>
-            <a:off x="640080" y="822960"/>
-            <a:ext cx="10972800" cy="640080"/>
+            <a:off x="640080" y="777240"/>
+            <a:ext cx="10972800" cy="594360"/>
           </a:xfrm>
           <a:prstGeom prst="rect">
             <a:avLst/>
@@ -3945,7 +3945,7 @@
               </a:spcAft>
             </a:pPr>
             <a:r>
-              <a:rPr sz="3600" b="1">
+              <a:rPr sz="3000" b="1">
                 <a:solidFill>
                   <a:srgbClr val="141C24"/>
                 </a:solidFill>
@@ -3953,7 +3953,7 @@
                 <a:ea typeface="Calibri"/>
                 <a:cs typeface="Calibri"/>
               </a:rPr>
-              <a:t>Enterprises buy AI coding credits — then burn them on waste.</a:t>
+              <a:t>Teams buy AI coding credits — then burn them on waste.</a:t>
             </a:r>
           </a:p>
         </p:txBody>
@@ -3966,8 +3966,8 @@
         </p:nvSpPr>
         <p:spPr>
           <a:xfrm>
-            <a:off x="640080" y="1554480"/>
-            <a:ext cx="10972800" cy="548640"/>
+            <a:off x="640080" y="1463040"/>
+            <a:ext cx="10972800" cy="457200"/>
           </a:xfrm>
           <a:prstGeom prst="rect">
             <a:avLst/>
@@ -3989,7 +3989,7 @@
               </a:spcAft>
             </a:pPr>
             <a:r>
-              <a:rPr sz="1800" b="0">
+              <a:rPr sz="1600" b="0">
                 <a:solidFill>
                   <a:srgbClr val="4A5766"/>
                 </a:solidFill>
@@ -3997,7 +3997,7 @@
                 <a:ea typeface="Calibri"/>
                 <a:cs typeface="Calibri"/>
               </a:rPr>
-              <a:t>Low-value context inflates Chat/Agent workflows. Managers lack a loop to see → fix → prove savings.</a:t>
+              <a:t>Low-value context inflates Chat/Agent workflows. There’s no clear loop to see → fix → prove savings.</a:t>
             </a:r>
           </a:p>
         </p:txBody>
@@ -4010,8 +4010,8 @@
         </p:nvSpPr>
         <p:spPr>
           <a:xfrm>
-            <a:off x="640080" y="2331720"/>
-            <a:ext cx="2606040" cy="2377440"/>
+            <a:off x="640080" y="2103120"/>
+            <a:ext cx="2606040" cy="2606040"/>
           </a:xfrm>
           <a:prstGeom prst="rect">
             <a:avLst/>
@@ -4053,8 +4053,8 @@
         </p:nvSpPr>
         <p:spPr>
           <a:xfrm>
-            <a:off x="640080" y="2331720"/>
-            <a:ext cx="73152" cy="2377440"/>
+            <a:off x="640080" y="2103120"/>
+            <a:ext cx="73152" cy="2606040"/>
           </a:xfrm>
           <a:prstGeom prst="rect">
             <a:avLst/>
@@ -4096,8 +4096,8 @@
         </p:nvSpPr>
         <p:spPr>
           <a:xfrm>
-            <a:off x="640080" y="2331720"/>
-            <a:ext cx="2606040" cy="2377440"/>
+            <a:off x="640080" y="2103120"/>
+            <a:ext cx="2606040" cy="2606040"/>
           </a:xfrm>
           <a:prstGeom prst="rect">
             <a:avLst/>
@@ -4139,8 +4139,8 @@
         </p:nvSpPr>
         <p:spPr>
           <a:xfrm>
-            <a:off x="896112" y="2532888"/>
-            <a:ext cx="2240280" cy="365760"/>
+            <a:off x="841248" y="2267712"/>
+            <a:ext cx="2203704" cy="502920"/>
           </a:xfrm>
           <a:prstGeom prst="rect">
             <a:avLst/>
@@ -4148,9 +4148,7 @@
           <a:noFill/>
         </p:spPr>
         <p:txBody>
-          <a:bodyPr wrap="square">
-            <a:spAutoFit/>
-          </a:bodyPr>
+          <a:bodyPr wrap="square"/>
           <a:lstStyle/>
           <a:p>
             <a:pPr algn="l">
@@ -4162,7 +4160,7 @@
               </a:spcAft>
             </a:pPr>
             <a:r>
-              <a:rPr sz="1600" b="1">
+              <a:rPr sz="1500" b="1">
                 <a:solidFill>
                   <a:srgbClr val="141C24"/>
                 </a:solidFill>
@@ -4183,8 +4181,8 @@
         </p:nvSpPr>
         <p:spPr>
           <a:xfrm>
-            <a:off x="896112" y="2926080"/>
-            <a:ext cx="2240280" cy="1600200"/>
+            <a:off x="841248" y="2843784"/>
+            <a:ext cx="2203704" cy="1719072"/>
           </a:xfrm>
           <a:prstGeom prst="rect">
             <a:avLst/>
@@ -4202,11 +4200,11 @@
                 <a:spcPts val="0"/>
               </a:spcBef>
               <a:spcAft>
-                <a:spcPts val="0"/>
+                <a:spcPts val="400"/>
               </a:spcAft>
             </a:pPr>
             <a:r>
-              <a:rPr sz="1400" b="0">
+              <a:rPr sz="1300" b="0">
                 <a:solidFill>
                   <a:srgbClr val="4A5766"/>
                 </a:solidFill>
@@ -4214,7 +4212,7 @@
                 <a:ea typeface="Calibri"/>
                 <a:cs typeface="Calibri"/>
               </a:rPr>
-              <a:t>Open lockfiles, bundles, and stale editors ride into every Agent turn.</a:t>
+              <a:t>Lockfiles, bundles, and stale editors ride into every Agent turn.</a:t>
             </a:r>
           </a:p>
         </p:txBody>
@@ -4227,8 +4225,8 @@
         </p:nvSpPr>
         <p:spPr>
           <a:xfrm>
-            <a:off x="3447288" y="2331720"/>
-            <a:ext cx="2606040" cy="2377440"/>
+            <a:off x="3447288" y="2103120"/>
+            <a:ext cx="2606040" cy="2606040"/>
           </a:xfrm>
           <a:prstGeom prst="rect">
             <a:avLst/>
@@ -4270,8 +4268,8 @@
         </p:nvSpPr>
         <p:spPr>
           <a:xfrm>
-            <a:off x="3447288" y="2331720"/>
-            <a:ext cx="73152" cy="2377440"/>
+            <a:off x="3447288" y="2103120"/>
+            <a:ext cx="73152" cy="2606040"/>
           </a:xfrm>
           <a:prstGeom prst="rect">
             <a:avLst/>
@@ -4313,8 +4311,8 @@
         </p:nvSpPr>
         <p:spPr>
           <a:xfrm>
-            <a:off x="3447288" y="2331720"/>
-            <a:ext cx="2606040" cy="2377440"/>
+            <a:off x="3447288" y="2103120"/>
+            <a:ext cx="2606040" cy="2606040"/>
           </a:xfrm>
           <a:prstGeom prst="rect">
             <a:avLst/>
@@ -4356,8 +4354,8 @@
         </p:nvSpPr>
         <p:spPr>
           <a:xfrm>
-            <a:off x="3703320" y="2532888"/>
-            <a:ext cx="2240280" cy="365760"/>
+            <a:off x="3648456" y="2267712"/>
+            <a:ext cx="2203704" cy="502920"/>
           </a:xfrm>
           <a:prstGeom prst="rect">
             <a:avLst/>
@@ -4365,9 +4363,7 @@
           <a:noFill/>
         </p:spPr>
         <p:txBody>
-          <a:bodyPr wrap="square">
-            <a:spAutoFit/>
-          </a:bodyPr>
+          <a:bodyPr wrap="square"/>
           <a:lstStyle/>
           <a:p>
             <a:pPr algn="l">
@@ -4379,7 +4375,7 @@
               </a:spcAft>
             </a:pPr>
             <a:r>
-              <a:rPr sz="1600" b="1">
+              <a:rPr sz="1500" b="1">
                 <a:solidFill>
                   <a:srgbClr val="141C24"/>
                 </a:solidFill>
@@ -4400,8 +4396,8 @@
         </p:nvSpPr>
         <p:spPr>
           <a:xfrm>
-            <a:off x="3703320" y="2926080"/>
-            <a:ext cx="2240280" cy="1600200"/>
+            <a:off x="3648456" y="2843784"/>
+            <a:ext cx="2203704" cy="1719072"/>
           </a:xfrm>
           <a:prstGeom prst="rect">
             <a:avLst/>
@@ -4419,11 +4415,11 @@
                 <a:spcPts val="0"/>
               </a:spcBef>
               <a:spcAft>
-                <a:spcPts val="0"/>
+                <a:spcPts val="400"/>
               </a:spcAft>
             </a:pPr>
             <a:r>
-              <a:rPr sz="1400" b="0">
+              <a:rPr sz="1300" b="0">
                 <a:solidFill>
                   <a:srgbClr val="4A5766"/>
                 </a:solidFill>
@@ -4444,8 +4440,8 @@
         </p:nvSpPr>
         <p:spPr>
           <a:xfrm>
-            <a:off x="6254496" y="2331720"/>
-            <a:ext cx="2606040" cy="2377440"/>
+            <a:off x="6254496" y="2103120"/>
+            <a:ext cx="2606040" cy="2606040"/>
           </a:xfrm>
           <a:prstGeom prst="rect">
             <a:avLst/>
@@ -4487,8 +4483,8 @@
         </p:nvSpPr>
         <p:spPr>
           <a:xfrm>
-            <a:off x="6254496" y="2331720"/>
-            <a:ext cx="73152" cy="2377440"/>
+            <a:off x="6254496" y="2103120"/>
+            <a:ext cx="73152" cy="2606040"/>
           </a:xfrm>
           <a:prstGeom prst="rect">
             <a:avLst/>
@@ -4530,8 +4526,8 @@
         </p:nvSpPr>
         <p:spPr>
           <a:xfrm>
-            <a:off x="6254496" y="2331720"/>
-            <a:ext cx="2606040" cy="2377440"/>
+            <a:off x="6254496" y="2103120"/>
+            <a:ext cx="2606040" cy="2606040"/>
           </a:xfrm>
           <a:prstGeom prst="rect">
             <a:avLst/>
@@ -4573,8 +4569,8 @@
         </p:nvSpPr>
         <p:spPr>
           <a:xfrm>
-            <a:off x="6510528" y="2532888"/>
-            <a:ext cx="2240280" cy="365760"/>
+            <a:off x="6455664" y="2267712"/>
+            <a:ext cx="2203704" cy="502920"/>
           </a:xfrm>
           <a:prstGeom prst="rect">
             <a:avLst/>
@@ -4582,9 +4578,7 @@
           <a:noFill/>
         </p:spPr>
         <p:txBody>
-          <a:bodyPr wrap="square">
-            <a:spAutoFit/>
-          </a:bodyPr>
+          <a:bodyPr wrap="square"/>
           <a:lstStyle/>
           <a:p>
             <a:pPr algn="l">
@@ -4596,7 +4590,7 @@
               </a:spcAft>
             </a:pPr>
             <a:r>
-              <a:rPr sz="1600" b="1">
+              <a:rPr sz="1500" b="1">
                 <a:solidFill>
                   <a:srgbClr val="141C24"/>
                 </a:solidFill>
@@ -4617,8 +4611,8 @@
         </p:nvSpPr>
         <p:spPr>
           <a:xfrm>
-            <a:off x="6510528" y="2926080"/>
-            <a:ext cx="2240280" cy="1600200"/>
+            <a:off x="6455664" y="2843784"/>
+            <a:ext cx="2203704" cy="1719072"/>
           </a:xfrm>
           <a:prstGeom prst="rect">
             <a:avLst/>
@@ -4636,11 +4630,11 @@
                 <a:spcPts val="0"/>
               </a:spcBef>
               <a:spcAft>
-                <a:spcPts val="0"/>
+                <a:spcPts val="400"/>
               </a:spcAft>
             </a:pPr>
             <a:r>
-              <a:rPr sz="1400" b="0">
+              <a:rPr sz="1300" b="0">
                 <a:solidFill>
                   <a:srgbClr val="4A5766"/>
                 </a:solidFill>
@@ -4661,8 +4655,8 @@
         </p:nvSpPr>
         <p:spPr>
           <a:xfrm>
-            <a:off x="9061704" y="2331720"/>
-            <a:ext cx="2606040" cy="2377440"/>
+            <a:off x="9061704" y="2103120"/>
+            <a:ext cx="2606040" cy="2606040"/>
           </a:xfrm>
           <a:prstGeom prst="rect">
             <a:avLst/>
@@ -4704,8 +4698,8 @@
         </p:nvSpPr>
         <p:spPr>
           <a:xfrm>
-            <a:off x="9061704" y="2331720"/>
-            <a:ext cx="73152" cy="2377440"/>
+            <a:off x="9061704" y="2103120"/>
+            <a:ext cx="73152" cy="2606040"/>
           </a:xfrm>
           <a:prstGeom prst="rect">
             <a:avLst/>
@@ -4747,8 +4741,8 @@
         </p:nvSpPr>
         <p:spPr>
           <a:xfrm>
-            <a:off x="9061704" y="2331720"/>
-            <a:ext cx="2606040" cy="2377440"/>
+            <a:off x="9061704" y="2103120"/>
+            <a:ext cx="2606040" cy="2606040"/>
           </a:xfrm>
           <a:prstGeom prst="rect">
             <a:avLst/>
@@ -4790,8 +4784,8 @@
         </p:nvSpPr>
         <p:spPr>
           <a:xfrm>
-            <a:off x="9317736" y="2532888"/>
-            <a:ext cx="2240280" cy="365760"/>
+            <a:off x="9262872" y="2267712"/>
+            <a:ext cx="2203704" cy="502920"/>
           </a:xfrm>
           <a:prstGeom prst="rect">
             <a:avLst/>
@@ -4799,9 +4793,7 @@
           <a:noFill/>
         </p:spPr>
         <p:txBody>
-          <a:bodyPr wrap="square">
-            <a:spAutoFit/>
-          </a:bodyPr>
+          <a:bodyPr wrap="square"/>
           <a:lstStyle/>
           <a:p>
             <a:pPr algn="l">
@@ -4813,7 +4805,7 @@
               </a:spcAft>
             </a:pPr>
             <a:r>
-              <a:rPr sz="1600" b="1">
+              <a:rPr sz="1500" b="1">
                 <a:solidFill>
                   <a:srgbClr val="141C24"/>
                 </a:solidFill>
@@ -4821,7 +4813,7 @@
                 <a:ea typeface="Calibri"/>
                 <a:cs typeface="Calibri"/>
               </a:rPr>
-              <a:t>No buyer proof</a:t>
+              <a:t>No savings proof</a:t>
             </a:r>
           </a:p>
         </p:txBody>
@@ -4834,8 +4826,8 @@
         </p:nvSpPr>
         <p:spPr>
           <a:xfrm>
-            <a:off x="9317736" y="2926080"/>
-            <a:ext cx="2240280" cy="1600200"/>
+            <a:off x="9262872" y="2843784"/>
+            <a:ext cx="2203704" cy="1719072"/>
           </a:xfrm>
           <a:prstGeom prst="rect">
             <a:avLst/>
@@ -4853,11 +4845,11 @@
                 <a:spcPts val="0"/>
               </a:spcBef>
               <a:spcAft>
-                <a:spcPts val="0"/>
+                <a:spcPts val="400"/>
               </a:spcAft>
             </a:pPr>
             <a:r>
-              <a:rPr sz="1400" b="0">
+              <a:rPr sz="1300" b="0">
                 <a:solidFill>
                   <a:srgbClr val="4A5766"/>
                 </a:solidFill>
@@ -4865,7 +4857,7 @@
                 <a:ea typeface="Calibri"/>
                 <a:cs typeface="Calibri"/>
               </a:rPr>
-              <a:t>Spend shows up on invoices — waste does not show up as a finding.</a:t>
+              <a:t>Spend shows on invoices — waste never shows as a finding.</a:t>
             </a:r>
           </a:p>
         </p:txBody>
@@ -4878,8 +4870,8 @@
         </p:nvSpPr>
         <p:spPr>
           <a:xfrm>
-            <a:off x="640080" y="6446520"/>
-            <a:ext cx="9144000" cy="274320"/>
+            <a:off x="640080" y="6492240"/>
+            <a:ext cx="10972800" cy="256032"/>
           </a:xfrm>
           <a:prstGeom prst="rect">
             <a:avLst/>
@@ -4909,7 +4901,7 @@
                 <a:ea typeface="Calibri"/>
                 <a:cs typeface="Calibri"/>
               </a:rPr>
-              <a:t>TokenForge  ·  AI Coding FinOps  ·  Confidential board brief  ·  2 / 10</a:t>
+              <a:t>TokenForge  ·  AI Coding FinOps  ·  Hackathon pitch  ·  2 / 10</a:t>
             </a:r>
           </a:p>
         </p:txBody>
@@ -5026,8 +5018,8 @@
         </p:nvSpPr>
         <p:spPr>
           <a:xfrm>
-            <a:off x="640080" y="502920"/>
-            <a:ext cx="10972800" cy="320040"/>
+            <a:off x="640080" y="457200"/>
+            <a:ext cx="10972800" cy="274320"/>
           </a:xfrm>
           <a:prstGeom prst="rect">
             <a:avLst/>
@@ -5070,7 +5062,7 @@
         </p:nvSpPr>
         <p:spPr>
           <a:xfrm>
-            <a:off x="640080" y="822960"/>
+            <a:off x="640080" y="777240"/>
             <a:ext cx="10972800" cy="640080"/>
           </a:xfrm>
           <a:prstGeom prst="rect">
@@ -5093,7 +5085,7 @@
               </a:spcAft>
             </a:pPr>
             <a:r>
-              <a:rPr sz="3600" b="1">
+              <a:rPr sz="2800" b="1">
                 <a:solidFill>
                   <a:srgbClr val="141C24"/>
                 </a:solidFill>
@@ -5114,8 +5106,8 @@
         </p:nvSpPr>
         <p:spPr>
           <a:xfrm>
-            <a:off x="640080" y="1691640"/>
-            <a:ext cx="10789920" cy="438912"/>
+            <a:off x="640080" y="1645920"/>
+            <a:ext cx="10789920" cy="411480"/>
           </a:xfrm>
           <a:prstGeom prst="rect">
             <a:avLst/>
@@ -5157,8 +5149,8 @@
         </p:nvSpPr>
         <p:spPr>
           <a:xfrm>
-            <a:off x="777240" y="1764792"/>
-            <a:ext cx="2377440" cy="320040"/>
+            <a:off x="777240" y="1719072"/>
+            <a:ext cx="2331720" cy="292608"/>
           </a:xfrm>
           <a:prstGeom prst="rect">
             <a:avLst/>
@@ -5180,7 +5172,7 @@
               </a:spcAft>
             </a:pPr>
             <a:r>
-              <a:rPr sz="1400" b="1">
+              <a:rPr sz="1300" b="1">
                 <a:solidFill>
                   <a:srgbClr val="FFFFFF"/>
                 </a:solidFill>
@@ -5201,8 +5193,8 @@
         </p:nvSpPr>
         <p:spPr>
           <a:xfrm>
-            <a:off x="3337560" y="1764792"/>
-            <a:ext cx="3657600" cy="320040"/>
+            <a:off x="3337560" y="1719072"/>
+            <a:ext cx="3611880" cy="292608"/>
           </a:xfrm>
           <a:prstGeom prst="rect">
             <a:avLst/>
@@ -5224,7 +5216,7 @@
               </a:spcAft>
             </a:pPr>
             <a:r>
-              <a:rPr sz="1400" b="1">
+              <a:rPr sz="1300" b="1">
                 <a:solidFill>
                   <a:srgbClr val="FFFFFF"/>
                 </a:solidFill>
@@ -5245,8 +5237,8 @@
         </p:nvSpPr>
         <p:spPr>
           <a:xfrm>
-            <a:off x="7178040" y="1764792"/>
-            <a:ext cx="4206240" cy="320040"/>
+            <a:off x="7178040" y="1719072"/>
+            <a:ext cx="4160520" cy="292608"/>
           </a:xfrm>
           <a:prstGeom prst="rect">
             <a:avLst/>
@@ -5268,7 +5260,7 @@
               </a:spcAft>
             </a:pPr>
             <a:r>
-              <a:rPr sz="1400" b="1">
+              <a:rPr sz="1300" b="1">
                 <a:solidFill>
                   <a:srgbClr val="FFFFFF"/>
                 </a:solidFill>
@@ -5289,8 +5281,8 @@
         </p:nvSpPr>
         <p:spPr>
           <a:xfrm>
-            <a:off x="640080" y="2130552"/>
-            <a:ext cx="10789920" cy="777240"/>
+            <a:off x="640080" y="2057400"/>
+            <a:ext cx="10789920" cy="713232"/>
           </a:xfrm>
           <a:prstGeom prst="rect">
             <a:avLst/>
@@ -5332,8 +5324,8 @@
         </p:nvSpPr>
         <p:spPr>
           <a:xfrm>
-            <a:off x="777240" y="2331720"/>
-            <a:ext cx="2331720" cy="457200"/>
+            <a:off x="777240" y="2258568"/>
+            <a:ext cx="2331720" cy="365760"/>
           </a:xfrm>
           <a:prstGeom prst="rect">
             <a:avLst/>
@@ -5355,7 +5347,7 @@
               </a:spcAft>
             </a:pPr>
             <a:r>
-              <a:rPr sz="1500" b="1">
+              <a:rPr sz="1400" b="1">
                 <a:solidFill>
                   <a:srgbClr val="141C24"/>
                 </a:solidFill>
@@ -5376,8 +5368,8 @@
         </p:nvSpPr>
         <p:spPr>
           <a:xfrm>
-            <a:off x="3337560" y="2331720"/>
-            <a:ext cx="3611880" cy="457200"/>
+            <a:off x="3337560" y="2258568"/>
+            <a:ext cx="3611880" cy="365760"/>
           </a:xfrm>
           <a:prstGeom prst="rect">
             <a:avLst/>
@@ -5399,7 +5391,7 @@
               </a:spcAft>
             </a:pPr>
             <a:r>
-              <a:rPr sz="1500" b="0">
+              <a:rPr sz="1400" b="0">
                 <a:solidFill>
                   <a:srgbClr val="4A5766"/>
                 </a:solidFill>
@@ -5420,8 +5412,8 @@
         </p:nvSpPr>
         <p:spPr>
           <a:xfrm>
-            <a:off x="7178040" y="2331720"/>
-            <a:ext cx="4160520" cy="457200"/>
+            <a:off x="7178040" y="2258568"/>
+            <a:ext cx="4160520" cy="365760"/>
           </a:xfrm>
           <a:prstGeom prst="rect">
             <a:avLst/>
@@ -5443,7 +5435,7 @@
               </a:spcAft>
             </a:pPr>
             <a:r>
-              <a:rPr sz="1500" b="0">
+              <a:rPr sz="1400" b="0">
                 <a:solidFill>
                   <a:srgbClr val="4A5766"/>
                 </a:solidFill>
@@ -5464,8 +5456,8 @@
         </p:nvSpPr>
         <p:spPr>
           <a:xfrm>
-            <a:off x="640080" y="2907792"/>
-            <a:ext cx="10789920" cy="777240"/>
+            <a:off x="640080" y="2770632"/>
+            <a:ext cx="10789920" cy="713232"/>
           </a:xfrm>
           <a:prstGeom prst="rect">
             <a:avLst/>
@@ -5507,8 +5499,8 @@
         </p:nvSpPr>
         <p:spPr>
           <a:xfrm>
-            <a:off x="777240" y="3108960"/>
-            <a:ext cx="2331720" cy="457200"/>
+            <a:off x="777240" y="2971800"/>
+            <a:ext cx="2331720" cy="365760"/>
           </a:xfrm>
           <a:prstGeom prst="rect">
             <a:avLst/>
@@ -5530,7 +5522,7 @@
               </a:spcAft>
             </a:pPr>
             <a:r>
-              <a:rPr sz="1500" b="1">
+              <a:rPr sz="1400" b="1">
                 <a:solidFill>
                   <a:srgbClr val="141C24"/>
                 </a:solidFill>
@@ -5551,8 +5543,8 @@
         </p:nvSpPr>
         <p:spPr>
           <a:xfrm>
-            <a:off x="3337560" y="3108960"/>
-            <a:ext cx="3611880" cy="457200"/>
+            <a:off x="3337560" y="2971800"/>
+            <a:ext cx="3611880" cy="365760"/>
           </a:xfrm>
           <a:prstGeom prst="rect">
             <a:avLst/>
@@ -5574,7 +5566,7 @@
               </a:spcAft>
             </a:pPr>
             <a:r>
-              <a:rPr sz="1500" b="0">
+              <a:rPr sz="1400" b="0">
                 <a:solidFill>
                   <a:srgbClr val="4A5766"/>
                 </a:solidFill>
@@ -5595,8 +5587,8 @@
         </p:nvSpPr>
         <p:spPr>
           <a:xfrm>
-            <a:off x="7178040" y="3108960"/>
-            <a:ext cx="4160520" cy="457200"/>
+            <a:off x="7178040" y="2971800"/>
+            <a:ext cx="4160520" cy="365760"/>
           </a:xfrm>
           <a:prstGeom prst="rect">
             <a:avLst/>
@@ -5618,7 +5610,7 @@
               </a:spcAft>
             </a:pPr>
             <a:r>
-              <a:rPr sz="1500" b="0">
+              <a:rPr sz="1400" b="0">
                 <a:solidFill>
                   <a:srgbClr val="4A5766"/>
                 </a:solidFill>
@@ -5639,8 +5631,8 @@
         </p:nvSpPr>
         <p:spPr>
           <a:xfrm>
-            <a:off x="640080" y="3685032"/>
-            <a:ext cx="10789920" cy="777240"/>
+            <a:off x="640080" y="3483864"/>
+            <a:ext cx="10789920" cy="713232"/>
           </a:xfrm>
           <a:prstGeom prst="rect">
             <a:avLst/>
@@ -5682,8 +5674,8 @@
         </p:nvSpPr>
         <p:spPr>
           <a:xfrm>
-            <a:off x="777240" y="3886200"/>
-            <a:ext cx="2331720" cy="457200"/>
+            <a:off x="777240" y="3685032"/>
+            <a:ext cx="2331720" cy="365760"/>
           </a:xfrm>
           <a:prstGeom prst="rect">
             <a:avLst/>
@@ -5705,7 +5697,7 @@
               </a:spcAft>
             </a:pPr>
             <a:r>
-              <a:rPr sz="1500" b="1">
+              <a:rPr sz="1400" b="1">
                 <a:solidFill>
                   <a:srgbClr val="141C24"/>
                 </a:solidFill>
@@ -5726,8 +5718,8 @@
         </p:nvSpPr>
         <p:spPr>
           <a:xfrm>
-            <a:off x="3337560" y="3886200"/>
-            <a:ext cx="3611880" cy="457200"/>
+            <a:off x="3337560" y="3685032"/>
+            <a:ext cx="3611880" cy="365760"/>
           </a:xfrm>
           <a:prstGeom prst="rect">
             <a:avLst/>
@@ -5749,7 +5741,7 @@
               </a:spcAft>
             </a:pPr>
             <a:r>
-              <a:rPr sz="1500" b="0">
+              <a:rPr sz="1400" b="0">
                 <a:solidFill>
                   <a:srgbClr val="4A5766"/>
                 </a:solidFill>
@@ -5770,8 +5762,8 @@
         </p:nvSpPr>
         <p:spPr>
           <a:xfrm>
-            <a:off x="7178040" y="3886200"/>
-            <a:ext cx="4160520" cy="457200"/>
+            <a:off x="7178040" y="3685032"/>
+            <a:ext cx="4160520" cy="365760"/>
           </a:xfrm>
           <a:prstGeom prst="rect">
             <a:avLst/>
@@ -5793,7 +5785,7 @@
               </a:spcAft>
             </a:pPr>
             <a:r>
-              <a:rPr sz="1500" b="0">
+              <a:rPr sz="1400" b="0">
                 <a:solidFill>
                   <a:srgbClr val="4A5766"/>
                 </a:solidFill>
@@ -5814,8 +5806,8 @@
         </p:nvSpPr>
         <p:spPr>
           <a:xfrm>
-            <a:off x="640080" y="4462272"/>
-            <a:ext cx="10789920" cy="777240"/>
+            <a:off x="640080" y="4197096"/>
+            <a:ext cx="10789920" cy="713232"/>
           </a:xfrm>
           <a:prstGeom prst="rect">
             <a:avLst/>
@@ -5857,8 +5849,8 @@
         </p:nvSpPr>
         <p:spPr>
           <a:xfrm>
-            <a:off x="777240" y="4663440"/>
-            <a:ext cx="2331720" cy="457200"/>
+            <a:off x="777240" y="4398264"/>
+            <a:ext cx="2331720" cy="365760"/>
           </a:xfrm>
           <a:prstGeom prst="rect">
             <a:avLst/>
@@ -5880,7 +5872,7 @@
               </a:spcAft>
             </a:pPr>
             <a:r>
-              <a:rPr sz="1500" b="1">
+              <a:rPr sz="1400" b="1">
                 <a:solidFill>
                   <a:srgbClr val="141C24"/>
                 </a:solidFill>
@@ -5901,8 +5893,8 @@
         </p:nvSpPr>
         <p:spPr>
           <a:xfrm>
-            <a:off x="3337560" y="4663440"/>
-            <a:ext cx="3611880" cy="457200"/>
+            <a:off x="3337560" y="4398264"/>
+            <a:ext cx="3611880" cy="365760"/>
           </a:xfrm>
           <a:prstGeom prst="rect">
             <a:avLst/>
@@ -5924,7 +5916,7 @@
               </a:spcAft>
             </a:pPr>
             <a:r>
-              <a:rPr sz="1500" b="0">
+              <a:rPr sz="1400" b="0">
                 <a:solidFill>
                   <a:srgbClr val="4A5766"/>
                 </a:solidFill>
@@ -5945,8 +5937,8 @@
         </p:nvSpPr>
         <p:spPr>
           <a:xfrm>
-            <a:off x="7178040" y="4663440"/>
-            <a:ext cx="4160520" cy="457200"/>
+            <a:off x="7178040" y="4398264"/>
+            <a:ext cx="4160520" cy="365760"/>
           </a:xfrm>
           <a:prstGeom prst="rect">
             <a:avLst/>
@@ -5968,7 +5960,7 @@
               </a:spcAft>
             </a:pPr>
             <a:r>
-              <a:rPr sz="1500" b="0">
+              <a:rPr sz="1400" b="0">
                 <a:solidFill>
                   <a:srgbClr val="4A5766"/>
                 </a:solidFill>
@@ -5989,8 +5981,8 @@
         </p:nvSpPr>
         <p:spPr>
           <a:xfrm>
-            <a:off x="640080" y="6446520"/>
-            <a:ext cx="9144000" cy="274320"/>
+            <a:off x="640080" y="6492240"/>
+            <a:ext cx="10972800" cy="256032"/>
           </a:xfrm>
           <a:prstGeom prst="rect">
             <a:avLst/>
@@ -6020,7 +6012,7 @@
                 <a:ea typeface="Calibri"/>
                 <a:cs typeface="Calibri"/>
               </a:rPr>
-              <a:t>TokenForge  ·  AI Coding FinOps  ·  Confidential board brief  ·  3 / 10</a:t>
+              <a:t>TokenForge  ·  AI Coding FinOps  ·  Hackathon pitch  ·  3 / 10</a:t>
             </a:r>
           </a:p>
         </p:txBody>
@@ -6137,8 +6129,8 @@
         </p:nvSpPr>
         <p:spPr>
           <a:xfrm>
-            <a:off x="640080" y="502920"/>
-            <a:ext cx="10972800" cy="320040"/>
+            <a:off x="640080" y="457200"/>
+            <a:ext cx="10972800" cy="274320"/>
           </a:xfrm>
           <a:prstGeom prst="rect">
             <a:avLst/>
@@ -6181,8 +6173,8 @@
         </p:nvSpPr>
         <p:spPr>
           <a:xfrm>
-            <a:off x="640080" y="822960"/>
-            <a:ext cx="10972800" cy="640080"/>
+            <a:off x="640080" y="777240"/>
+            <a:ext cx="10972800" cy="685800"/>
           </a:xfrm>
           <a:prstGeom prst="rect">
             <a:avLst/>
@@ -6204,7 +6196,7 @@
               </a:spcAft>
             </a:pPr>
             <a:r>
-              <a:rPr sz="3600" b="1">
+              <a:rPr sz="2600" b="1">
                 <a:solidFill>
                   <a:srgbClr val="141C24"/>
                 </a:solidFill>
@@ -6225,8 +6217,8 @@
         </p:nvSpPr>
         <p:spPr>
           <a:xfrm>
-            <a:off x="640080" y="1691640"/>
-            <a:ext cx="5212080" cy="3291840"/>
+            <a:off x="640080" y="1645920"/>
+            <a:ext cx="5212080" cy="3063240"/>
           </a:xfrm>
           <a:prstGeom prst="rect">
             <a:avLst/>
@@ -6268,7 +6260,7 @@
         </p:nvSpPr>
         <p:spPr>
           <a:xfrm>
-            <a:off x="640080" y="1691640"/>
+            <a:off x="640080" y="1645920"/>
             <a:ext cx="5212080" cy="502920"/>
           </a:xfrm>
           <a:prstGeom prst="rect">
@@ -6311,8 +6303,8 @@
         </p:nvSpPr>
         <p:spPr>
           <a:xfrm>
-            <a:off x="914400" y="1783080"/>
-            <a:ext cx="4663440" cy="365760"/>
+            <a:off x="896112" y="1755648"/>
+            <a:ext cx="4754880" cy="320040"/>
           </a:xfrm>
           <a:prstGeom prst="rect">
             <a:avLst/>
@@ -6334,7 +6326,7 @@
               </a:spcAft>
             </a:pPr>
             <a:r>
-              <a:rPr sz="1800" b="1">
+              <a:rPr sz="1600" b="1">
                 <a:solidFill>
                   <a:srgbClr val="FFFFFF"/>
                 </a:solidFill>
@@ -6355,8 +6347,8 @@
         </p:nvSpPr>
         <p:spPr>
           <a:xfrm>
-            <a:off x="914400" y="2377440"/>
-            <a:ext cx="4663440" cy="2377440"/>
+            <a:off x="896112" y="2377440"/>
+            <a:ext cx="4754880" cy="2194560"/>
           </a:xfrm>
           <a:prstGeom prst="rect">
             <a:avLst/>
@@ -6374,11 +6366,11 @@
                 <a:spcPts val="0"/>
               </a:spcBef>
               <a:spcAft>
-                <a:spcPts val="1000"/>
+                <a:spcPts val="1200"/>
               </a:spcAft>
             </a:pPr>
             <a:r>
-              <a:rPr sz="1600" b="0">
+              <a:rPr sz="1500" b="0">
                 <a:solidFill>
                   <a:srgbClr val="4A5766"/>
                 </a:solidFill>
@@ -6395,11 +6387,11 @@
                 <a:spcPts val="0"/>
               </a:spcBef>
               <a:spcAft>
-                <a:spcPts val="1000"/>
+                <a:spcPts val="1200"/>
               </a:spcAft>
             </a:pPr>
             <a:r>
-              <a:rPr sz="1600" b="0">
+              <a:rPr sz="1500" b="0">
                 <a:solidFill>
                   <a:srgbClr val="4A5766"/>
                 </a:solidFill>
@@ -6420,7 +6412,7 @@
               </a:spcAft>
             </a:pPr>
             <a:r>
-              <a:rPr sz="1600" b="0">
+              <a:rPr sz="1500" b="0">
                 <a:solidFill>
                   <a:srgbClr val="4A5766"/>
                 </a:solidFill>
@@ -6441,8 +6433,8 @@
         </p:nvSpPr>
         <p:spPr>
           <a:xfrm>
-            <a:off x="6309360" y="1691640"/>
-            <a:ext cx="5212080" cy="3291840"/>
+            <a:off x="6309360" y="1645920"/>
+            <a:ext cx="5212080" cy="3063240"/>
           </a:xfrm>
           <a:prstGeom prst="rect">
             <a:avLst/>
@@ -6484,7 +6476,7 @@
         </p:nvSpPr>
         <p:spPr>
           <a:xfrm>
-            <a:off x="6309360" y="1691640"/>
+            <a:off x="6309360" y="1645920"/>
             <a:ext cx="5212080" cy="502920"/>
           </a:xfrm>
           <a:prstGeom prst="rect">
@@ -6527,8 +6519,8 @@
         </p:nvSpPr>
         <p:spPr>
           <a:xfrm>
-            <a:off x="6583680" y="1783080"/>
-            <a:ext cx="4663440" cy="365760"/>
+            <a:off x="6565392" y="1755648"/>
+            <a:ext cx="4754880" cy="320040"/>
           </a:xfrm>
           <a:prstGeom prst="rect">
             <a:avLst/>
@@ -6550,7 +6542,7 @@
               </a:spcAft>
             </a:pPr>
             <a:r>
-              <a:rPr sz="1800" b="1">
+              <a:rPr sz="1600" b="1">
                 <a:solidFill>
                   <a:srgbClr val="FFFFFF"/>
                 </a:solidFill>
@@ -6571,8 +6563,8 @@
         </p:nvSpPr>
         <p:spPr>
           <a:xfrm>
-            <a:off x="6583680" y="2377440"/>
-            <a:ext cx="4663440" cy="2377440"/>
+            <a:off x="6565392" y="2377440"/>
+            <a:ext cx="4754880" cy="2194560"/>
           </a:xfrm>
           <a:prstGeom prst="rect">
             <a:avLst/>
@@ -6590,11 +6582,11 @@
                 <a:spcPts val="0"/>
               </a:spcBef>
               <a:spcAft>
-                <a:spcPts val="1000"/>
+                <a:spcPts val="1200"/>
               </a:spcAft>
             </a:pPr>
             <a:r>
-              <a:rPr sz="1600" b="1">
+              <a:rPr sz="1500" b="1">
                 <a:solidFill>
                   <a:srgbClr val="141C24"/>
                 </a:solidFill>
@@ -6611,11 +6603,11 @@
                 <a:spcPts val="0"/>
               </a:spcBef>
               <a:spcAft>
-                <a:spcPts val="1000"/>
+                <a:spcPts val="1200"/>
               </a:spcAft>
             </a:pPr>
             <a:r>
-              <a:rPr sz="1600" b="1">
+              <a:rPr sz="1500" b="1">
                 <a:solidFill>
                   <a:srgbClr val="141C24"/>
                 </a:solidFill>
@@ -6623,7 +6615,7 @@
                 <a:ea typeface="Calibri"/>
                 <a:cs typeface="Calibri"/>
               </a:rPr>
-              <a:t>Cuts billable waste for the enterprise</a:t>
+              <a:t>Cuts billable waste for the team</a:t>
             </a:r>
           </a:p>
           <a:p>
@@ -6636,7 +6628,7 @@
               </a:spcAft>
             </a:pPr>
             <a:r>
-              <a:rPr sz="1600" b="1">
+              <a:rPr sz="1500" b="1">
                 <a:solidFill>
                   <a:srgbClr val="141C24"/>
                 </a:solidFill>
@@ -6657,8 +6649,8 @@
         </p:nvSpPr>
         <p:spPr>
           <a:xfrm>
-            <a:off x="640080" y="5212080"/>
-            <a:ext cx="10972800" cy="640080"/>
+            <a:off x="640080" y="4983480"/>
+            <a:ext cx="10972800" cy="822960"/>
           </a:xfrm>
           <a:prstGeom prst="rect">
             <a:avLst/>
@@ -6680,7 +6672,7 @@
               </a:spcAft>
             </a:pPr>
             <a:r>
-              <a:rPr sz="1600" b="1">
+              <a:rPr sz="1500" b="1">
                 <a:solidFill>
                   <a:srgbClr val="084C49"/>
                 </a:solidFill>
@@ -6688,7 +6680,7 @@
                 <a:ea typeface="Calibri"/>
                 <a:cs typeface="Calibri"/>
               </a:rPr>
-              <a:t>Unique wedge: Token Risk → provider policy pack → global + per-team $ proof across architectures.</a:t>
+              <a:t>Unique wedge: Token Risk → provider policy pack → global + per-team $ proof.</a:t>
             </a:r>
           </a:p>
         </p:txBody>
@@ -6701,8 +6693,8 @@
         </p:nvSpPr>
         <p:spPr>
           <a:xfrm>
-            <a:off x="640080" y="6446520"/>
-            <a:ext cx="9144000" cy="274320"/>
+            <a:off x="640080" y="6492240"/>
+            <a:ext cx="10972800" cy="256032"/>
           </a:xfrm>
           <a:prstGeom prst="rect">
             <a:avLst/>
@@ -6732,7 +6724,7 @@
                 <a:ea typeface="Calibri"/>
                 <a:cs typeface="Calibri"/>
               </a:rPr>
-              <a:t>TokenForge  ·  AI Coding FinOps  ·  Confidential board brief  ·  4 / 10</a:t>
+              <a:t>TokenForge  ·  AI Coding FinOps  ·  Hackathon pitch  ·  4 / 10</a:t>
             </a:r>
           </a:p>
         </p:txBody>
@@ -6849,8 +6841,8 @@
         </p:nvSpPr>
         <p:spPr>
           <a:xfrm>
-            <a:off x="640080" y="502920"/>
-            <a:ext cx="10972800" cy="320040"/>
+            <a:off x="640080" y="457200"/>
+            <a:ext cx="10972800" cy="274320"/>
           </a:xfrm>
           <a:prstGeom prst="rect">
             <a:avLst/>
@@ -6893,7 +6885,7 @@
         </p:nvSpPr>
         <p:spPr>
           <a:xfrm>
-            <a:off x="640080" y="822960"/>
+            <a:off x="640080" y="777240"/>
             <a:ext cx="10972800" cy="640080"/>
           </a:xfrm>
           <a:prstGeom prst="rect">
@@ -6916,7 +6908,7 @@
               </a:spcAft>
             </a:pPr>
             <a:r>
-              <a:rPr sz="3600" b="1">
+              <a:rPr sz="3000" b="1">
                 <a:solidFill>
                   <a:srgbClr val="141C24"/>
                 </a:solidFill>
@@ -6937,8 +6929,8 @@
         </p:nvSpPr>
         <p:spPr>
           <a:xfrm>
-            <a:off x="640080" y="1737360"/>
-            <a:ext cx="3520440" cy="3108960"/>
+            <a:off x="640080" y="1691640"/>
+            <a:ext cx="3520440" cy="3291840"/>
           </a:xfrm>
           <a:prstGeom prst="rect">
             <a:avLst/>
@@ -6980,8 +6972,8 @@
         </p:nvSpPr>
         <p:spPr>
           <a:xfrm>
-            <a:off x="640080" y="1737360"/>
-            <a:ext cx="73152" cy="3108960"/>
+            <a:off x="640080" y="1691640"/>
+            <a:ext cx="73152" cy="3291840"/>
           </a:xfrm>
           <a:prstGeom prst="rect">
             <a:avLst/>
@@ -7023,8 +7015,8 @@
         </p:nvSpPr>
         <p:spPr>
           <a:xfrm>
-            <a:off x="640080" y="1737360"/>
-            <a:ext cx="3520440" cy="3108960"/>
+            <a:off x="640080" y="1691640"/>
+            <a:ext cx="3520440" cy="3291840"/>
           </a:xfrm>
           <a:prstGeom prst="rect">
             <a:avLst/>
@@ -7066,8 +7058,8 @@
         </p:nvSpPr>
         <p:spPr>
           <a:xfrm>
-            <a:off x="896112" y="1938528"/>
-            <a:ext cx="3154680" cy="365760"/>
+            <a:off x="841248" y="1856232"/>
+            <a:ext cx="3118104" cy="502920"/>
           </a:xfrm>
           <a:prstGeom prst="rect">
             <a:avLst/>
@@ -7075,9 +7067,7 @@
           <a:noFill/>
         </p:spPr>
         <p:txBody>
-          <a:bodyPr wrap="square">
-            <a:spAutoFit/>
-          </a:bodyPr>
+          <a:bodyPr wrap="square"/>
           <a:lstStyle/>
           <a:p>
             <a:pPr algn="l">
@@ -7089,7 +7079,7 @@
               </a:spcAft>
             </a:pPr>
             <a:r>
-              <a:rPr sz="1600" b="1">
+              <a:rPr sz="1400" b="1">
                 <a:solidFill>
                   <a:srgbClr val="141C24"/>
                 </a:solidFill>
@@ -7097,7 +7087,7 @@
                 <a:ea typeface="Calibri"/>
                 <a:cs typeface="Calibri"/>
               </a:rPr>
-              <a:t>Buyer  ·  Eng Manager / FinOps</a:t>
+              <a:t>Buyer: Eng Manager / FinOps</a:t>
             </a:r>
           </a:p>
         </p:txBody>
@@ -7110,8 +7100,8 @@
         </p:nvSpPr>
         <p:spPr>
           <a:xfrm>
-            <a:off x="896112" y="2331720"/>
-            <a:ext cx="3154680" cy="2331720"/>
+            <a:off x="841248" y="2432304"/>
+            <a:ext cx="3118104" cy="2404872"/>
           </a:xfrm>
           <a:prstGeom prst="rect">
             <a:avLst/>
@@ -7129,7 +7119,7 @@
                 <a:spcPts val="0"/>
               </a:spcBef>
               <a:spcAft>
-                <a:spcPts val="0"/>
+                <a:spcPts val="400"/>
               </a:spcAft>
             </a:pPr>
             <a:r>
@@ -7154,8 +7144,8 @@
         </p:nvSpPr>
         <p:spPr>
           <a:xfrm>
-            <a:off x="4389120" y="1737360"/>
-            <a:ext cx="3520440" cy="3108960"/>
+            <a:off x="4389120" y="1691640"/>
+            <a:ext cx="3520440" cy="3291840"/>
           </a:xfrm>
           <a:prstGeom prst="rect">
             <a:avLst/>
@@ -7197,8 +7187,8 @@
         </p:nvSpPr>
         <p:spPr>
           <a:xfrm>
-            <a:off x="4389120" y="1737360"/>
-            <a:ext cx="73152" cy="3108960"/>
+            <a:off x="4389120" y="1691640"/>
+            <a:ext cx="73152" cy="3291840"/>
           </a:xfrm>
           <a:prstGeom prst="rect">
             <a:avLst/>
@@ -7240,8 +7230,8 @@
         </p:nvSpPr>
         <p:spPr>
           <a:xfrm>
-            <a:off x="4389120" y="1737360"/>
-            <a:ext cx="3520440" cy="3108960"/>
+            <a:off x="4389120" y="1691640"/>
+            <a:ext cx="3520440" cy="3291840"/>
           </a:xfrm>
           <a:prstGeom prst="rect">
             <a:avLst/>
@@ -7283,8 +7273,8 @@
         </p:nvSpPr>
         <p:spPr>
           <a:xfrm>
-            <a:off x="4645152" y="1938528"/>
-            <a:ext cx="3154680" cy="365760"/>
+            <a:off x="4590288" y="1856232"/>
+            <a:ext cx="3118104" cy="502920"/>
           </a:xfrm>
           <a:prstGeom prst="rect">
             <a:avLst/>
@@ -7292,9 +7282,7 @@
           <a:noFill/>
         </p:spPr>
         <p:txBody>
-          <a:bodyPr wrap="square">
-            <a:spAutoFit/>
-          </a:bodyPr>
+          <a:bodyPr wrap="square"/>
           <a:lstStyle/>
           <a:p>
             <a:pPr algn="l">
@@ -7306,7 +7294,7 @@
               </a:spcAft>
             </a:pPr>
             <a:r>
-              <a:rPr sz="1600" b="1">
+              <a:rPr sz="1400" b="1">
                 <a:solidFill>
                   <a:srgbClr val="141C24"/>
                 </a:solidFill>
@@ -7314,7 +7302,7 @@
                 <a:ea typeface="Calibri"/>
                 <a:cs typeface="Calibri"/>
               </a:rPr>
-              <a:t>User  ·  Developer</a:t>
+              <a:t>User: Developer</a:t>
             </a:r>
           </a:p>
         </p:txBody>
@@ -7327,8 +7315,8 @@
         </p:nvSpPr>
         <p:spPr>
           <a:xfrm>
-            <a:off x="4645152" y="2331720"/>
-            <a:ext cx="3154680" cy="2331720"/>
+            <a:off x="4590288" y="2432304"/>
+            <a:ext cx="3118104" cy="2404872"/>
           </a:xfrm>
           <a:prstGeom prst="rect">
             <a:avLst/>
@@ -7346,7 +7334,7 @@
                 <a:spcPts val="0"/>
               </a:spcBef>
               <a:spcAft>
-                <a:spcPts val="0"/>
+                <a:spcPts val="400"/>
               </a:spcAft>
             </a:pPr>
             <a:r>
@@ -7371,8 +7359,8 @@
         </p:nvSpPr>
         <p:spPr>
           <a:xfrm>
-            <a:off x="8138160" y="1737360"/>
-            <a:ext cx="3520440" cy="3108960"/>
+            <a:off x="8138160" y="1691640"/>
+            <a:ext cx="3520440" cy="3291840"/>
           </a:xfrm>
           <a:prstGeom prst="rect">
             <a:avLst/>
@@ -7414,8 +7402,8 @@
         </p:nvSpPr>
         <p:spPr>
           <a:xfrm>
-            <a:off x="8138160" y="1737360"/>
-            <a:ext cx="73152" cy="3108960"/>
+            <a:off x="8138160" y="1691640"/>
+            <a:ext cx="73152" cy="3291840"/>
           </a:xfrm>
           <a:prstGeom prst="rect">
             <a:avLst/>
@@ -7457,8 +7445,8 @@
         </p:nvSpPr>
         <p:spPr>
           <a:xfrm>
-            <a:off x="8138160" y="1737360"/>
-            <a:ext cx="3520440" cy="3108960"/>
+            <a:off x="8138160" y="1691640"/>
+            <a:ext cx="3520440" cy="3291840"/>
           </a:xfrm>
           <a:prstGeom prst="rect">
             <a:avLst/>
@@ -7500,8 +7488,8 @@
         </p:nvSpPr>
         <p:spPr>
           <a:xfrm>
-            <a:off x="8394192" y="1938528"/>
-            <a:ext cx="3154680" cy="365760"/>
+            <a:off x="8339328" y="1856232"/>
+            <a:ext cx="3118104" cy="502920"/>
           </a:xfrm>
           <a:prstGeom prst="rect">
             <a:avLst/>
@@ -7509,9 +7497,7 @@
           <a:noFill/>
         </p:spPr>
         <p:txBody>
-          <a:bodyPr wrap="square">
-            <a:spAutoFit/>
-          </a:bodyPr>
+          <a:bodyPr wrap="square"/>
           <a:lstStyle/>
           <a:p>
             <a:pPr algn="l">
@@ -7523,7 +7509,7 @@
               </a:spcAft>
             </a:pPr>
             <a:r>
-              <a:rPr sz="1600" b="1">
+              <a:rPr sz="1400" b="1">
                 <a:solidFill>
                   <a:srgbClr val="141C24"/>
                 </a:solidFill>
@@ -7531,7 +7517,7 @@
                 <a:ea typeface="Calibri"/>
                 <a:cs typeface="Calibri"/>
               </a:rPr>
-              <a:t>Rollout  ·  Platform / DevEx</a:t>
+              <a:t>Rollout: Platform / DevEx</a:t>
             </a:r>
           </a:p>
         </p:txBody>
@@ -7544,8 +7530,8 @@
         </p:nvSpPr>
         <p:spPr>
           <a:xfrm>
-            <a:off x="8394192" y="2331720"/>
-            <a:ext cx="3154680" cy="2331720"/>
+            <a:off x="8339328" y="2432304"/>
+            <a:ext cx="3118104" cy="2404872"/>
           </a:xfrm>
           <a:prstGeom prst="rect">
             <a:avLst/>
@@ -7563,7 +7549,7 @@
                 <a:spcPts val="0"/>
               </a:spcBef>
               <a:spcAft>
-                <a:spcPts val="0"/>
+                <a:spcPts val="400"/>
               </a:spcAft>
             </a:pPr>
             <a:r>
@@ -7588,8 +7574,8 @@
         </p:nvSpPr>
         <p:spPr>
           <a:xfrm>
-            <a:off x="640080" y="6446520"/>
-            <a:ext cx="9144000" cy="274320"/>
+            <a:off x="640080" y="6492240"/>
+            <a:ext cx="10972800" cy="256032"/>
           </a:xfrm>
           <a:prstGeom prst="rect">
             <a:avLst/>
@@ -7619,7 +7605,7 @@
                 <a:ea typeface="Calibri"/>
                 <a:cs typeface="Calibri"/>
               </a:rPr>
-              <a:t>TokenForge  ·  AI Coding FinOps  ·  Confidential board brief  ·  5 / 10</a:t>
+              <a:t>TokenForge  ·  AI Coding FinOps  ·  Hackathon pitch  ·  5 / 10</a:t>
             </a:r>
           </a:p>
         </p:txBody>
@@ -7736,8 +7722,8 @@
         </p:nvSpPr>
         <p:spPr>
           <a:xfrm>
-            <a:off x="640080" y="502920"/>
-            <a:ext cx="10972800" cy="320040"/>
+            <a:off x="640080" y="457200"/>
+            <a:ext cx="10972800" cy="274320"/>
           </a:xfrm>
           <a:prstGeom prst="rect">
             <a:avLst/>
@@ -7780,7 +7766,7 @@
         </p:nvSpPr>
         <p:spPr>
           <a:xfrm>
-            <a:off x="640080" y="822960"/>
+            <a:off x="640080" y="777240"/>
             <a:ext cx="10972800" cy="640080"/>
           </a:xfrm>
           <a:prstGeom prst="rect">
@@ -7803,7 +7789,7 @@
               </a:spcAft>
             </a:pPr>
             <a:r>
-              <a:rPr sz="3600" b="1">
+              <a:rPr sz="3200" b="1">
                 <a:solidFill>
                   <a:srgbClr val="141C24"/>
                 </a:solidFill>
@@ -7824,8 +7810,8 @@
         </p:nvSpPr>
         <p:spPr>
           <a:xfrm>
-            <a:off x="640080" y="1737360"/>
-            <a:ext cx="3520440" cy="3200400"/>
+            <a:off x="640080" y="1691640"/>
+            <a:ext cx="3520440" cy="3383280"/>
           </a:xfrm>
           <a:prstGeom prst="rect">
             <a:avLst/>
@@ -7867,8 +7853,8 @@
         </p:nvSpPr>
         <p:spPr>
           <a:xfrm>
-            <a:off x="640080" y="1737360"/>
-            <a:ext cx="3520440" cy="822960"/>
+            <a:off x="640080" y="1691640"/>
+            <a:ext cx="3520440" cy="960120"/>
           </a:xfrm>
           <a:prstGeom prst="rect">
             <a:avLst/>
@@ -7910,8 +7896,8 @@
         </p:nvSpPr>
         <p:spPr>
           <a:xfrm>
-            <a:off x="914400" y="1874519"/>
-            <a:ext cx="2926080" cy="548640"/>
+            <a:off x="896112" y="1819656"/>
+            <a:ext cx="3063240" cy="274320"/>
           </a:xfrm>
           <a:prstGeom prst="rect">
             <a:avLst/>
@@ -7933,7 +7919,7 @@
               </a:spcAft>
             </a:pPr>
             <a:r>
-              <a:rPr sz="1400" b="1">
+              <a:rPr sz="1300" b="1">
                 <a:solidFill>
                   <a:srgbClr val="B7E0DC"/>
                 </a:solidFill>
@@ -7944,6 +7930,29 @@
               <a:t>01</a:t>
             </a:r>
           </a:p>
+        </p:txBody>
+      </p:sp>
+      <p:sp>
+        <p:nvSpPr>
+          <p:cNvPr id="9" name="TextBox 8"/>
+          <p:cNvSpPr txBox="1"/>
+          <p:nvPr/>
+        </p:nvSpPr>
+        <p:spPr>
+          <a:xfrm>
+            <a:off x="896112" y="2075688"/>
+            <a:ext cx="3063240" cy="411480"/>
+          </a:xfrm>
+          <a:prstGeom prst="rect">
+            <a:avLst/>
+          </a:prstGeom>
+          <a:noFill/>
+        </p:spPr>
+        <p:txBody>
+          <a:bodyPr wrap="square">
+            <a:spAutoFit/>
+          </a:bodyPr>
+          <a:lstStyle/>
           <a:p>
             <a:pPr algn="l">
               <a:spcBef>
@@ -7954,7 +7963,7 @@
               </a:spcAft>
             </a:pPr>
             <a:r>
-              <a:rPr sz="2400" b="1">
+              <a:rPr sz="2200" b="1">
                 <a:solidFill>
                   <a:srgbClr val="FFFFFF"/>
                 </a:solidFill>
@@ -7969,14 +7978,14 @@
       </p:sp>
       <p:sp>
         <p:nvSpPr>
-          <p:cNvPr id="9" name="TextBox 8"/>
+          <p:cNvPr id="10" name="TextBox 9"/>
           <p:cNvSpPr txBox="1"/>
           <p:nvPr/>
         </p:nvSpPr>
         <p:spPr>
           <a:xfrm>
-            <a:off x="914400" y="2788920"/>
-            <a:ext cx="2926080" cy="1920240"/>
+            <a:off x="896112" y="2880360"/>
+            <a:ext cx="3063240" cy="2057400"/>
           </a:xfrm>
           <a:prstGeom prst="rect">
             <a:avLst/>
@@ -7994,11 +8003,11 @@
                 <a:spcPts val="0"/>
               </a:spcBef>
               <a:spcAft>
-                <a:spcPts val="600"/>
+                <a:spcPts val="800"/>
               </a:spcAft>
             </a:pPr>
             <a:r>
-              <a:rPr sz="1600" b="0">
+              <a:rPr sz="1500" b="0">
                 <a:solidFill>
                   <a:srgbClr val="4A5766"/>
                 </a:solidFill>
@@ -8015,11 +8024,11 @@
                 <a:spcPts val="0"/>
               </a:spcBef>
               <a:spcAft>
-                <a:spcPts val="600"/>
+                <a:spcPts val="800"/>
               </a:spcAft>
             </a:pPr>
             <a:r>
-              <a:rPr sz="1600" b="0">
+              <a:rPr sz="1500" b="0">
                 <a:solidFill>
                   <a:srgbClr val="4A5766"/>
                 </a:solidFill>
@@ -8036,11 +8045,11 @@
                 <a:spcPts val="0"/>
               </a:spcBef>
               <a:spcAft>
-                <a:spcPts val="600"/>
+                <a:spcPts val="800"/>
               </a:spcAft>
             </a:pPr>
             <a:r>
-              <a:rPr sz="1600" b="0">
+              <a:rPr sz="1500" b="0">
                 <a:solidFill>
                   <a:srgbClr val="4A5766"/>
                 </a:solidFill>
@@ -8055,58 +8064,14 @@
       </p:sp>
       <p:sp>
         <p:nvSpPr>
-          <p:cNvPr id="10" name="TextBox 9"/>
-          <p:cNvSpPr txBox="1"/>
-          <p:nvPr/>
-        </p:nvSpPr>
-        <p:spPr>
-          <a:xfrm>
-            <a:off x="4114800" y="3108960"/>
-            <a:ext cx="320040" cy="365760"/>
-          </a:xfrm>
-          <a:prstGeom prst="rect">
-            <a:avLst/>
-          </a:prstGeom>
-          <a:noFill/>
-        </p:spPr>
-        <p:txBody>
-          <a:bodyPr wrap="square">
-            <a:spAutoFit/>
-          </a:bodyPr>
-          <a:lstStyle/>
-          <a:p>
-            <a:pPr algn="l">
-              <a:spcBef>
-                <a:spcPts val="0"/>
-              </a:spcBef>
-              <a:spcAft>
-                <a:spcPts val="0"/>
-              </a:spcAft>
-            </a:pPr>
-            <a:r>
-              <a:rPr sz="2200" b="1">
-                <a:solidFill>
-                  <a:srgbClr val="0B6E6A"/>
-                </a:solidFill>
-                <a:latin typeface="Calibri"/>
-                <a:ea typeface="Calibri"/>
-                <a:cs typeface="Calibri"/>
-              </a:rPr>
-              <a:t>→</a:t>
-            </a:r>
-          </a:p>
-        </p:txBody>
-      </p:sp>
-      <p:sp>
-        <p:nvSpPr>
           <p:cNvPr id="11" name="Rectangle 10"/>
           <p:cNvSpPr/>
           <p:nvPr/>
         </p:nvSpPr>
         <p:spPr>
           <a:xfrm>
-            <a:off x="4389120" y="1737360"/>
-            <a:ext cx="3520440" cy="3200400"/>
+            <a:off x="4389120" y="1691640"/>
+            <a:ext cx="3520440" cy="3383280"/>
           </a:xfrm>
           <a:prstGeom prst="rect">
             <a:avLst/>
@@ -8148,8 +8113,8 @@
         </p:nvSpPr>
         <p:spPr>
           <a:xfrm>
-            <a:off x="4389120" y="1737360"/>
-            <a:ext cx="3520440" cy="822960"/>
+            <a:off x="4389120" y="1691640"/>
+            <a:ext cx="3520440" cy="960120"/>
           </a:xfrm>
           <a:prstGeom prst="rect">
             <a:avLst/>
@@ -8191,8 +8156,8 @@
         </p:nvSpPr>
         <p:spPr>
           <a:xfrm>
-            <a:off x="4663440" y="1874519"/>
-            <a:ext cx="2926080" cy="548640"/>
+            <a:off x="4645152" y="1819656"/>
+            <a:ext cx="3063240" cy="274320"/>
           </a:xfrm>
           <a:prstGeom prst="rect">
             <a:avLst/>
@@ -8214,7 +8179,7 @@
               </a:spcAft>
             </a:pPr>
             <a:r>
-              <a:rPr sz="1400" b="1">
+              <a:rPr sz="1300" b="1">
                 <a:solidFill>
                   <a:srgbClr val="B7E0DC"/>
                 </a:solidFill>
@@ -8225,6 +8190,29 @@
               <a:t>02</a:t>
             </a:r>
           </a:p>
+        </p:txBody>
+      </p:sp>
+      <p:sp>
+        <p:nvSpPr>
+          <p:cNvPr id="14" name="TextBox 13"/>
+          <p:cNvSpPr txBox="1"/>
+          <p:nvPr/>
+        </p:nvSpPr>
+        <p:spPr>
+          <a:xfrm>
+            <a:off x="4645152" y="2075688"/>
+            <a:ext cx="3063240" cy="411480"/>
+          </a:xfrm>
+          <a:prstGeom prst="rect">
+            <a:avLst/>
+          </a:prstGeom>
+          <a:noFill/>
+        </p:spPr>
+        <p:txBody>
+          <a:bodyPr wrap="square">
+            <a:spAutoFit/>
+          </a:bodyPr>
+          <a:lstStyle/>
           <a:p>
             <a:pPr algn="l">
               <a:spcBef>
@@ -8235,7 +8223,7 @@
               </a:spcAft>
             </a:pPr>
             <a:r>
-              <a:rPr sz="2400" b="1">
+              <a:rPr sz="2200" b="1">
                 <a:solidFill>
                   <a:srgbClr val="FFFFFF"/>
                 </a:solidFill>
@@ -8250,14 +8238,14 @@
       </p:sp>
       <p:sp>
         <p:nvSpPr>
-          <p:cNvPr id="14" name="TextBox 13"/>
+          <p:cNvPr id="15" name="TextBox 14"/>
           <p:cNvSpPr txBox="1"/>
           <p:nvPr/>
         </p:nvSpPr>
         <p:spPr>
           <a:xfrm>
-            <a:off x="4663440" y="2788920"/>
-            <a:ext cx="2926080" cy="1920240"/>
+            <a:off x="4645152" y="2880360"/>
+            <a:ext cx="3063240" cy="2057400"/>
           </a:xfrm>
           <a:prstGeom prst="rect">
             <a:avLst/>
@@ -8275,11 +8263,11 @@
                 <a:spcPts val="0"/>
               </a:spcBef>
               <a:spcAft>
-                <a:spcPts val="600"/>
+                <a:spcPts val="800"/>
               </a:spcAft>
             </a:pPr>
             <a:r>
-              <a:rPr sz="1600" b="0">
+              <a:rPr sz="1500" b="0">
                 <a:solidFill>
                   <a:srgbClr val="4A5766"/>
                 </a:solidFill>
@@ -8296,11 +8284,11 @@
                 <a:spcPts val="0"/>
               </a:spcBef>
               <a:spcAft>
-                <a:spcPts val="600"/>
+                <a:spcPts val="800"/>
               </a:spcAft>
             </a:pPr>
             <a:r>
-              <a:rPr sz="1600" b="0">
+              <a:rPr sz="1500" b="0">
                 <a:solidFill>
                   <a:srgbClr val="4A5766"/>
                 </a:solidFill>
@@ -8317,11 +8305,11 @@
                 <a:spcPts val="0"/>
               </a:spcBef>
               <a:spcAft>
-                <a:spcPts val="600"/>
+                <a:spcPts val="800"/>
               </a:spcAft>
             </a:pPr>
             <a:r>
-              <a:rPr sz="1600" b="0">
+              <a:rPr sz="1500" b="0">
                 <a:solidFill>
                   <a:srgbClr val="4A5766"/>
                 </a:solidFill>
@@ -8336,58 +8324,14 @@
       </p:sp>
       <p:sp>
         <p:nvSpPr>
-          <p:cNvPr id="15" name="TextBox 14"/>
-          <p:cNvSpPr txBox="1"/>
-          <p:nvPr/>
-        </p:nvSpPr>
-        <p:spPr>
-          <a:xfrm>
-            <a:off x="7863840" y="3108960"/>
-            <a:ext cx="320040" cy="365760"/>
-          </a:xfrm>
-          <a:prstGeom prst="rect">
-            <a:avLst/>
-          </a:prstGeom>
-          <a:noFill/>
-        </p:spPr>
-        <p:txBody>
-          <a:bodyPr wrap="square">
-            <a:spAutoFit/>
-          </a:bodyPr>
-          <a:lstStyle/>
-          <a:p>
-            <a:pPr algn="l">
-              <a:spcBef>
-                <a:spcPts val="0"/>
-              </a:spcBef>
-              <a:spcAft>
-                <a:spcPts val="0"/>
-              </a:spcAft>
-            </a:pPr>
-            <a:r>
-              <a:rPr sz="2200" b="1">
-                <a:solidFill>
-                  <a:srgbClr val="0B6E6A"/>
-                </a:solidFill>
-                <a:latin typeface="Calibri"/>
-                <a:ea typeface="Calibri"/>
-                <a:cs typeface="Calibri"/>
-              </a:rPr>
-              <a:t>→</a:t>
-            </a:r>
-          </a:p>
-        </p:txBody>
-      </p:sp>
-      <p:sp>
-        <p:nvSpPr>
           <p:cNvPr id="16" name="Rectangle 15"/>
           <p:cNvSpPr/>
           <p:nvPr/>
         </p:nvSpPr>
         <p:spPr>
           <a:xfrm>
-            <a:off x="8138160" y="1737360"/>
-            <a:ext cx="3520440" cy="3200400"/>
+            <a:off x="8138160" y="1691640"/>
+            <a:ext cx="3520440" cy="3383280"/>
           </a:xfrm>
           <a:prstGeom prst="rect">
             <a:avLst/>
@@ -8429,8 +8373,8 @@
         </p:nvSpPr>
         <p:spPr>
           <a:xfrm>
-            <a:off x="8138160" y="1737360"/>
-            <a:ext cx="3520440" cy="822960"/>
+            <a:off x="8138160" y="1691640"/>
+            <a:ext cx="3520440" cy="960120"/>
           </a:xfrm>
           <a:prstGeom prst="rect">
             <a:avLst/>
@@ -8472,8 +8416,8 @@
         </p:nvSpPr>
         <p:spPr>
           <a:xfrm>
-            <a:off x="8412480" y="1874519"/>
-            <a:ext cx="2926080" cy="548640"/>
+            <a:off x="8394192" y="1819656"/>
+            <a:ext cx="3063240" cy="274320"/>
           </a:xfrm>
           <a:prstGeom prst="rect">
             <a:avLst/>
@@ -8495,7 +8439,7 @@
               </a:spcAft>
             </a:pPr>
             <a:r>
-              <a:rPr sz="1400" b="1">
+              <a:rPr sz="1300" b="1">
                 <a:solidFill>
                   <a:srgbClr val="B7E0DC"/>
                 </a:solidFill>
@@ -8506,6 +8450,29 @@
               <a:t>03</a:t>
             </a:r>
           </a:p>
+        </p:txBody>
+      </p:sp>
+      <p:sp>
+        <p:nvSpPr>
+          <p:cNvPr id="19" name="TextBox 18"/>
+          <p:cNvSpPr txBox="1"/>
+          <p:nvPr/>
+        </p:nvSpPr>
+        <p:spPr>
+          <a:xfrm>
+            <a:off x="8394192" y="2075688"/>
+            <a:ext cx="3063240" cy="411480"/>
+          </a:xfrm>
+          <a:prstGeom prst="rect">
+            <a:avLst/>
+          </a:prstGeom>
+          <a:noFill/>
+        </p:spPr>
+        <p:txBody>
+          <a:bodyPr wrap="square">
+            <a:spAutoFit/>
+          </a:bodyPr>
+          <a:lstStyle/>
           <a:p>
             <a:pPr algn="l">
               <a:spcBef>
@@ -8516,7 +8483,7 @@
               </a:spcAft>
             </a:pPr>
             <a:r>
-              <a:rPr sz="2400" b="1">
+              <a:rPr sz="2200" b="1">
                 <a:solidFill>
                   <a:srgbClr val="FFFFFF"/>
                 </a:solidFill>
@@ -8531,14 +8498,14 @@
       </p:sp>
       <p:sp>
         <p:nvSpPr>
-          <p:cNvPr id="19" name="TextBox 18"/>
+          <p:cNvPr id="20" name="TextBox 19"/>
           <p:cNvSpPr txBox="1"/>
           <p:nvPr/>
         </p:nvSpPr>
         <p:spPr>
           <a:xfrm>
-            <a:off x="8412480" y="2788920"/>
-            <a:ext cx="2926080" cy="1920240"/>
+            <a:off x="8394192" y="2880360"/>
+            <a:ext cx="3063240" cy="2057400"/>
           </a:xfrm>
           <a:prstGeom prst="rect">
             <a:avLst/>
@@ -8556,11 +8523,11 @@
                 <a:spcPts val="0"/>
               </a:spcBef>
               <a:spcAft>
-                <a:spcPts val="600"/>
+                <a:spcPts val="800"/>
               </a:spcAft>
             </a:pPr>
             <a:r>
-              <a:rPr sz="1600" b="0">
+              <a:rPr sz="1500" b="0">
                 <a:solidFill>
                   <a:srgbClr val="4A5766"/>
                 </a:solidFill>
@@ -8577,11 +8544,11 @@
                 <a:spcPts val="0"/>
               </a:spcBef>
               <a:spcAft>
-                <a:spcPts val="600"/>
+                <a:spcPts val="800"/>
               </a:spcAft>
             </a:pPr>
             <a:r>
-              <a:rPr sz="1600" b="0">
+              <a:rPr sz="1500" b="0">
                 <a:solidFill>
                   <a:srgbClr val="4A5766"/>
                 </a:solidFill>
@@ -8598,11 +8565,11 @@
                 <a:spcPts val="0"/>
               </a:spcBef>
               <a:spcAft>
-                <a:spcPts val="600"/>
+                <a:spcPts val="800"/>
               </a:spcAft>
             </a:pPr>
             <a:r>
-              <a:rPr sz="1600" b="0">
+              <a:rPr sz="1500" b="0">
                 <a:solidFill>
                   <a:srgbClr val="4A5766"/>
                 </a:solidFill>
@@ -8617,14 +8584,14 @@
       </p:sp>
       <p:sp>
         <p:nvSpPr>
-          <p:cNvPr id="20" name="TextBox 19"/>
+          <p:cNvPr id="21" name="TextBox 20"/>
           <p:cNvSpPr txBox="1"/>
           <p:nvPr/>
         </p:nvSpPr>
         <p:spPr>
           <a:xfrm>
-            <a:off x="640080" y="6446520"/>
-            <a:ext cx="9144000" cy="274320"/>
+            <a:off x="640080" y="6492240"/>
+            <a:ext cx="10972800" cy="256032"/>
           </a:xfrm>
           <a:prstGeom prst="rect">
             <a:avLst/>
@@ -8654,7 +8621,7 @@
                 <a:ea typeface="Calibri"/>
                 <a:cs typeface="Calibri"/>
               </a:rPr>
-              <a:t>TokenForge  ·  AI Coding FinOps  ·  Confidential board brief  ·  6 / 10</a:t>
+              <a:t>TokenForge  ·  AI Coding FinOps  ·  Hackathon pitch  ·  6 / 10</a:t>
             </a:r>
           </a:p>
         </p:txBody>
@@ -8771,8 +8738,8 @@
         </p:nvSpPr>
         <p:spPr>
           <a:xfrm>
-            <a:off x="640080" y="502920"/>
-            <a:ext cx="10972800" cy="320040"/>
+            <a:off x="640080" y="457200"/>
+            <a:ext cx="10972800" cy="274320"/>
           </a:xfrm>
           <a:prstGeom prst="rect">
             <a:avLst/>
@@ -8802,7 +8769,7 @@
                 <a:ea typeface="Calibri"/>
                 <a:cs typeface="Calibri"/>
               </a:rPr>
-              <a:t>06  ·  LIVE PROOF</a:t>
+              <a:t>06  ·  LIVE DEMO</a:t>
             </a:r>
           </a:p>
         </p:txBody>
@@ -8815,7 +8782,7 @@
         </p:nvSpPr>
         <p:spPr>
           <a:xfrm>
-            <a:off x="640080" y="822960"/>
+            <a:off x="640080" y="777240"/>
             <a:ext cx="10972800" cy="640080"/>
           </a:xfrm>
           <a:prstGeom prst="rect">
@@ -8838,7 +8805,7 @@
               </a:spcAft>
             </a:pPr>
             <a:r>
-              <a:rPr sz="3600" b="1">
+              <a:rPr sz="3000" b="1">
                 <a:solidFill>
                   <a:srgbClr val="141C24"/>
                 </a:solidFill>
@@ -8859,8 +8826,8 @@
         </p:nvSpPr>
         <p:spPr>
           <a:xfrm>
-            <a:off x="640080" y="1737360"/>
-            <a:ext cx="2606040" cy="3200400"/>
+            <a:off x="640080" y="1691640"/>
+            <a:ext cx="2606040" cy="3383280"/>
           </a:xfrm>
           <a:prstGeom prst="rect">
             <a:avLst/>
@@ -8902,8 +8869,8 @@
         </p:nvSpPr>
         <p:spPr>
           <a:xfrm>
-            <a:off x="640080" y="1737360"/>
-            <a:ext cx="73152" cy="3200400"/>
+            <a:off x="640080" y="1691640"/>
+            <a:ext cx="73152" cy="3383280"/>
           </a:xfrm>
           <a:prstGeom prst="rect">
             <a:avLst/>
@@ -8945,8 +8912,8 @@
         </p:nvSpPr>
         <p:spPr>
           <a:xfrm>
-            <a:off x="640080" y="1737360"/>
-            <a:ext cx="2606040" cy="3200400"/>
+            <a:off x="640080" y="1691640"/>
+            <a:ext cx="2606040" cy="3383280"/>
           </a:xfrm>
           <a:prstGeom prst="rect">
             <a:avLst/>
@@ -8988,8 +8955,8 @@
         </p:nvSpPr>
         <p:spPr>
           <a:xfrm>
-            <a:off x="896112" y="1938528"/>
-            <a:ext cx="2240280" cy="365760"/>
+            <a:off x="841248" y="1856232"/>
+            <a:ext cx="2203704" cy="502920"/>
           </a:xfrm>
           <a:prstGeom prst="rect">
             <a:avLst/>
@@ -8997,9 +8964,7 @@
           <a:noFill/>
         </p:spPr>
         <p:txBody>
-          <a:bodyPr wrap="square">
-            <a:spAutoFit/>
-          </a:bodyPr>
+          <a:bodyPr wrap="square"/>
           <a:lstStyle/>
           <a:p>
             <a:pPr algn="l">
@@ -9011,7 +8976,7 @@
               </a:spcAft>
             </a:pPr>
             <a:r>
-              <a:rPr sz="1600" b="1">
+              <a:rPr sz="1500" b="1">
                 <a:solidFill>
                   <a:srgbClr val="141C24"/>
                 </a:solidFill>
@@ -9019,7 +8984,7 @@
                 <a:ea typeface="Calibri"/>
                 <a:cs typeface="Calibri"/>
               </a:rPr>
-              <a:t>1.  Detect</a:t>
+              <a:t>1. Detect</a:t>
             </a:r>
           </a:p>
         </p:txBody>
@@ -9032,8 +8997,8 @@
         </p:nvSpPr>
         <p:spPr>
           <a:xfrm>
-            <a:off x="896112" y="2331720"/>
-            <a:ext cx="2240280" cy="2423160"/>
+            <a:off x="841248" y="2432304"/>
+            <a:ext cx="2203704" cy="2496312"/>
           </a:xfrm>
           <a:prstGeom prst="rect">
             <a:avLst/>
@@ -9051,11 +9016,11 @@
                 <a:spcPts val="0"/>
               </a:spcBef>
               <a:spcAft>
-                <a:spcPts val="0"/>
+                <a:spcPts val="400"/>
               </a:spcAft>
             </a:pPr>
             <a:r>
-              <a:rPr sz="1400" b="0">
+              <a:rPr sz="1300" b="0">
                 <a:solidFill>
                   <a:srgbClr val="4A5766"/>
                 </a:solidFill>
@@ -9063,8 +9028,28 @@
                 <a:ea typeface="Calibri"/>
                 <a:cs typeface="Calibri"/>
               </a:rPr>
-              <a:t>Context Guard on noisy tabs
-Filter lockfile → risk drops</a:t>
+              <a:t>Context Guard on noisy tabs.</a:t>
+            </a:r>
+          </a:p>
+          <a:p>
+            <a:pPr algn="l">
+              <a:spcBef>
+                <a:spcPts val="0"/>
+              </a:spcBef>
+              <a:spcAft>
+                <a:spcPts val="400"/>
+              </a:spcAft>
+            </a:pPr>
+            <a:r>
+              <a:rPr sz="1300" b="0">
+                <a:solidFill>
+                  <a:srgbClr val="4A5766"/>
+                </a:solidFill>
+                <a:latin typeface="Calibri"/>
+                <a:ea typeface="Calibri"/>
+                <a:cs typeface="Calibri"/>
+              </a:rPr>
+              <a:t>Filter lockfile → risk drops.</a:t>
             </a:r>
           </a:p>
         </p:txBody>
@@ -9077,8 +9062,8 @@
         </p:nvSpPr>
         <p:spPr>
           <a:xfrm>
-            <a:off x="3447288" y="1737360"/>
-            <a:ext cx="2606040" cy="3200400"/>
+            <a:off x="3447288" y="1691640"/>
+            <a:ext cx="2606040" cy="3383280"/>
           </a:xfrm>
           <a:prstGeom prst="rect">
             <a:avLst/>
@@ -9120,8 +9105,8 @@
         </p:nvSpPr>
         <p:spPr>
           <a:xfrm>
-            <a:off x="3447288" y="1737360"/>
-            <a:ext cx="73152" cy="3200400"/>
+            <a:off x="3447288" y="1691640"/>
+            <a:ext cx="73152" cy="3383280"/>
           </a:xfrm>
           <a:prstGeom prst="rect">
             <a:avLst/>
@@ -9163,8 +9148,8 @@
         </p:nvSpPr>
         <p:spPr>
           <a:xfrm>
-            <a:off x="3447288" y="1737360"/>
-            <a:ext cx="2606040" cy="3200400"/>
+            <a:off x="3447288" y="1691640"/>
+            <a:ext cx="2606040" cy="3383280"/>
           </a:xfrm>
           <a:prstGeom prst="rect">
             <a:avLst/>
@@ -9206,8 +9191,8 @@
         </p:nvSpPr>
         <p:spPr>
           <a:xfrm>
-            <a:off x="3703320" y="1938528"/>
-            <a:ext cx="2240280" cy="365760"/>
+            <a:off x="3648456" y="1856232"/>
+            <a:ext cx="2203704" cy="502920"/>
           </a:xfrm>
           <a:prstGeom prst="rect">
             <a:avLst/>
@@ -9215,9 +9200,7 @@
           <a:noFill/>
         </p:spPr>
         <p:txBody>
-          <a:bodyPr wrap="square">
-            <a:spAutoFit/>
-          </a:bodyPr>
+          <a:bodyPr wrap="square"/>
           <a:lstStyle/>
           <a:p>
             <a:pPr algn="l">
@@ -9229,7 +9212,7 @@
               </a:spcAft>
             </a:pPr>
             <a:r>
-              <a:rPr sz="1600" b="1">
+              <a:rPr sz="1500" b="1">
                 <a:solidFill>
                   <a:srgbClr val="141C24"/>
                 </a:solidFill>
@@ -9237,7 +9220,7 @@
                 <a:ea typeface="Calibri"/>
                 <a:cs typeface="Calibri"/>
               </a:rPr>
-              <a:t>2.  Fix</a:t>
+              <a:t>2. Fix</a:t>
             </a:r>
           </a:p>
         </p:txBody>
@@ -9250,8 +9233,8 @@
         </p:nvSpPr>
         <p:spPr>
           <a:xfrm>
-            <a:off x="3703320" y="2331720"/>
-            <a:ext cx="2240280" cy="2423160"/>
+            <a:off x="3648456" y="2432304"/>
+            <a:ext cx="2203704" cy="2496312"/>
           </a:xfrm>
           <a:prstGeom prst="rect">
             <a:avLst/>
@@ -9269,11 +9252,11 @@
                 <a:spcPts val="0"/>
               </a:spcBef>
               <a:spcAft>
-                <a:spcPts val="0"/>
+                <a:spcPts val="400"/>
               </a:spcAft>
             </a:pPr>
             <a:r>
-              <a:rPr sz="1400" b="0">
+              <a:rPr sz="1300" b="0">
                 <a:solidFill>
                   <a:srgbClr val="4A5766"/>
                 </a:solidFill>
@@ -9281,8 +9264,28 @@
                 <a:ea typeface="Calibri"/>
                 <a:cs typeface="Calibri"/>
               </a:rPr>
-              <a:t>CLI scan → apply policy pack
-(or org-pack for the estate)</a:t>
+              <a:t>CLI scan → apply policy pack</a:t>
+            </a:r>
+          </a:p>
+          <a:p>
+            <a:pPr algn="l">
+              <a:spcBef>
+                <a:spcPts val="0"/>
+              </a:spcBef>
+              <a:spcAft>
+                <a:spcPts val="400"/>
+              </a:spcAft>
+            </a:pPr>
+            <a:r>
+              <a:rPr sz="1300" b="0">
+                <a:solidFill>
+                  <a:srgbClr val="4A5766"/>
+                </a:solidFill>
+                <a:latin typeface="Calibri"/>
+                <a:ea typeface="Calibri"/>
+                <a:cs typeface="Calibri"/>
+              </a:rPr>
+              <a:t>(or org-pack for the estate).</a:t>
             </a:r>
           </a:p>
         </p:txBody>
@@ -9295,8 +9298,8 @@
         </p:nvSpPr>
         <p:spPr>
           <a:xfrm>
-            <a:off x="6254496" y="1737360"/>
-            <a:ext cx="2606040" cy="3200400"/>
+            <a:off x="6254496" y="1691640"/>
+            <a:ext cx="2606040" cy="3383280"/>
           </a:xfrm>
           <a:prstGeom prst="rect">
             <a:avLst/>
@@ -9338,8 +9341,8 @@
         </p:nvSpPr>
         <p:spPr>
           <a:xfrm>
-            <a:off x="6254496" y="1737360"/>
-            <a:ext cx="73152" cy="3200400"/>
+            <a:off x="6254496" y="1691640"/>
+            <a:ext cx="73152" cy="3383280"/>
           </a:xfrm>
           <a:prstGeom prst="rect">
             <a:avLst/>
@@ -9381,8 +9384,8 @@
         </p:nvSpPr>
         <p:spPr>
           <a:xfrm>
-            <a:off x="6254496" y="1737360"/>
-            <a:ext cx="2606040" cy="3200400"/>
+            <a:off x="6254496" y="1691640"/>
+            <a:ext cx="2606040" cy="3383280"/>
           </a:xfrm>
           <a:prstGeom prst="rect">
             <a:avLst/>
@@ -9424,8 +9427,8 @@
         </p:nvSpPr>
         <p:spPr>
           <a:xfrm>
-            <a:off x="6510528" y="1938528"/>
-            <a:ext cx="2240280" cy="365760"/>
+            <a:off x="6455664" y="1856232"/>
+            <a:ext cx="2203704" cy="502920"/>
           </a:xfrm>
           <a:prstGeom prst="rect">
             <a:avLst/>
@@ -9433,9 +9436,7 @@
           <a:noFill/>
         </p:spPr>
         <p:txBody>
-          <a:bodyPr wrap="square">
-            <a:spAutoFit/>
-          </a:bodyPr>
+          <a:bodyPr wrap="square"/>
           <a:lstStyle/>
           <a:p>
             <a:pPr algn="l">
@@ -9447,7 +9448,7 @@
               </a:spcAft>
             </a:pPr>
             <a:r>
-              <a:rPr sz="1600" b="1">
+              <a:rPr sz="1500" b="1">
                 <a:solidFill>
                   <a:srgbClr val="141C24"/>
                 </a:solidFill>
@@ -9455,7 +9456,7 @@
                 <a:ea typeface="Calibri"/>
                 <a:cs typeface="Calibri"/>
               </a:rPr>
-              <a:t>3.  Prove</a:t>
+              <a:t>3. Prove</a:t>
             </a:r>
           </a:p>
         </p:txBody>
@@ -9468,8 +9469,8 @@
         </p:nvSpPr>
         <p:spPr>
           <a:xfrm>
-            <a:off x="6510528" y="2331720"/>
-            <a:ext cx="2240280" cy="2423160"/>
+            <a:off x="6455664" y="2432304"/>
+            <a:ext cx="2203704" cy="2496312"/>
           </a:xfrm>
           <a:prstGeom prst="rect">
             <a:avLst/>
@@ -9487,11 +9488,11 @@
                 <a:spcPts val="0"/>
               </a:spcBef>
               <a:spcAft>
-                <a:spcPts val="0"/>
+                <a:spcPts val="400"/>
               </a:spcAft>
             </a:pPr>
             <a:r>
-              <a:rPr sz="1400" b="0">
+              <a:rPr sz="1300" b="0">
                 <a:solidFill>
                   <a:srgbClr val="4A5766"/>
                 </a:solidFill>
@@ -9499,8 +9500,28 @@
                 <a:ea typeface="Calibri"/>
                 <a:cs typeface="Calibri"/>
               </a:rPr>
-              <a:t>Global Overview → team drill-down
-Architecture mix + usage import</a:t>
+              <a:t>Global Overview → team drill-down.</a:t>
+            </a:r>
+          </a:p>
+          <a:p>
+            <a:pPr algn="l">
+              <a:spcBef>
+                <a:spcPts val="0"/>
+              </a:spcBef>
+              <a:spcAft>
+                <a:spcPts val="400"/>
+              </a:spcAft>
+            </a:pPr>
+            <a:r>
+              <a:rPr sz="1300" b="0">
+                <a:solidFill>
+                  <a:srgbClr val="4A5766"/>
+                </a:solidFill>
+                <a:latin typeface="Calibri"/>
+                <a:ea typeface="Calibri"/>
+                <a:cs typeface="Calibri"/>
+              </a:rPr>
+              <a:t>Architecture mix + usage import.</a:t>
             </a:r>
           </a:p>
         </p:txBody>
@@ -9513,8 +9534,8 @@
         </p:nvSpPr>
         <p:spPr>
           <a:xfrm>
-            <a:off x="9061704" y="1737360"/>
-            <a:ext cx="2606040" cy="3200400"/>
+            <a:off x="9061704" y="1691640"/>
+            <a:ext cx="2606040" cy="3383280"/>
           </a:xfrm>
           <a:prstGeom prst="rect">
             <a:avLst/>
@@ -9556,8 +9577,8 @@
         </p:nvSpPr>
         <p:spPr>
           <a:xfrm>
-            <a:off x="9061704" y="1737360"/>
-            <a:ext cx="73152" cy="3200400"/>
+            <a:off x="9061704" y="1691640"/>
+            <a:ext cx="73152" cy="3383280"/>
           </a:xfrm>
           <a:prstGeom prst="rect">
             <a:avLst/>
@@ -9599,8 +9620,8 @@
         </p:nvSpPr>
         <p:spPr>
           <a:xfrm>
-            <a:off x="9061704" y="1737360"/>
-            <a:ext cx="2606040" cy="3200400"/>
+            <a:off x="9061704" y="1691640"/>
+            <a:ext cx="2606040" cy="3383280"/>
           </a:xfrm>
           <a:prstGeom prst="rect">
             <a:avLst/>
@@ -9642,8 +9663,8 @@
         </p:nvSpPr>
         <p:spPr>
           <a:xfrm>
-            <a:off x="9317736" y="1938528"/>
-            <a:ext cx="2240280" cy="365760"/>
+            <a:off x="9262872" y="1856232"/>
+            <a:ext cx="2203704" cy="502920"/>
           </a:xfrm>
           <a:prstGeom prst="rect">
             <a:avLst/>
@@ -9651,9 +9672,7 @@
           <a:noFill/>
         </p:spPr>
         <p:txBody>
-          <a:bodyPr wrap="square">
-            <a:spAutoFit/>
-          </a:bodyPr>
+          <a:bodyPr wrap="square"/>
           <a:lstStyle/>
           <a:p>
             <a:pPr algn="l">
@@ -9665,7 +9684,7 @@
               </a:spcAft>
             </a:pPr>
             <a:r>
-              <a:rPr sz="1600" b="1">
+              <a:rPr sz="1500" b="1">
                 <a:solidFill>
                   <a:srgbClr val="141C24"/>
                 </a:solidFill>
@@ -9673,7 +9692,7 @@
                 <a:ea typeface="Calibri"/>
                 <a:cs typeface="Calibri"/>
               </a:rPr>
-              <a:t>4.  Close</a:t>
+              <a:t>4. Close</a:t>
             </a:r>
           </a:p>
         </p:txBody>
@@ -9686,8 +9705,8 @@
         </p:nvSpPr>
         <p:spPr>
           <a:xfrm>
-            <a:off x="9317736" y="2331720"/>
-            <a:ext cx="2240280" cy="2423160"/>
+            <a:off x="9262872" y="2432304"/>
+            <a:ext cx="2203704" cy="2496312"/>
           </a:xfrm>
           <a:prstGeom prst="rect">
             <a:avLst/>
@@ -9705,11 +9724,11 @@
                 <a:spcPts val="0"/>
               </a:spcBef>
               <a:spcAft>
-                <a:spcPts val="0"/>
+                <a:spcPts val="400"/>
               </a:spcAft>
             </a:pPr>
             <a:r>
-              <a:rPr sz="1400" b="0">
+              <a:rPr sz="1300" b="0">
                 <a:solidFill>
                   <a:srgbClr val="4A5766"/>
                 </a:solidFill>
@@ -9717,44 +9736,20 @@
                 <a:ea typeface="Calibri"/>
                 <a:cs typeface="Calibri"/>
               </a:rPr>
-              <a:t>Assumptions → ~30% scenario
-Memory ≠ FinOps sound bite</a:t>
-            </a:r>
-          </a:p>
-        </p:txBody>
-      </p:sp>
-      <p:sp>
-        <p:nvSpPr>
-          <p:cNvPr id="26" name="TextBox 25"/>
-          <p:cNvSpPr txBox="1"/>
-          <p:nvPr/>
-        </p:nvSpPr>
-        <p:spPr>
-          <a:xfrm>
-            <a:off x="640080" y="6446520"/>
-            <a:ext cx="9144000" cy="274320"/>
-          </a:xfrm>
-          <a:prstGeom prst="rect">
-            <a:avLst/>
-          </a:prstGeom>
-          <a:noFill/>
-        </p:spPr>
-        <p:txBody>
-          <a:bodyPr wrap="square">
-            <a:spAutoFit/>
-          </a:bodyPr>
-          <a:lstStyle/>
+              <a:t>Assumptions → ~30% scenario.</a:t>
+            </a:r>
+          </a:p>
           <a:p>
             <a:pPr algn="l">
               <a:spcBef>
                 <a:spcPts val="0"/>
               </a:spcBef>
               <a:spcAft>
-                <a:spcPts val="0"/>
+                <a:spcPts val="400"/>
               </a:spcAft>
             </a:pPr>
             <a:r>
-              <a:rPr sz="1100" b="0">
+              <a:rPr sz="1300" b="0">
                 <a:solidFill>
                   <a:srgbClr val="4A5766"/>
                 </a:solidFill>
@@ -9762,7 +9757,51 @@
                 <a:ea typeface="Calibri"/>
                 <a:cs typeface="Calibri"/>
               </a:rPr>
-              <a:t>TokenForge  ·  AI Coding FinOps  ·  Confidential board brief  ·  7 / 10</a:t>
+              <a:t>Memory ≠ FinOps sound bite.</a:t>
+            </a:r>
+          </a:p>
+        </p:txBody>
+      </p:sp>
+      <p:sp>
+        <p:nvSpPr>
+          <p:cNvPr id="26" name="TextBox 25"/>
+          <p:cNvSpPr txBox="1"/>
+          <p:nvPr/>
+        </p:nvSpPr>
+        <p:spPr>
+          <a:xfrm>
+            <a:off x="640080" y="6492240"/>
+            <a:ext cx="10972800" cy="256032"/>
+          </a:xfrm>
+          <a:prstGeom prst="rect">
+            <a:avLst/>
+          </a:prstGeom>
+          <a:noFill/>
+        </p:spPr>
+        <p:txBody>
+          <a:bodyPr wrap="square">
+            <a:spAutoFit/>
+          </a:bodyPr>
+          <a:lstStyle/>
+          <a:p>
+            <a:pPr algn="l">
+              <a:spcBef>
+                <a:spcPts val="0"/>
+              </a:spcBef>
+              <a:spcAft>
+                <a:spcPts val="0"/>
+              </a:spcAft>
+            </a:pPr>
+            <a:r>
+              <a:rPr sz="1100" b="0">
+                <a:solidFill>
+                  <a:srgbClr val="4A5766"/>
+                </a:solidFill>
+                <a:latin typeface="Calibri"/>
+                <a:ea typeface="Calibri"/>
+                <a:cs typeface="Calibri"/>
+              </a:rPr>
+              <a:t>TokenForge  ·  AI Coding FinOps  ·  Hackathon pitch  ·  7 / 10</a:t>
             </a:r>
           </a:p>
         </p:txBody>
@@ -9879,8 +9918,8 @@
         </p:nvSpPr>
         <p:spPr>
           <a:xfrm>
-            <a:off x="640080" y="502920"/>
-            <a:ext cx="10972800" cy="320040"/>
+            <a:off x="640080" y="457200"/>
+            <a:ext cx="10972800" cy="274320"/>
           </a:xfrm>
           <a:prstGeom prst="rect">
             <a:avLst/>
@@ -9910,7 +9949,7 @@
                 <a:ea typeface="Calibri"/>
                 <a:cs typeface="Calibri"/>
               </a:rPr>
-              <a:t>07  ·  TRUST</a:t>
+              <a:t>07  ·  HONESTY</a:t>
             </a:r>
           </a:p>
         </p:txBody>
@@ -9923,7 +9962,7 @@
         </p:nvSpPr>
         <p:spPr>
           <a:xfrm>
-            <a:off x="640080" y="822960"/>
+            <a:off x="640080" y="777240"/>
             <a:ext cx="10972800" cy="640080"/>
           </a:xfrm>
           <a:prstGeom prst="rect">
@@ -9946,7 +9985,7 @@
               </a:spcAft>
             </a:pPr>
             <a:r>
-              <a:rPr sz="3600" b="1">
+              <a:rPr sz="2800" b="1">
                 <a:solidFill>
                   <a:srgbClr val="141C24"/>
                 </a:solidFill>
@@ -9967,8 +10006,8 @@
         </p:nvSpPr>
         <p:spPr>
           <a:xfrm>
-            <a:off x="640080" y="1600200"/>
-            <a:ext cx="5349240" cy="1188720"/>
+            <a:off x="640080" y="1554480"/>
+            <a:ext cx="5349240" cy="1280160"/>
           </a:xfrm>
           <a:prstGeom prst="rect">
             <a:avLst/>
@@ -10010,8 +10049,8 @@
         </p:nvSpPr>
         <p:spPr>
           <a:xfrm>
-            <a:off x="640080" y="1600200"/>
-            <a:ext cx="73152" cy="1188720"/>
+            <a:off x="640080" y="1554480"/>
+            <a:ext cx="73152" cy="1280160"/>
           </a:xfrm>
           <a:prstGeom prst="rect">
             <a:avLst/>
@@ -10053,8 +10092,8 @@
         </p:nvSpPr>
         <p:spPr>
           <a:xfrm>
-            <a:off x="640080" y="1600200"/>
-            <a:ext cx="5349240" cy="1188720"/>
+            <a:off x="640080" y="1554480"/>
+            <a:ext cx="5349240" cy="1280160"/>
           </a:xfrm>
           <a:prstGeom prst="rect">
             <a:avLst/>
@@ -10096,8 +10135,8 @@
         </p:nvSpPr>
         <p:spPr>
           <a:xfrm>
-            <a:off x="896112" y="1801368"/>
-            <a:ext cx="4983480" cy="365760"/>
+            <a:off x="841248" y="1719072"/>
+            <a:ext cx="4946904" cy="502920"/>
           </a:xfrm>
           <a:prstGeom prst="rect">
             <a:avLst/>
@@ -10105,9 +10144,7 @@
           <a:noFill/>
         </p:spPr>
         <p:txBody>
-          <a:bodyPr wrap="square">
-            <a:spAutoFit/>
-          </a:bodyPr>
+          <a:bodyPr wrap="square"/>
           <a:lstStyle/>
           <a:p>
             <a:pPr algn="l">
@@ -10119,7 +10156,7 @@
               </a:spcAft>
             </a:pPr>
             <a:r>
-              <a:rPr sz="1600" b="1">
+              <a:rPr sz="1400" b="1">
                 <a:solidFill>
                   <a:srgbClr val="141C24"/>
                 </a:solidFill>
@@ -10140,8 +10177,8 @@
         </p:nvSpPr>
         <p:spPr>
           <a:xfrm>
-            <a:off x="896112" y="2194560"/>
-            <a:ext cx="4983480" cy="411480"/>
+            <a:off x="841248" y="2295144"/>
+            <a:ext cx="4946904" cy="393192"/>
           </a:xfrm>
           <a:prstGeom prst="rect">
             <a:avLst/>
@@ -10159,11 +10196,11 @@
                 <a:spcPts val="0"/>
               </a:spcBef>
               <a:spcAft>
-                <a:spcPts val="0"/>
+                <a:spcPts val="400"/>
               </a:spcAft>
             </a:pPr>
             <a:r>
-              <a:rPr sz="1400" b="0">
+              <a:rPr sz="1200" b="0">
                 <a:solidFill>
                   <a:srgbClr val="4A5766"/>
                 </a:solidFill>
@@ -10184,8 +10221,8 @@
         </p:nvSpPr>
         <p:spPr>
           <a:xfrm>
-            <a:off x="6172200" y="1600200"/>
-            <a:ext cx="5349240" cy="1188720"/>
+            <a:off x="6172200" y="1554480"/>
+            <a:ext cx="5349240" cy="1280160"/>
           </a:xfrm>
           <a:prstGeom prst="rect">
             <a:avLst/>
@@ -10227,8 +10264,8 @@
         </p:nvSpPr>
         <p:spPr>
           <a:xfrm>
-            <a:off x="6172200" y="1600200"/>
-            <a:ext cx="73152" cy="1188720"/>
+            <a:off x="6172200" y="1554480"/>
+            <a:ext cx="73152" cy="1280160"/>
           </a:xfrm>
           <a:prstGeom prst="rect">
             <a:avLst/>
@@ -10270,8 +10307,8 @@
         </p:nvSpPr>
         <p:spPr>
           <a:xfrm>
-            <a:off x="6172200" y="1600200"/>
-            <a:ext cx="5349240" cy="1188720"/>
+            <a:off x="6172200" y="1554480"/>
+            <a:ext cx="5349240" cy="1280160"/>
           </a:xfrm>
           <a:prstGeom prst="rect">
             <a:avLst/>
@@ -10313,8 +10350,8 @@
         </p:nvSpPr>
         <p:spPr>
           <a:xfrm>
-            <a:off x="6428232" y="1801368"/>
-            <a:ext cx="4983480" cy="365760"/>
+            <a:off x="6373368" y="1719072"/>
+            <a:ext cx="4946904" cy="502920"/>
           </a:xfrm>
           <a:prstGeom prst="rect">
             <a:avLst/>
@@ -10322,9 +10359,7 @@
           <a:noFill/>
         </p:spPr>
         <p:txBody>
-          <a:bodyPr wrap="square">
-            <a:spAutoFit/>
-          </a:bodyPr>
+          <a:bodyPr wrap="square"/>
           <a:lstStyle/>
           <a:p>
             <a:pPr algn="l">
@@ -10336,7 +10371,7 @@
               </a:spcAft>
             </a:pPr>
             <a:r>
-              <a:rPr sz="1600" b="1">
+              <a:rPr sz="1400" b="1">
                 <a:solidFill>
                   <a:srgbClr val="141C24"/>
                 </a:solidFill>
@@ -10357,8 +10392,8 @@
         </p:nvSpPr>
         <p:spPr>
           <a:xfrm>
-            <a:off x="6428232" y="2194560"/>
-            <a:ext cx="4983480" cy="411480"/>
+            <a:off x="6373368" y="2295144"/>
+            <a:ext cx="4946904" cy="393192"/>
           </a:xfrm>
           <a:prstGeom prst="rect">
             <a:avLst/>
@@ -10376,11 +10411,11 @@
                 <a:spcPts val="0"/>
               </a:spcBef>
               <a:spcAft>
-                <a:spcPts val="0"/>
+                <a:spcPts val="400"/>
               </a:spcAft>
             </a:pPr>
             <a:r>
-              <a:rPr sz="1400" b="0">
+              <a:rPr sz="1200" b="0">
                 <a:solidFill>
                   <a:srgbClr val="4A5766"/>
                 </a:solidFill>
@@ -10401,8 +10436,8 @@
         </p:nvSpPr>
         <p:spPr>
           <a:xfrm>
-            <a:off x="640080" y="2926080"/>
-            <a:ext cx="5349240" cy="1188720"/>
+            <a:off x="640080" y="2971800"/>
+            <a:ext cx="5349240" cy="1280160"/>
           </a:xfrm>
           <a:prstGeom prst="rect">
             <a:avLst/>
@@ -10444,8 +10479,8 @@
         </p:nvSpPr>
         <p:spPr>
           <a:xfrm>
-            <a:off x="640080" y="2926080"/>
-            <a:ext cx="73152" cy="1188720"/>
+            <a:off x="640080" y="2971800"/>
+            <a:ext cx="73152" cy="1280160"/>
           </a:xfrm>
           <a:prstGeom prst="rect">
             <a:avLst/>
@@ -10487,8 +10522,8 @@
         </p:nvSpPr>
         <p:spPr>
           <a:xfrm>
-            <a:off x="640080" y="2926080"/>
-            <a:ext cx="5349240" cy="1188720"/>
+            <a:off x="640080" y="2971800"/>
+            <a:ext cx="5349240" cy="1280160"/>
           </a:xfrm>
           <a:prstGeom prst="rect">
             <a:avLst/>
@@ -10530,8 +10565,8 @@
         </p:nvSpPr>
         <p:spPr>
           <a:xfrm>
-            <a:off x="896112" y="3127248"/>
-            <a:ext cx="4983480" cy="365760"/>
+            <a:off x="841248" y="3136392"/>
+            <a:ext cx="4946904" cy="502920"/>
           </a:xfrm>
           <a:prstGeom prst="rect">
             <a:avLst/>
@@ -10539,9 +10574,7 @@
           <a:noFill/>
         </p:spPr>
         <p:txBody>
-          <a:bodyPr wrap="square">
-            <a:spAutoFit/>
-          </a:bodyPr>
+          <a:bodyPr wrap="square"/>
           <a:lstStyle/>
           <a:p>
             <a:pPr algn="l">
@@ -10553,7 +10586,7 @@
               </a:spcAft>
             </a:pPr>
             <a:r>
-              <a:rPr sz="1600" b="1">
+              <a:rPr sz="1400" b="1">
                 <a:solidFill>
                   <a:srgbClr val="141C24"/>
                 </a:solidFill>
@@ -10574,8 +10607,8 @@
         </p:nvSpPr>
         <p:spPr>
           <a:xfrm>
-            <a:off x="896112" y="3520440"/>
-            <a:ext cx="4983480" cy="411480"/>
+            <a:off x="841248" y="3712464"/>
+            <a:ext cx="4946904" cy="393192"/>
           </a:xfrm>
           <a:prstGeom prst="rect">
             <a:avLst/>
@@ -10593,11 +10626,11 @@
                 <a:spcPts val="0"/>
               </a:spcBef>
               <a:spcAft>
-                <a:spcPts val="0"/>
+                <a:spcPts val="400"/>
               </a:spcAft>
             </a:pPr>
             <a:r>
-              <a:rPr sz="1400" b="0">
+              <a:rPr sz="1200" b="0">
                 <a:solidFill>
                   <a:srgbClr val="4A5766"/>
                 </a:solidFill>
@@ -10618,8 +10651,8 @@
         </p:nvSpPr>
         <p:spPr>
           <a:xfrm>
-            <a:off x="6172200" y="2926080"/>
-            <a:ext cx="5349240" cy="1188720"/>
+            <a:off x="6172200" y="2971800"/>
+            <a:ext cx="5349240" cy="1280160"/>
           </a:xfrm>
           <a:prstGeom prst="rect">
             <a:avLst/>
@@ -10661,8 +10694,8 @@
         </p:nvSpPr>
         <p:spPr>
           <a:xfrm>
-            <a:off x="6172200" y="2926080"/>
-            <a:ext cx="73152" cy="1188720"/>
+            <a:off x="6172200" y="2971800"/>
+            <a:ext cx="73152" cy="1280160"/>
           </a:xfrm>
           <a:prstGeom prst="rect">
             <a:avLst/>
@@ -10704,8 +10737,8 @@
         </p:nvSpPr>
         <p:spPr>
           <a:xfrm>
-            <a:off x="6172200" y="2926080"/>
-            <a:ext cx="5349240" cy="1188720"/>
+            <a:off x="6172200" y="2971800"/>
+            <a:ext cx="5349240" cy="1280160"/>
           </a:xfrm>
           <a:prstGeom prst="rect">
             <a:avLst/>
@@ -10747,8 +10780,8 @@
         </p:nvSpPr>
         <p:spPr>
           <a:xfrm>
-            <a:off x="6428232" y="3127248"/>
-            <a:ext cx="4983480" cy="365760"/>
+            <a:off x="6373368" y="3136392"/>
+            <a:ext cx="4946904" cy="502920"/>
           </a:xfrm>
           <a:prstGeom prst="rect">
             <a:avLst/>
@@ -10756,9 +10789,7 @@
           <a:noFill/>
         </p:spPr>
         <p:txBody>
-          <a:bodyPr wrap="square">
-            <a:spAutoFit/>
-          </a:bodyPr>
+          <a:bodyPr wrap="square"/>
           <a:lstStyle/>
           <a:p>
             <a:pPr algn="l">
@@ -10770,7 +10801,7 @@
               </a:spcAft>
             </a:pPr>
             <a:r>
-              <a:rPr sz="1600" b="1">
+              <a:rPr sz="1400" b="1">
                 <a:solidFill>
                   <a:srgbClr val="141C24"/>
                 </a:solidFill>
@@ -10791,8 +10822,8 @@
         </p:nvSpPr>
         <p:spPr>
           <a:xfrm>
-            <a:off x="6428232" y="3520440"/>
-            <a:ext cx="4983480" cy="411480"/>
+            <a:off x="6373368" y="3712464"/>
+            <a:ext cx="4946904" cy="393192"/>
           </a:xfrm>
           <a:prstGeom prst="rect">
             <a:avLst/>
@@ -10810,11 +10841,11 @@
                 <a:spcPts val="0"/>
               </a:spcBef>
               <a:spcAft>
-                <a:spcPts val="0"/>
+                <a:spcPts val="400"/>
               </a:spcAft>
             </a:pPr>
             <a:r>
-              <a:rPr sz="1400" b="0">
+              <a:rPr sz="1200" b="0">
                 <a:solidFill>
                   <a:srgbClr val="4A5766"/>
                 </a:solidFill>
@@ -10822,7 +10853,7 @@
                 <a:ea typeface="Calibri"/>
                 <a:cs typeface="Calibri"/>
               </a:rPr>
-              <a:t>Scenario math on demo seed (exclusion × waste applicability) — not a universal SLA.</a:t>
+              <a:t>Scenario math on the demo seed — not a universal SLA.</a:t>
             </a:r>
           </a:p>
         </p:txBody>
@@ -10835,8 +10866,8 @@
         </p:nvSpPr>
         <p:spPr>
           <a:xfrm>
-            <a:off x="640080" y="4251960"/>
-            <a:ext cx="5349240" cy="1188720"/>
+            <a:off x="640080" y="4389120"/>
+            <a:ext cx="5349240" cy="1280160"/>
           </a:xfrm>
           <a:prstGeom prst="rect">
             <a:avLst/>
@@ -10878,8 +10909,8 @@
         </p:nvSpPr>
         <p:spPr>
           <a:xfrm>
-            <a:off x="640080" y="4251960"/>
-            <a:ext cx="73152" cy="1188720"/>
+            <a:off x="640080" y="4389120"/>
+            <a:ext cx="73152" cy="1280160"/>
           </a:xfrm>
           <a:prstGeom prst="rect">
             <a:avLst/>
@@ -10921,8 +10952,8 @@
         </p:nvSpPr>
         <p:spPr>
           <a:xfrm>
-            <a:off x="640080" y="4251960"/>
-            <a:ext cx="5349240" cy="1188720"/>
+            <a:off x="640080" y="4389120"/>
+            <a:ext cx="5349240" cy="1280160"/>
           </a:xfrm>
           <a:prstGeom prst="rect">
             <a:avLst/>
@@ -10964,8 +10995,8 @@
         </p:nvSpPr>
         <p:spPr>
           <a:xfrm>
-            <a:off x="896112" y="4453128"/>
-            <a:ext cx="4983480" cy="365760"/>
+            <a:off x="841248" y="4553712"/>
+            <a:ext cx="4946904" cy="502920"/>
           </a:xfrm>
           <a:prstGeom prst="rect">
             <a:avLst/>
@@ -10973,9 +11004,7 @@
           <a:noFill/>
         </p:spPr>
         <p:txBody>
-          <a:bodyPr wrap="square">
-            <a:spAutoFit/>
-          </a:bodyPr>
+          <a:bodyPr wrap="square"/>
           <a:lstStyle/>
           <a:p>
             <a:pPr algn="l">
@@ -10987,7 +11016,7 @@
               </a:spcAft>
             </a:pPr>
             <a:r>
-              <a:rPr sz="1600" b="1">
+              <a:rPr sz="1400" b="1">
                 <a:solidFill>
                   <a:srgbClr val="141C24"/>
                 </a:solidFill>
@@ -11008,8 +11037,8 @@
         </p:nvSpPr>
         <p:spPr>
           <a:xfrm>
-            <a:off x="896112" y="4846320"/>
-            <a:ext cx="4983480" cy="411480"/>
+            <a:off x="841248" y="5129784"/>
+            <a:ext cx="4946904" cy="393192"/>
           </a:xfrm>
           <a:prstGeom prst="rect">
             <a:avLst/>
@@ -11027,11 +11056,11 @@
                 <a:spcPts val="0"/>
               </a:spcBef>
               <a:spcAft>
-                <a:spcPts val="0"/>
+                <a:spcPts val="400"/>
               </a:spcAft>
             </a:pPr>
             <a:r>
-              <a:rPr sz="1400" b="0">
+              <a:rPr sz="1200" b="0">
                 <a:solidFill>
                   <a:srgbClr val="4A5766"/>
                 </a:solidFill>
@@ -11039,7 +11068,7 @@
                 <a:ea typeface="Calibri"/>
                 <a:cs typeface="Calibri"/>
               </a:rPr>
-              <a:t>Demo / file metrics today. Live vendor billing sync is next — not this demo.</a:t>
+              <a:t>Demo / file metrics today. Live billing sync is next.</a:t>
             </a:r>
           </a:p>
         </p:txBody>
@@ -11052,8 +11081,8 @@
         </p:nvSpPr>
         <p:spPr>
           <a:xfrm>
-            <a:off x="6172200" y="4251960"/>
-            <a:ext cx="5349240" cy="1188720"/>
+            <a:off x="6172200" y="4389120"/>
+            <a:ext cx="5349240" cy="1280160"/>
           </a:xfrm>
           <a:prstGeom prst="rect">
             <a:avLst/>
@@ -11095,8 +11124,8 @@
         </p:nvSpPr>
         <p:spPr>
           <a:xfrm>
-            <a:off x="6172200" y="4251960"/>
-            <a:ext cx="73152" cy="1188720"/>
+            <a:off x="6172200" y="4389120"/>
+            <a:ext cx="73152" cy="1280160"/>
           </a:xfrm>
           <a:prstGeom prst="rect">
             <a:avLst/>
@@ -11138,8 +11167,8 @@
         </p:nvSpPr>
         <p:spPr>
           <a:xfrm>
-            <a:off x="6172200" y="4251960"/>
-            <a:ext cx="5349240" cy="1188720"/>
+            <a:off x="6172200" y="4389120"/>
+            <a:ext cx="5349240" cy="1280160"/>
           </a:xfrm>
           <a:prstGeom prst="rect">
             <a:avLst/>
@@ -11181,8 +11210,8 @@
         </p:nvSpPr>
         <p:spPr>
           <a:xfrm>
-            <a:off x="6428232" y="4453128"/>
-            <a:ext cx="4983480" cy="365760"/>
+            <a:off x="6373368" y="4553712"/>
+            <a:ext cx="4946904" cy="502920"/>
           </a:xfrm>
           <a:prstGeom prst="rect">
             <a:avLst/>
@@ -11190,9 +11219,7 @@
           <a:noFill/>
         </p:spPr>
         <p:txBody>
-          <a:bodyPr wrap="square">
-            <a:spAutoFit/>
-          </a:bodyPr>
+          <a:bodyPr wrap="square"/>
           <a:lstStyle/>
           <a:p>
             <a:pPr algn="l">
@@ -11204,7 +11231,7 @@
               </a:spcAft>
             </a:pPr>
             <a:r>
-              <a:rPr sz="1600" b="1">
+              <a:rPr sz="1400" b="1">
                 <a:solidFill>
                   <a:srgbClr val="141C24"/>
                 </a:solidFill>
@@ -11225,8 +11252,8 @@
         </p:nvSpPr>
         <p:spPr>
           <a:xfrm>
-            <a:off x="6428232" y="4846320"/>
-            <a:ext cx="4983480" cy="411480"/>
+            <a:off x="6373368" y="5129784"/>
+            <a:ext cx="4946904" cy="393192"/>
           </a:xfrm>
           <a:prstGeom prst="rect">
             <a:avLst/>
@@ -11244,11 +11271,11 @@
                 <a:spcPts val="0"/>
               </a:spcBef>
               <a:spcAft>
-                <a:spcPts val="0"/>
+                <a:spcPts val="400"/>
               </a:spcAft>
             </a:pPr>
             <a:r>
-              <a:rPr sz="1400" b="0">
+              <a:rPr sz="1200" b="0">
                 <a:solidFill>
                   <a:srgbClr val="4A5766"/>
                 </a:solidFill>
@@ -11256,7 +11283,7 @@
                 <a:ea typeface="Calibri"/>
                 <a:cs typeface="Calibri"/>
               </a:rPr>
-              <a:t>Chat / Agent / AI credits. Not unlimited inline completions.</a:t>
+              <a:t>Chat / Agent / AI credits — not unlimited completions.</a:t>
             </a:r>
           </a:p>
         </p:txBody>
@@ -11269,8 +11296,8 @@
         </p:nvSpPr>
         <p:spPr>
           <a:xfrm>
-            <a:off x="640080" y="6446520"/>
-            <a:ext cx="9144000" cy="274320"/>
+            <a:off x="640080" y="6492240"/>
+            <a:ext cx="10972800" cy="256032"/>
           </a:xfrm>
           <a:prstGeom prst="rect">
             <a:avLst/>
@@ -11300,7 +11327,7 @@
                 <a:ea typeface="Calibri"/>
                 <a:cs typeface="Calibri"/>
               </a:rPr>
-              <a:t>TokenForge  ·  AI Coding FinOps  ·  Confidential board brief  ·  8 / 10</a:t>
+              <a:t>TokenForge  ·  AI Coding FinOps  ·  Hackathon pitch  ·  8 / 10</a:t>
             </a:r>
           </a:p>
         </p:txBody>
@@ -11417,8 +11444,8 @@
         </p:nvSpPr>
         <p:spPr>
           <a:xfrm>
-            <a:off x="640080" y="502920"/>
-            <a:ext cx="10972800" cy="320040"/>
+            <a:off x="640080" y="457200"/>
+            <a:ext cx="10972800" cy="274320"/>
           </a:xfrm>
           <a:prstGeom prst="rect">
             <a:avLst/>
@@ -11461,7 +11488,7 @@
         </p:nvSpPr>
         <p:spPr>
           <a:xfrm>
-            <a:off x="640080" y="822960"/>
+            <a:off x="640080" y="777240"/>
             <a:ext cx="10972800" cy="640080"/>
           </a:xfrm>
           <a:prstGeom prst="rect">
@@ -11484,7 +11511,7 @@
               </a:spcAft>
             </a:pPr>
             <a:r>
-              <a:rPr sz="3600" b="1">
+              <a:rPr sz="3000" b="1">
                 <a:solidFill>
                   <a:srgbClr val="141C24"/>
                 </a:solidFill>
@@ -11634,8 +11661,8 @@
         </p:nvSpPr>
         <p:spPr>
           <a:xfrm>
-            <a:off x="896112" y="1892808"/>
-            <a:ext cx="4983480" cy="365760"/>
+            <a:off x="841248" y="1856232"/>
+            <a:ext cx="4946904" cy="502920"/>
           </a:xfrm>
           <a:prstGeom prst="rect">
             <a:avLst/>
@@ -11643,9 +11670,7 @@
           <a:noFill/>
         </p:spPr>
         <p:txBody>
-          <a:bodyPr wrap="square">
-            <a:spAutoFit/>
-          </a:bodyPr>
+          <a:bodyPr wrap="square"/>
           <a:lstStyle/>
           <a:p>
             <a:pPr algn="l">
@@ -11665,7 +11690,7 @@
                 <a:ea typeface="Calibri"/>
                 <a:cs typeface="Calibri"/>
               </a:rPr>
-              <a:t>Shipped for board demo</a:t>
+              <a:t>Shipped for the hackathon demo</a:t>
             </a:r>
           </a:p>
         </p:txBody>
@@ -11678,8 +11703,8 @@
         </p:nvSpPr>
         <p:spPr>
           <a:xfrm>
-            <a:off x="896112" y="2286000"/>
-            <a:ext cx="4983480" cy="2697480"/>
+            <a:off x="841248" y="2432304"/>
+            <a:ext cx="4946904" cy="2587752"/>
           </a:xfrm>
           <a:prstGeom prst="rect">
             <a:avLst/>
@@ -11697,11 +11722,11 @@
                 <a:spcPts val="0"/>
               </a:spcBef>
               <a:spcAft>
-                <a:spcPts val="0"/>
+                <a:spcPts val="400"/>
               </a:spcAft>
             </a:pPr>
             <a:r>
-              <a:rPr sz="1400" b="0">
+              <a:rPr sz="1500" b="0">
                 <a:solidFill>
                   <a:srgbClr val="4A5766"/>
                 </a:solidFill>
@@ -11709,7 +11734,70 @@
                 <a:ea typeface="Calibri"/>
                 <a:cs typeface="Calibri"/>
               </a:rPr>
-              <a:t>Per-team + global Prove · architecture tags · usage import · org-pack · Cursor/Claude adapters · advisory levers (do not lead).</a:t>
+              <a:t>Per-team + global Prove</a:t>
+            </a:r>
+          </a:p>
+          <a:p>
+            <a:pPr algn="l">
+              <a:spcBef>
+                <a:spcPts val="0"/>
+              </a:spcBef>
+              <a:spcAft>
+                <a:spcPts val="400"/>
+              </a:spcAft>
+            </a:pPr>
+            <a:r>
+              <a:rPr sz="1500" b="0">
+                <a:solidFill>
+                  <a:srgbClr val="4A5766"/>
+                </a:solidFill>
+                <a:latin typeface="Calibri"/>
+                <a:ea typeface="Calibri"/>
+                <a:cs typeface="Calibri"/>
+              </a:rPr>
+              <a:t>Architecture tags + usage import</a:t>
+            </a:r>
+          </a:p>
+          <a:p>
+            <a:pPr algn="l">
+              <a:spcBef>
+                <a:spcPts val="0"/>
+              </a:spcBef>
+              <a:spcAft>
+                <a:spcPts val="400"/>
+              </a:spcAft>
+            </a:pPr>
+            <a:r>
+              <a:rPr sz="1500" b="0">
+                <a:solidFill>
+                  <a:srgbClr val="4A5766"/>
+                </a:solidFill>
+                <a:latin typeface="Calibri"/>
+                <a:ea typeface="Calibri"/>
+                <a:cs typeface="Calibri"/>
+              </a:rPr>
+              <a:t>Org-pack + Cursor/Claude adapters</a:t>
+            </a:r>
+          </a:p>
+          <a:p>
+            <a:pPr algn="l">
+              <a:spcBef>
+                <a:spcPts val="0"/>
+              </a:spcBef>
+              <a:spcAft>
+                <a:spcPts val="400"/>
+              </a:spcAft>
+            </a:pPr>
+            <a:r>
+              <a:rPr sz="1500" b="0">
+                <a:solidFill>
+                  <a:srgbClr val="4A5766"/>
+                </a:solidFill>
+                <a:latin typeface="Calibri"/>
+                <a:ea typeface="Calibri"/>
+                <a:cs typeface="Calibri"/>
+              </a:rPr>
+              <a:t>Advisory levers (do not lead the pitch)</a:t>
             </a:r>
           </a:p>
         </p:txBody>
@@ -11851,8 +11939,8 @@
         </p:nvSpPr>
         <p:spPr>
           <a:xfrm>
-            <a:off x="6565392" y="1892808"/>
-            <a:ext cx="4983480" cy="365760"/>
+            <a:off x="6510528" y="1856232"/>
+            <a:ext cx="4946904" cy="502920"/>
           </a:xfrm>
           <a:prstGeom prst="rect">
             <a:avLst/>
@@ -11860,9 +11948,7 @@
           <a:noFill/>
         </p:spPr>
         <p:txBody>
-          <a:bodyPr wrap="square">
-            <a:spAutoFit/>
-          </a:bodyPr>
+          <a:bodyPr wrap="square"/>
           <a:lstStyle/>
           <a:p>
             <a:pPr algn="l">
@@ -11882,7 +11968,7 @@
                 <a:ea typeface="Calibri"/>
                 <a:cs typeface="Calibri"/>
               </a:rPr>
-              <a:t>Next proof for a BU pilot</a:t>
+              <a:t>Next if we keep building</a:t>
             </a:r>
           </a:p>
         </p:txBody>
@@ -11895,8 +11981,8 @@
         </p:nvSpPr>
         <p:spPr>
           <a:xfrm>
-            <a:off x="6565392" y="2286000"/>
-            <a:ext cx="4983480" cy="2697480"/>
+            <a:off x="6510528" y="2432304"/>
+            <a:ext cx="4946904" cy="2587752"/>
           </a:xfrm>
           <a:prstGeom prst="rect">
             <a:avLst/>
@@ -11914,11 +12000,11 @@
                 <a:spcPts val="0"/>
               </a:spcBef>
               <a:spcAft>
-                <a:spcPts val="0"/>
+                <a:spcPts val="400"/>
               </a:spcAft>
             </a:pPr>
             <a:r>
-              <a:rPr sz="1400" b="0">
+              <a:rPr sz="1500" b="0">
                 <a:solidFill>
                   <a:srgbClr val="4A5766"/>
                 </a:solidFill>
@@ -11926,43 +12012,20 @@
                 <a:ea typeface="Calibri"/>
                 <a:cs typeface="Calibri"/>
               </a:rPr>
-              <a:t>Live billing sync per provider · remote org exclusion apply APIs · keep Detect → Fix → Prove as the spine.</a:t>
-            </a:r>
-          </a:p>
-        </p:txBody>
-      </p:sp>
-      <p:sp>
-        <p:nvSpPr>
-          <p:cNvPr id="16" name="TextBox 15"/>
-          <p:cNvSpPr txBox="1"/>
-          <p:nvPr/>
-        </p:nvSpPr>
-        <p:spPr>
-          <a:xfrm>
-            <a:off x="640080" y="6446520"/>
-            <a:ext cx="9144000" cy="274320"/>
-          </a:xfrm>
-          <a:prstGeom prst="rect">
-            <a:avLst/>
-          </a:prstGeom>
-          <a:noFill/>
-        </p:spPr>
-        <p:txBody>
-          <a:bodyPr wrap="square">
-            <a:spAutoFit/>
-          </a:bodyPr>
-          <a:lstStyle/>
+              <a:t>Live billing sync per provider</a:t>
+            </a:r>
+          </a:p>
           <a:p>
             <a:pPr algn="l">
               <a:spcBef>
                 <a:spcPts val="0"/>
               </a:spcBef>
               <a:spcAft>
-                <a:spcPts val="0"/>
+                <a:spcPts val="400"/>
               </a:spcAft>
             </a:pPr>
             <a:r>
-              <a:rPr sz="1100" b="0">
+              <a:rPr sz="1500" b="0">
                 <a:solidFill>
                   <a:srgbClr val="4A5766"/>
                 </a:solidFill>
@@ -11970,7 +12033,72 @@
                 <a:ea typeface="Calibri"/>
                 <a:cs typeface="Calibri"/>
               </a:rPr>
-              <a:t>TokenForge  ·  AI Coding FinOps  ·  Confidential board brief  ·  9 / 10</a:t>
+              <a:t>Remote org exclusion apply APIs</a:t>
+            </a:r>
+          </a:p>
+          <a:p>
+            <a:pPr algn="l">
+              <a:spcBef>
+                <a:spcPts val="0"/>
+              </a:spcBef>
+              <a:spcAft>
+                <a:spcPts val="400"/>
+              </a:spcAft>
+            </a:pPr>
+            <a:r>
+              <a:rPr sz="1500" b="0">
+                <a:solidFill>
+                  <a:srgbClr val="4A5766"/>
+                </a:solidFill>
+                <a:latin typeface="Calibri"/>
+                <a:ea typeface="Calibri"/>
+                <a:cs typeface="Calibri"/>
+              </a:rPr>
+              <a:t>Keep Detect → Fix → Prove as the spine</a:t>
+            </a:r>
+          </a:p>
+        </p:txBody>
+      </p:sp>
+      <p:sp>
+        <p:nvSpPr>
+          <p:cNvPr id="16" name="TextBox 15"/>
+          <p:cNvSpPr txBox="1"/>
+          <p:nvPr/>
+        </p:nvSpPr>
+        <p:spPr>
+          <a:xfrm>
+            <a:off x="640080" y="6492240"/>
+            <a:ext cx="10972800" cy="256032"/>
+          </a:xfrm>
+          <a:prstGeom prst="rect">
+            <a:avLst/>
+          </a:prstGeom>
+          <a:noFill/>
+        </p:spPr>
+        <p:txBody>
+          <a:bodyPr wrap="square">
+            <a:spAutoFit/>
+          </a:bodyPr>
+          <a:lstStyle/>
+          <a:p>
+            <a:pPr algn="l">
+              <a:spcBef>
+                <a:spcPts val="0"/>
+              </a:spcBef>
+              <a:spcAft>
+                <a:spcPts val="0"/>
+              </a:spcAft>
+            </a:pPr>
+            <a:r>
+              <a:rPr sz="1100" b="0">
+                <a:solidFill>
+                  <a:srgbClr val="4A5766"/>
+                </a:solidFill>
+                <a:latin typeface="Calibri"/>
+                <a:ea typeface="Calibri"/>
+                <a:cs typeface="Calibri"/>
+              </a:rPr>
+              <a:t>TokenForge  ·  AI Coding FinOps  ·  Hackathon pitch  ·  9 / 10</a:t>
             </a:r>
           </a:p>
         </p:txBody>

</xml_diff>

<commit_message>
docs: refresh FAQ and pitch deck for Wave C honesty
Record Waves A–C as shipped and point roadmap at Parallel org-apply work.

Co-authored-by: Cursor <cursoragent@cursor.com>
</commit_message>
<xml_diff>
--- a/docs/pitch/TokenForge-Pitch.pptx
+++ b/docs/pitch/TokenForge-Pitch.pptx
@@ -11024,7 +11024,7 @@
                 <a:ea typeface="Calibri"/>
                 <a:cs typeface="Calibri"/>
               </a:rPr>
-              <a:t>Usage import</a:t>
+              <a:t>Usage</a:t>
             </a:r>
           </a:p>
         </p:txBody>
@@ -11068,7 +11068,7 @@
                 <a:ea typeface="Calibri"/>
                 <a:cs typeface="Calibri"/>
               </a:rPr>
-              <a:t>Demo / file metrics today. Live billing sync is next.</a:t>
+              <a:t>Import or live sync into UsageMetrics. Estimate vs bill + cohort note.</a:t>
             </a:r>
           </a:p>
         </p:txBody>
@@ -11726,7 +11726,7 @@
               </a:spcAft>
             </a:pPr>
             <a:r>
-              <a:rPr sz="1500" b="0">
+              <a:rPr sz="1400" b="0">
                 <a:solidFill>
                   <a:srgbClr val="4A5766"/>
                 </a:solidFill>
@@ -11747,7 +11747,7 @@
               </a:spcAft>
             </a:pPr>
             <a:r>
-              <a:rPr sz="1500" b="0">
+              <a:rPr sz="1400" b="0">
                 <a:solidFill>
                   <a:srgbClr val="4A5766"/>
                 </a:solidFill>
@@ -11755,7 +11755,7 @@
                 <a:ea typeface="Calibri"/>
                 <a:cs typeface="Calibri"/>
               </a:rPr>
-              <a:t>Architecture tags + usage import</a:t>
+              <a:t>Architecture tags + usage import/sync</a:t>
             </a:r>
           </a:p>
           <a:p>
@@ -11768,7 +11768,28 @@
               </a:spcAft>
             </a:pPr>
             <a:r>
-              <a:rPr sz="1500" b="0">
+              <a:rPr sz="1400" b="0">
+                <a:solidFill>
+                  <a:srgbClr val="4A5766"/>
+                </a:solidFill>
+                <a:latin typeface="Calibri"/>
+                <a:ea typeface="Calibri"/>
+                <a:cs typeface="Calibri"/>
+              </a:rPr>
+              <a:t>Variance board + change markers + cohort</a:t>
+            </a:r>
+          </a:p>
+          <a:p>
+            <a:pPr algn="l">
+              <a:spcBef>
+                <a:spcPts val="0"/>
+              </a:spcBef>
+              <a:spcAft>
+                <a:spcPts val="400"/>
+              </a:spcAft>
+            </a:pPr>
+            <a:r>
+              <a:rPr sz="1400" b="0">
                 <a:solidFill>
                   <a:srgbClr val="4A5766"/>
                 </a:solidFill>
@@ -11789,7 +11810,7 @@
               </a:spcAft>
             </a:pPr>
             <a:r>
-              <a:rPr sz="1500" b="0">
+              <a:rPr sz="1400" b="0">
                 <a:solidFill>
                   <a:srgbClr val="4A5766"/>
                 </a:solidFill>
@@ -12012,7 +12033,7 @@
                 <a:ea typeface="Calibri"/>
                 <a:cs typeface="Calibri"/>
               </a:rPr>
-              <a:t>Live billing sync per provider</a:t>
+              <a:t>Remote org exclusion apply APIs</a:t>
             </a:r>
           </a:p>
           <a:p>
@@ -12033,7 +12054,7 @@
                 <a:ea typeface="Calibri"/>
                 <a:cs typeface="Calibri"/>
               </a:rPr>
-              <a:t>Remote org exclusion apply APIs</a:t>
+              <a:t>Org pilot pack (scan → apply → prove)</a:t>
             </a:r>
           </a:p>
           <a:p>

</xml_diff>

<commit_message>
Refresh pitch deck for competition, uniqueness, and architecture slides.
Adds demo hybrid scan JSON for dashboard LLM boards and updates the deck generator accordingly.

Co-authored-by: Cursor <cursoragent@cursor.com>
</commit_message>
<xml_diff>
--- a/docs/pitch/TokenForge-Pitch.pptx
+++ b/docs/pitch/TokenForge-Pitch.pptx
@@ -12,9 +12,10 @@
     <p:sldId id="260" r:id="rId11"/>
     <p:sldId id="261" r:id="rId12"/>
     <p:sldId id="262" r:id="rId13"/>
-    <p:sldId id="263" r:id="rId14"/>
-    <p:sldId id="264" r:id="rId15"/>
-    <p:sldId id="265" r:id="rId16"/>
+    <p:sldId id="263" r:id="rId15"/>
+    <p:sldId id="264" r:id="rId16"/>
+    <p:sldId id="265" r:id="rId17"/>
+    <p:sldId id="266" r:id="rId18"/>
   </p:sldIdLst>
   <p:sldSz cx="12191695" cy="6858000" type="screen4x3"/>
   <p:notesSz cx="6858000" cy="9144000"/>
@@ -114,6 +115,441 @@
     </a:lvl9pPr>
   </p:defaultTextStyle>
 </p:presentation>
+</file>
+
+<file path=ppt/notesMasters/notesMaster1.xml><?xml version="1.0" encoding="utf-8"?>
+<p:notesMaster xmlns:a="http://schemas.openxmlformats.org/drawingml/2006/main" xmlns:p="http://schemas.openxmlformats.org/presentationml/2006/main" xmlns:r="http://schemas.openxmlformats.org/officeDocument/2006/relationships">
+  <p:cSld>
+    <p:bg>
+      <p:bgRef idx="1001">
+        <a:schemeClr val="bg1"/>
+      </p:bgRef>
+    </p:bg>
+    <p:spTree>
+      <p:nvGrpSpPr>
+        <p:cNvPr id="1" name=""/>
+        <p:cNvGrpSpPr/>
+        <p:nvPr/>
+      </p:nvGrpSpPr>
+      <p:grpSpPr>
+        <a:xfrm>
+          <a:off x="0" y="0"/>
+          <a:ext cx="0" cy="0"/>
+          <a:chOff x="0" y="0"/>
+          <a:chExt cx="0" cy="0"/>
+        </a:xfrm>
+      </p:grpSpPr>
+      <p:sp>
+        <p:nvSpPr>
+          <p:cNvPr id="2" name="Header Placeholder 1"/>
+          <p:cNvSpPr>
+            <a:spLocks noGrp="1"/>
+          </p:cNvSpPr>
+          <p:nvPr>
+            <p:ph type="hdr" sz="quarter"/>
+          </p:nvPr>
+        </p:nvSpPr>
+        <p:spPr>
+          <a:xfrm>
+            <a:off x="0" y="0"/>
+            <a:ext cx="2971800" cy="457200"/>
+          </a:xfrm>
+          <a:prstGeom prst="rect">
+            <a:avLst/>
+          </a:prstGeom>
+        </p:spPr>
+        <p:txBody>
+          <a:bodyPr vert="horz" lIns="91440" tIns="45720" rIns="91440" bIns="45720" rtlCol="0"/>
+          <a:lstStyle>
+            <a:lvl1pPr algn="l">
+              <a:defRPr sz="1200"/>
+            </a:lvl1pPr>
+          </a:lstStyle>
+          <a:p>
+            <a:endParaRPr lang="en-US"/>
+          </a:p>
+        </p:txBody>
+      </p:sp>
+      <p:sp>
+        <p:nvSpPr>
+          <p:cNvPr id="3" name="Date Placeholder 2"/>
+          <p:cNvSpPr>
+            <a:spLocks noGrp="1"/>
+          </p:cNvSpPr>
+          <p:nvPr>
+            <p:ph type="dt" idx="1"/>
+          </p:nvPr>
+        </p:nvSpPr>
+        <p:spPr>
+          <a:xfrm>
+            <a:off x="3884613" y="0"/>
+            <a:ext cx="2971800" cy="457200"/>
+          </a:xfrm>
+          <a:prstGeom prst="rect">
+            <a:avLst/>
+          </a:prstGeom>
+        </p:spPr>
+        <p:txBody>
+          <a:bodyPr vert="horz" lIns="91440" tIns="45720" rIns="91440" bIns="45720" rtlCol="0"/>
+          <a:lstStyle>
+            <a:lvl1pPr algn="r">
+              <a:defRPr sz="1200"/>
+            </a:lvl1pPr>
+          </a:lstStyle>
+          <a:p>
+            <a:fld id="{0F89C1C7-3DCD-1040-A9CF-14679D8B5DDD}" type="datetimeFigureOut">
+              <a:rPr lang="en-US" smtClean="0"/>
+              <a:t>10/17/16</a:t>
+            </a:fld>
+            <a:endParaRPr lang="en-US"/>
+          </a:p>
+        </p:txBody>
+      </p:sp>
+      <p:sp>
+        <p:nvSpPr>
+          <p:cNvPr id="4" name="Slide Image Placeholder 3"/>
+          <p:cNvSpPr>
+            <a:spLocks noGrp="1" noRot="1" noChangeAspect="1"/>
+          </p:cNvSpPr>
+          <p:nvPr>
+            <p:ph type="sldImg" idx="2"/>
+          </p:nvPr>
+        </p:nvSpPr>
+        <p:spPr>
+          <a:xfrm>
+            <a:off x="1143000" y="685800"/>
+            <a:ext cx="4572000" cy="3429000"/>
+          </a:xfrm>
+          <a:prstGeom prst="rect">
+            <a:avLst/>
+          </a:prstGeom>
+          <a:noFill/>
+          <a:ln w="12700">
+            <a:solidFill>
+              <a:prstClr val="black"/>
+            </a:solidFill>
+          </a:ln>
+        </p:spPr>
+        <p:txBody>
+          <a:bodyPr vert="horz" lIns="91440" tIns="45720" rIns="91440" bIns="45720" rtlCol="0" anchor="ctr"/>
+          <a:lstStyle/>
+          <a:p>
+            <a:endParaRPr lang="en-US"/>
+          </a:p>
+        </p:txBody>
+      </p:sp>
+      <p:sp>
+        <p:nvSpPr>
+          <p:cNvPr id="5" name="Notes Placeholder 4"/>
+          <p:cNvSpPr>
+            <a:spLocks noGrp="1"/>
+          </p:cNvSpPr>
+          <p:nvPr>
+            <p:ph type="body" sz="quarter" idx="3"/>
+          </p:nvPr>
+        </p:nvSpPr>
+        <p:spPr>
+          <a:xfrm>
+            <a:off x="685800" y="4343400"/>
+            <a:ext cx="5486400" cy="4114800"/>
+          </a:xfrm>
+          <a:prstGeom prst="rect">
+            <a:avLst/>
+          </a:prstGeom>
+        </p:spPr>
+        <p:txBody>
+          <a:bodyPr vert="horz" lIns="91440" tIns="45720" rIns="91440" bIns="45720" rtlCol="0"/>
+          <a:lstStyle/>
+          <a:p>
+            <a:pPr lvl="0"/>
+            <a:r>
+              <a:rPr lang="en-US" smtClean="0"/>
+              <a:t>Click to edit Master text styles</a:t>
+            </a:r>
+          </a:p>
+          <a:p>
+            <a:pPr lvl="1"/>
+            <a:r>
+              <a:rPr lang="en-US" smtClean="0"/>
+              <a:t>Second level</a:t>
+            </a:r>
+          </a:p>
+          <a:p>
+            <a:pPr lvl="2"/>
+            <a:r>
+              <a:rPr lang="en-US" smtClean="0"/>
+              <a:t>Third level</a:t>
+            </a:r>
+          </a:p>
+          <a:p>
+            <a:pPr lvl="3"/>
+            <a:r>
+              <a:rPr lang="en-US" smtClean="0"/>
+              <a:t>Fourth level</a:t>
+            </a:r>
+          </a:p>
+          <a:p>
+            <a:pPr lvl="4"/>
+            <a:r>
+              <a:rPr lang="en-US" smtClean="0"/>
+              <a:t>Fifth level</a:t>
+            </a:r>
+            <a:endParaRPr lang="en-US"/>
+          </a:p>
+        </p:txBody>
+      </p:sp>
+      <p:sp>
+        <p:nvSpPr>
+          <p:cNvPr id="6" name="Footer Placeholder 5"/>
+          <p:cNvSpPr>
+            <a:spLocks noGrp="1"/>
+          </p:cNvSpPr>
+          <p:nvPr>
+            <p:ph type="ftr" sz="quarter" idx="4"/>
+          </p:nvPr>
+        </p:nvSpPr>
+        <p:spPr>
+          <a:xfrm>
+            <a:off x="0" y="8685213"/>
+            <a:ext cx="2971800" cy="457200"/>
+          </a:xfrm>
+          <a:prstGeom prst="rect">
+            <a:avLst/>
+          </a:prstGeom>
+        </p:spPr>
+        <p:txBody>
+          <a:bodyPr vert="horz" lIns="91440" tIns="45720" rIns="91440" bIns="45720" rtlCol="0" anchor="b"/>
+          <a:lstStyle>
+            <a:lvl1pPr algn="l">
+              <a:defRPr sz="1200"/>
+            </a:lvl1pPr>
+          </a:lstStyle>
+          <a:p>
+            <a:endParaRPr lang="en-US"/>
+          </a:p>
+        </p:txBody>
+      </p:sp>
+      <p:sp>
+        <p:nvSpPr>
+          <p:cNvPr id="7" name="Slide Number Placeholder 6"/>
+          <p:cNvSpPr>
+            <a:spLocks noGrp="1"/>
+          </p:cNvSpPr>
+          <p:nvPr>
+            <p:ph type="sldNum" sz="quarter" idx="5"/>
+          </p:nvPr>
+        </p:nvSpPr>
+        <p:spPr>
+          <a:xfrm>
+            <a:off x="3884613" y="8685213"/>
+            <a:ext cx="2971800" cy="457200"/>
+          </a:xfrm>
+          <a:prstGeom prst="rect">
+            <a:avLst/>
+          </a:prstGeom>
+        </p:spPr>
+        <p:txBody>
+          <a:bodyPr vert="horz" lIns="91440" tIns="45720" rIns="91440" bIns="45720" rtlCol="0" anchor="b"/>
+          <a:lstStyle>
+            <a:lvl1pPr algn="r">
+              <a:defRPr sz="1200"/>
+            </a:lvl1pPr>
+          </a:lstStyle>
+          <a:p>
+            <a:fld id="{BB5E49A5-4136-284D-997B-48E1D791AD67}" type="slidenum">
+              <a:rPr lang="en-US" smtClean="0"/>
+              <a:t>‹#›</a:t>
+            </a:fld>
+            <a:endParaRPr lang="en-US"/>
+          </a:p>
+        </p:txBody>
+      </p:sp>
+    </p:spTree>
+    <p:extLst>
+      <p:ext uri="{BB962C8B-B14F-4D97-AF65-F5344CB8AC3E}">
+        <p14:creationId xmlns:p14="http://schemas.microsoft.com/office/powerpoint/2010/main" val="2623252185"/>
+      </p:ext>
+    </p:extLst>
+  </p:cSld>
+  <p:clrMap bg1="lt1" tx1="dk1" bg2="lt2" tx2="dk2" accent1="accent1" accent2="accent2" accent3="accent3" accent4="accent4" accent5="accent5" accent6="accent6" hlink="hlink" folHlink="folHlink"/>
+  <p:notesStyle>
+    <a:lvl1pPr marL="0" algn="l" defTabSz="457200" rtl="0" eaLnBrk="1" latinLnBrk="0" hangingPunct="1">
+      <a:defRPr sz="1200" kern="1200">
+        <a:solidFill>
+          <a:schemeClr val="tx1"/>
+        </a:solidFill>
+        <a:latin typeface="+mn-lt"/>
+        <a:ea typeface="+mn-ea"/>
+        <a:cs typeface="+mn-cs"/>
+      </a:defRPr>
+    </a:lvl1pPr>
+    <a:lvl2pPr marL="457200" algn="l" defTabSz="457200" rtl="0" eaLnBrk="1" latinLnBrk="0" hangingPunct="1">
+      <a:defRPr sz="1200" kern="1200">
+        <a:solidFill>
+          <a:schemeClr val="tx1"/>
+        </a:solidFill>
+        <a:latin typeface="+mn-lt"/>
+        <a:ea typeface="+mn-ea"/>
+        <a:cs typeface="+mn-cs"/>
+      </a:defRPr>
+    </a:lvl2pPr>
+    <a:lvl3pPr marL="914400" algn="l" defTabSz="457200" rtl="0" eaLnBrk="1" latinLnBrk="0" hangingPunct="1">
+      <a:defRPr sz="1200" kern="1200">
+        <a:solidFill>
+          <a:schemeClr val="tx1"/>
+        </a:solidFill>
+        <a:latin typeface="+mn-lt"/>
+        <a:ea typeface="+mn-ea"/>
+        <a:cs typeface="+mn-cs"/>
+      </a:defRPr>
+    </a:lvl3pPr>
+    <a:lvl4pPr marL="1371600" algn="l" defTabSz="457200" rtl="0" eaLnBrk="1" latinLnBrk="0" hangingPunct="1">
+      <a:defRPr sz="1200" kern="1200">
+        <a:solidFill>
+          <a:schemeClr val="tx1"/>
+        </a:solidFill>
+        <a:latin typeface="+mn-lt"/>
+        <a:ea typeface="+mn-ea"/>
+        <a:cs typeface="+mn-cs"/>
+      </a:defRPr>
+    </a:lvl4pPr>
+    <a:lvl5pPr marL="1828800" algn="l" defTabSz="457200" rtl="0" eaLnBrk="1" latinLnBrk="0" hangingPunct="1">
+      <a:defRPr sz="1200" kern="1200">
+        <a:solidFill>
+          <a:schemeClr val="tx1"/>
+        </a:solidFill>
+        <a:latin typeface="+mn-lt"/>
+        <a:ea typeface="+mn-ea"/>
+        <a:cs typeface="+mn-cs"/>
+      </a:defRPr>
+    </a:lvl5pPr>
+    <a:lvl6pPr marL="2286000" algn="l" defTabSz="457200" rtl="0" eaLnBrk="1" latinLnBrk="0" hangingPunct="1">
+      <a:defRPr sz="1200" kern="1200">
+        <a:solidFill>
+          <a:schemeClr val="tx1"/>
+        </a:solidFill>
+        <a:latin typeface="+mn-lt"/>
+        <a:ea typeface="+mn-ea"/>
+        <a:cs typeface="+mn-cs"/>
+      </a:defRPr>
+    </a:lvl6pPr>
+    <a:lvl7pPr marL="2743200" algn="l" defTabSz="457200" rtl="0" eaLnBrk="1" latinLnBrk="0" hangingPunct="1">
+      <a:defRPr sz="1200" kern="1200">
+        <a:solidFill>
+          <a:schemeClr val="tx1"/>
+        </a:solidFill>
+        <a:latin typeface="+mn-lt"/>
+        <a:ea typeface="+mn-ea"/>
+        <a:cs typeface="+mn-cs"/>
+      </a:defRPr>
+    </a:lvl7pPr>
+    <a:lvl8pPr marL="3200400" algn="l" defTabSz="457200" rtl="0" eaLnBrk="1" latinLnBrk="0" hangingPunct="1">
+      <a:defRPr sz="1200" kern="1200">
+        <a:solidFill>
+          <a:schemeClr val="tx1"/>
+        </a:solidFill>
+        <a:latin typeface="+mn-lt"/>
+        <a:ea typeface="+mn-ea"/>
+        <a:cs typeface="+mn-cs"/>
+      </a:defRPr>
+    </a:lvl8pPr>
+    <a:lvl9pPr marL="3657600" algn="l" defTabSz="457200" rtl="0" eaLnBrk="1" latinLnBrk="0" hangingPunct="1">
+      <a:defRPr sz="1200" kern="1200">
+        <a:solidFill>
+          <a:schemeClr val="tx1"/>
+        </a:solidFill>
+        <a:latin typeface="+mn-lt"/>
+        <a:ea typeface="+mn-ea"/>
+        <a:cs typeface="+mn-cs"/>
+      </a:defRPr>
+    </a:lvl9pPr>
+  </p:notesStyle>
+</p:notesMaster>
+</file>
+
+<file path=ppt/notesSlides/notesSlide1.xml><?xml version="1.0" encoding="utf-8"?>
+<p:notes xmlns:a="http://schemas.openxmlformats.org/drawingml/2006/main" xmlns:p="http://schemas.openxmlformats.org/presentationml/2006/main" xmlns:r="http://schemas.openxmlformats.org/officeDocument/2006/relationships">
+  <p:cSld>
+    <p:spTree>
+      <p:nvGrpSpPr>
+        <p:cNvPr id="1" name=""/>
+        <p:cNvGrpSpPr/>
+        <p:nvPr/>
+      </p:nvGrpSpPr>
+      <p:grpSpPr>
+        <a:xfrm>
+          <a:off x="0" y="0"/>
+          <a:ext cx="0" cy="0"/>
+          <a:chOff x="0" y="0"/>
+          <a:chExt cx="0" cy="0"/>
+        </a:xfrm>
+      </p:grpSpPr>
+      <p:sp>
+        <p:nvSpPr>
+          <p:cNvPr id="2" name="Slide Image Placeholder 1"/>
+          <p:cNvSpPr>
+            <a:spLocks noGrp="1"/>
+          </p:cNvSpPr>
+          <p:nvPr>
+            <p:ph type="sldImg" idx="2"/>
+          </p:nvPr>
+        </p:nvSpPr>
+        <p:spPr/>
+      </p:sp>
+      <p:sp>
+        <p:nvSpPr>
+          <p:cNvPr id="3" name="Notes Placeholder 2"/>
+          <p:cNvSpPr>
+            <a:spLocks noGrp="1"/>
+          </p:cNvSpPr>
+          <p:nvPr>
+            <p:ph type="body" idx="3" sz="quarter"/>
+          </p:nvPr>
+        </p:nvSpPr>
+        <p:spPr/>
+        <p:txBody>
+          <a:bodyPr/>
+          <a:lstStyle/>
+          <a:p>
+            <a:r>
+              <a:t>HIDDEN during demo. Full script: .presentation/hackathon-2026-09/PRESENTER_RUNBOOK.md</a:t>
+            </a:r>
+          </a:p>
+          <a:p>
+            <a:r>
+              <a:t>Hybrid: npm run tokenforge -- scan fixtures/instructions-app --mode hybrid --llm cursor-cli:composer-2.5 --allow-external</a:t>
+            </a:r>
+          </a:p>
+          <a:p>
+            <a:r>
+              <a:t>Fallback: dashboard/public/demo-hybrid-cursor-report.json</a:t>
+            </a:r>
+          </a:p>
+          <a:p>
+            <a:r>
+              <a:t>Cut order: team scope → live hybrid → architecture slide</a:t>
+            </a:r>
+          </a:p>
+        </p:txBody>
+      </p:sp>
+      <p:sp>
+        <p:nvSpPr>
+          <p:cNvPr id="4" name="Slide Number Placeholder 3"/>
+          <p:cNvSpPr>
+            <a:spLocks noGrp="1"/>
+          </p:cNvSpPr>
+          <p:nvPr>
+            <p:ph type="sldNum" idx="5" sz="quarter"/>
+          </p:nvPr>
+        </p:nvSpPr>
+        <p:spPr/>
+      </p:sp>
+    </p:spTree>
+  </p:cSld>
+  <p:clrMapOvr>
+    <a:masterClrMapping/>
+  </p:clrMapOvr>
+</p:notes>
 </file>
 
 <file path=ppt/slideLayouts/slideLayout1.xml><?xml version="1.0" encoding="utf-8"?>
@@ -3477,6 +3913,1078 @@
             <a:avLst/>
           </a:prstGeom>
           <a:solidFill>
+            <a:srgbClr val="F7F8F9"/>
+          </a:solidFill>
+          <a:ln>
+            <a:noFill/>
+          </a:ln>
+        </p:spPr>
+        <p:style>
+          <a:lnRef idx="1">
+            <a:schemeClr val="accent1"/>
+          </a:lnRef>
+          <a:fillRef idx="3">
+            <a:schemeClr val="accent1"/>
+          </a:fillRef>
+          <a:effectRef idx="2">
+            <a:schemeClr val="accent1"/>
+          </a:effectRef>
+          <a:fontRef idx="minor">
+            <a:schemeClr val="lt1"/>
+          </a:fontRef>
+        </p:style>
+        <p:txBody>
+          <a:bodyPr rtlCol="0" anchor="ctr"/>
+          <a:lstStyle/>
+          <a:p>
+            <a:pPr algn="ctr"/>
+          </a:p>
+        </p:txBody>
+      </p:sp>
+      <p:sp>
+        <p:nvSpPr>
+          <p:cNvPr id="3" name="Rectangle 2"/>
+          <p:cNvSpPr/>
+          <p:nvPr/>
+        </p:nvSpPr>
+        <p:spPr>
+          <a:xfrm>
+            <a:off x="0" y="0"/>
+            <a:ext cx="109728" cy="6858000"/>
+          </a:xfrm>
+          <a:prstGeom prst="rect">
+            <a:avLst/>
+          </a:prstGeom>
+          <a:solidFill>
+            <a:srgbClr val="0B6E6A"/>
+          </a:solidFill>
+          <a:ln>
+            <a:noFill/>
+          </a:ln>
+        </p:spPr>
+        <p:style>
+          <a:lnRef idx="1">
+            <a:schemeClr val="accent1"/>
+          </a:lnRef>
+          <a:fillRef idx="3">
+            <a:schemeClr val="accent1"/>
+          </a:fillRef>
+          <a:effectRef idx="2">
+            <a:schemeClr val="accent1"/>
+          </a:effectRef>
+          <a:fontRef idx="minor">
+            <a:schemeClr val="lt1"/>
+          </a:fontRef>
+        </p:style>
+        <p:txBody>
+          <a:bodyPr rtlCol="0" anchor="ctr"/>
+          <a:lstStyle/>
+          <a:p>
+            <a:pPr algn="ctr"/>
+          </a:p>
+        </p:txBody>
+      </p:sp>
+      <p:sp>
+        <p:nvSpPr>
+          <p:cNvPr id="4" name="TextBox 3"/>
+          <p:cNvSpPr txBox="1"/>
+          <p:nvPr/>
+        </p:nvSpPr>
+        <p:spPr>
+          <a:xfrm>
+            <a:off x="640080" y="457200"/>
+            <a:ext cx="10972800" cy="274320"/>
+          </a:xfrm>
+          <a:prstGeom prst="rect">
+            <a:avLst/>
+          </a:prstGeom>
+          <a:noFill/>
+        </p:spPr>
+        <p:txBody>
+          <a:bodyPr wrap="square">
+            <a:spAutoFit/>
+          </a:bodyPr>
+          <a:lstStyle/>
+          <a:p>
+            <a:pPr algn="l">
+              <a:spcBef>
+                <a:spcPts val="0"/>
+              </a:spcBef>
+              <a:spcAft>
+                <a:spcPts val="0"/>
+              </a:spcAft>
+            </a:pPr>
+            <a:r>
+              <a:rPr sz="1200" b="1">
+                <a:solidFill>
+                  <a:srgbClr val="0B6E6A"/>
+                </a:solidFill>
+                <a:latin typeface="Calibri"/>
+                <a:ea typeface="Calibri"/>
+                <a:cs typeface="Calibri"/>
+              </a:rPr>
+              <a:t>09  ·  ARCHITECTURE</a:t>
+            </a:r>
+          </a:p>
+        </p:txBody>
+      </p:sp>
+      <p:sp>
+        <p:nvSpPr>
+          <p:cNvPr id="5" name="TextBox 4"/>
+          <p:cNvSpPr txBox="1"/>
+          <p:nvPr/>
+        </p:nvSpPr>
+        <p:spPr>
+          <a:xfrm>
+            <a:off x="640080" y="777240"/>
+            <a:ext cx="10972800" cy="594360"/>
+          </a:xfrm>
+          <a:prstGeom prst="rect">
+            <a:avLst/>
+          </a:prstGeom>
+          <a:noFill/>
+        </p:spPr>
+        <p:txBody>
+          <a:bodyPr wrap="square">
+            <a:spAutoFit/>
+          </a:bodyPr>
+          <a:lstStyle/>
+          <a:p>
+            <a:pPr algn="l">
+              <a:spcBef>
+                <a:spcPts val="0"/>
+              </a:spcBef>
+              <a:spcAft>
+                <a:spcPts val="0"/>
+              </a:spcAft>
+            </a:pPr>
+            <a:r>
+              <a:rPr sz="2800" b="1">
+                <a:solidFill>
+                  <a:srgbClr val="141C24"/>
+                </a:solidFill>
+                <a:latin typeface="Calibri"/>
+                <a:ea typeface="Calibri"/>
+                <a:cs typeface="Calibri"/>
+              </a:rPr>
+              <a:t>Ports &amp; adapters — shared JSON contract.</a:t>
+            </a:r>
+          </a:p>
+        </p:txBody>
+      </p:sp>
+      <p:sp>
+        <p:nvSpPr>
+          <p:cNvPr id="6" name="Rectangle 5"/>
+          <p:cNvSpPr/>
+          <p:nvPr/>
+        </p:nvSpPr>
+        <p:spPr>
+          <a:xfrm>
+            <a:off x="640080" y="1600200"/>
+            <a:ext cx="3383280" cy="3566160"/>
+          </a:xfrm>
+          <a:prstGeom prst="rect">
+            <a:avLst/>
+          </a:prstGeom>
+          <a:solidFill>
+            <a:srgbClr val="FFFFFF"/>
+          </a:solidFill>
+          <a:ln>
+            <a:noFill/>
+          </a:ln>
+        </p:spPr>
+        <p:style>
+          <a:lnRef idx="1">
+            <a:schemeClr val="accent1"/>
+          </a:lnRef>
+          <a:fillRef idx="3">
+            <a:schemeClr val="accent1"/>
+          </a:fillRef>
+          <a:effectRef idx="2">
+            <a:schemeClr val="accent1"/>
+          </a:effectRef>
+          <a:fontRef idx="minor">
+            <a:schemeClr val="lt1"/>
+          </a:fontRef>
+        </p:style>
+        <p:txBody>
+          <a:bodyPr rtlCol="0" anchor="ctr"/>
+          <a:lstStyle/>
+          <a:p>
+            <a:pPr algn="ctr"/>
+          </a:p>
+        </p:txBody>
+      </p:sp>
+      <p:sp>
+        <p:nvSpPr>
+          <p:cNvPr id="7" name="Rectangle 6"/>
+          <p:cNvSpPr/>
+          <p:nvPr/>
+        </p:nvSpPr>
+        <p:spPr>
+          <a:xfrm>
+            <a:off x="640080" y="1600200"/>
+            <a:ext cx="73152" cy="3566160"/>
+          </a:xfrm>
+          <a:prstGeom prst="rect">
+            <a:avLst/>
+          </a:prstGeom>
+          <a:solidFill>
+            <a:srgbClr val="084C49"/>
+          </a:solidFill>
+          <a:ln>
+            <a:noFill/>
+          </a:ln>
+        </p:spPr>
+        <p:style>
+          <a:lnRef idx="1">
+            <a:schemeClr val="accent1"/>
+          </a:lnRef>
+          <a:fillRef idx="3">
+            <a:schemeClr val="accent1"/>
+          </a:fillRef>
+          <a:effectRef idx="2">
+            <a:schemeClr val="accent1"/>
+          </a:effectRef>
+          <a:fontRef idx="minor">
+            <a:schemeClr val="lt1"/>
+          </a:fontRef>
+        </p:style>
+        <p:txBody>
+          <a:bodyPr rtlCol="0" anchor="ctr"/>
+          <a:lstStyle/>
+          <a:p>
+            <a:pPr algn="ctr"/>
+          </a:p>
+        </p:txBody>
+      </p:sp>
+      <p:sp>
+        <p:nvSpPr>
+          <p:cNvPr id="8" name="Rectangle 7"/>
+          <p:cNvSpPr/>
+          <p:nvPr/>
+        </p:nvSpPr>
+        <p:spPr>
+          <a:xfrm>
+            <a:off x="640080" y="1600200"/>
+            <a:ext cx="3383280" cy="3566160"/>
+          </a:xfrm>
+          <a:prstGeom prst="rect">
+            <a:avLst/>
+          </a:prstGeom>
+          <a:noFill/>
+          <a:ln w="12700">
+            <a:solidFill>
+              <a:srgbClr val="D8DEE5"/>
+            </a:solidFill>
+          </a:ln>
+        </p:spPr>
+        <p:style>
+          <a:lnRef idx="1">
+            <a:schemeClr val="accent1"/>
+          </a:lnRef>
+          <a:fillRef idx="3">
+            <a:schemeClr val="accent1"/>
+          </a:fillRef>
+          <a:effectRef idx="2">
+            <a:schemeClr val="accent1"/>
+          </a:effectRef>
+          <a:fontRef idx="minor">
+            <a:schemeClr val="lt1"/>
+          </a:fontRef>
+        </p:style>
+        <p:txBody>
+          <a:bodyPr rtlCol="0" anchor="ctr"/>
+          <a:lstStyle/>
+          <a:p>
+            <a:pPr algn="ctr"/>
+          </a:p>
+        </p:txBody>
+      </p:sp>
+      <p:sp>
+        <p:nvSpPr>
+          <p:cNvPr id="9" name="TextBox 8"/>
+          <p:cNvSpPr txBox="1"/>
+          <p:nvPr/>
+        </p:nvSpPr>
+        <p:spPr>
+          <a:xfrm>
+            <a:off x="841248" y="1764792"/>
+            <a:ext cx="2980944" cy="502920"/>
+          </a:xfrm>
+          <a:prstGeom prst="rect">
+            <a:avLst/>
+          </a:prstGeom>
+          <a:noFill/>
+        </p:spPr>
+        <p:txBody>
+          <a:bodyPr wrap="square"/>
+          <a:lstStyle/>
+          <a:p>
+            <a:pPr algn="l">
+              <a:spcBef>
+                <a:spcPts val="0"/>
+              </a:spcBef>
+              <a:spcAft>
+                <a:spcPts val="0"/>
+              </a:spcAft>
+            </a:pPr>
+            <a:r>
+              <a:rPr sz="1500" b="1">
+                <a:solidFill>
+                  <a:srgbClr val="141C24"/>
+                </a:solidFill>
+                <a:latin typeface="Calibri"/>
+                <a:ea typeface="Calibri"/>
+                <a:cs typeface="Calibri"/>
+              </a:rPr>
+              <a:t>risk-core (kernel)</a:t>
+            </a:r>
+          </a:p>
+        </p:txBody>
+      </p:sp>
+      <p:sp>
+        <p:nvSpPr>
+          <p:cNvPr id="10" name="TextBox 9"/>
+          <p:cNvSpPr txBox="1"/>
+          <p:nvPr/>
+        </p:nvSpPr>
+        <p:spPr>
+          <a:xfrm>
+            <a:off x="841248" y="2340864"/>
+            <a:ext cx="2980944" cy="2679192"/>
+          </a:xfrm>
+          <a:prstGeom prst="rect">
+            <a:avLst/>
+          </a:prstGeom>
+          <a:noFill/>
+        </p:spPr>
+        <p:txBody>
+          <a:bodyPr wrap="square">
+            <a:spAutoFit/>
+          </a:bodyPr>
+          <a:lstStyle/>
+          <a:p>
+            <a:pPr algn="l">
+              <a:spcBef>
+                <a:spcPts val="0"/>
+              </a:spcBef>
+              <a:spcAft>
+                <a:spcPts val="400"/>
+              </a:spcAft>
+            </a:pPr>
+            <a:r>
+              <a:rPr sz="1300" b="0">
+                <a:solidFill>
+                  <a:srgbClr val="4A5766"/>
+                </a:solidFill>
+                <a:latin typeface="Calibri"/>
+                <a:ea typeface="Calibri"/>
+                <a:cs typeface="Calibri"/>
+              </a:rPr>
+              <a:t>Classify, score, protect,</a:t>
+            </a:r>
+          </a:p>
+          <a:p>
+            <a:pPr algn="l">
+              <a:spcBef>
+                <a:spcPts val="0"/>
+              </a:spcBef>
+              <a:spcAft>
+                <a:spcPts val="400"/>
+              </a:spcAft>
+            </a:pPr>
+            <a:r>
+              <a:rPr sz="1300" b="0">
+                <a:solidFill>
+                  <a:srgbClr val="4A5766"/>
+                </a:solidFill>
+                <a:latin typeface="Calibri"/>
+                <a:ea typeface="Calibri"/>
+                <a:cs typeface="Calibri"/>
+              </a:rPr>
+              <a:t>policy synthesis, usage math.</a:t>
+            </a:r>
+          </a:p>
+          <a:p>
+            <a:pPr algn="l">
+              <a:spcBef>
+                <a:spcPts val="0"/>
+              </a:spcBef>
+              <a:spcAft>
+                <a:spcPts val="400"/>
+              </a:spcAft>
+            </a:pPr>
+            <a:r>
+              <a:rPr sz="1300" b="0">
+                <a:solidFill>
+                  <a:srgbClr val="4A5766"/>
+                </a:solidFill>
+                <a:latin typeface="Calibri"/>
+                <a:ea typeface="Calibri"/>
+                <a:cs typeface="Calibri"/>
+              </a:rPr>
+              <a:t>No VS Code / React / CLI frameworks.</a:t>
+            </a:r>
+          </a:p>
+        </p:txBody>
+      </p:sp>
+      <p:sp>
+        <p:nvSpPr>
+          <p:cNvPr id="11" name="Rectangle 10"/>
+          <p:cNvSpPr/>
+          <p:nvPr/>
+        </p:nvSpPr>
+        <p:spPr>
+          <a:xfrm>
+            <a:off x="4389120" y="1600200"/>
+            <a:ext cx="3383280" cy="3566160"/>
+          </a:xfrm>
+          <a:prstGeom prst="rect">
+            <a:avLst/>
+          </a:prstGeom>
+          <a:solidFill>
+            <a:srgbClr val="FFFFFF"/>
+          </a:solidFill>
+          <a:ln>
+            <a:noFill/>
+          </a:ln>
+        </p:spPr>
+        <p:style>
+          <a:lnRef idx="1">
+            <a:schemeClr val="accent1"/>
+          </a:lnRef>
+          <a:fillRef idx="3">
+            <a:schemeClr val="accent1"/>
+          </a:fillRef>
+          <a:effectRef idx="2">
+            <a:schemeClr val="accent1"/>
+          </a:effectRef>
+          <a:fontRef idx="minor">
+            <a:schemeClr val="lt1"/>
+          </a:fontRef>
+        </p:style>
+        <p:txBody>
+          <a:bodyPr rtlCol="0" anchor="ctr"/>
+          <a:lstStyle/>
+          <a:p>
+            <a:pPr algn="ctr"/>
+          </a:p>
+        </p:txBody>
+      </p:sp>
+      <p:sp>
+        <p:nvSpPr>
+          <p:cNvPr id="12" name="Rectangle 11"/>
+          <p:cNvSpPr/>
+          <p:nvPr/>
+        </p:nvSpPr>
+        <p:spPr>
+          <a:xfrm>
+            <a:off x="4389120" y="1600200"/>
+            <a:ext cx="73152" cy="3566160"/>
+          </a:xfrm>
+          <a:prstGeom prst="rect">
+            <a:avLst/>
+          </a:prstGeom>
+          <a:solidFill>
+            <a:srgbClr val="0B6E6A"/>
+          </a:solidFill>
+          <a:ln>
+            <a:noFill/>
+          </a:ln>
+        </p:spPr>
+        <p:style>
+          <a:lnRef idx="1">
+            <a:schemeClr val="accent1"/>
+          </a:lnRef>
+          <a:fillRef idx="3">
+            <a:schemeClr val="accent1"/>
+          </a:fillRef>
+          <a:effectRef idx="2">
+            <a:schemeClr val="accent1"/>
+          </a:effectRef>
+          <a:fontRef idx="minor">
+            <a:schemeClr val="lt1"/>
+          </a:fontRef>
+        </p:style>
+        <p:txBody>
+          <a:bodyPr rtlCol="0" anchor="ctr"/>
+          <a:lstStyle/>
+          <a:p>
+            <a:pPr algn="ctr"/>
+          </a:p>
+        </p:txBody>
+      </p:sp>
+      <p:sp>
+        <p:nvSpPr>
+          <p:cNvPr id="13" name="Rectangle 12"/>
+          <p:cNvSpPr/>
+          <p:nvPr/>
+        </p:nvSpPr>
+        <p:spPr>
+          <a:xfrm>
+            <a:off x="4389120" y="1600200"/>
+            <a:ext cx="3383280" cy="3566160"/>
+          </a:xfrm>
+          <a:prstGeom prst="rect">
+            <a:avLst/>
+          </a:prstGeom>
+          <a:noFill/>
+          <a:ln w="12700">
+            <a:solidFill>
+              <a:srgbClr val="D8DEE5"/>
+            </a:solidFill>
+          </a:ln>
+        </p:spPr>
+        <p:style>
+          <a:lnRef idx="1">
+            <a:schemeClr val="accent1"/>
+          </a:lnRef>
+          <a:fillRef idx="3">
+            <a:schemeClr val="accent1"/>
+          </a:fillRef>
+          <a:effectRef idx="2">
+            <a:schemeClr val="accent1"/>
+          </a:effectRef>
+          <a:fontRef idx="minor">
+            <a:schemeClr val="lt1"/>
+          </a:fontRef>
+        </p:style>
+        <p:txBody>
+          <a:bodyPr rtlCol="0" anchor="ctr"/>
+          <a:lstStyle/>
+          <a:p>
+            <a:pPr algn="ctr"/>
+          </a:p>
+        </p:txBody>
+      </p:sp>
+      <p:sp>
+        <p:nvSpPr>
+          <p:cNvPr id="14" name="TextBox 13"/>
+          <p:cNvSpPr txBox="1"/>
+          <p:nvPr/>
+        </p:nvSpPr>
+        <p:spPr>
+          <a:xfrm>
+            <a:off x="4590288" y="1764792"/>
+            <a:ext cx="2980944" cy="502920"/>
+          </a:xfrm>
+          <a:prstGeom prst="rect">
+            <a:avLst/>
+          </a:prstGeom>
+          <a:noFill/>
+        </p:spPr>
+        <p:txBody>
+          <a:bodyPr wrap="square"/>
+          <a:lstStyle/>
+          <a:p>
+            <a:pPr algn="l">
+              <a:spcBef>
+                <a:spcPts val="0"/>
+              </a:spcBef>
+              <a:spcAft>
+                <a:spcPts val="0"/>
+              </a:spcAft>
+            </a:pPr>
+            <a:r>
+              <a:rPr sz="1500" b="1">
+                <a:solidFill>
+                  <a:srgbClr val="141C24"/>
+                </a:solidFill>
+                <a:latin typeface="Calibri"/>
+                <a:ea typeface="Calibri"/>
+                <a:cs typeface="Calibri"/>
+              </a:rPr>
+              <a:t>.tokenforge/*.json</a:t>
+            </a:r>
+          </a:p>
+        </p:txBody>
+      </p:sp>
+      <p:sp>
+        <p:nvSpPr>
+          <p:cNvPr id="15" name="TextBox 14"/>
+          <p:cNvSpPr txBox="1"/>
+          <p:nvPr/>
+        </p:nvSpPr>
+        <p:spPr>
+          <a:xfrm>
+            <a:off x="4590288" y="2340864"/>
+            <a:ext cx="2980944" cy="2679192"/>
+          </a:xfrm>
+          <a:prstGeom prst="rect">
+            <a:avLst/>
+          </a:prstGeom>
+          <a:noFill/>
+        </p:spPr>
+        <p:txBody>
+          <a:bodyPr wrap="square">
+            <a:spAutoFit/>
+          </a:bodyPr>
+          <a:lstStyle/>
+          <a:p>
+            <a:pPr algn="l">
+              <a:spcBef>
+                <a:spcPts val="0"/>
+              </a:spcBef>
+              <a:spcAft>
+                <a:spcPts val="400"/>
+              </a:spcAft>
+            </a:pPr>
+            <a:r>
+              <a:rPr sz="1300" b="0">
+                <a:solidFill>
+                  <a:srgbClr val="4A5766"/>
+                </a:solidFill>
+                <a:latin typeface="Calibri"/>
+                <a:ea typeface="Calibri"/>
+                <a:cs typeface="Calibri"/>
+              </a:rPr>
+              <a:t>scan-report.json</a:t>
+            </a:r>
+          </a:p>
+          <a:p>
+            <a:pPr algn="l">
+              <a:spcBef>
+                <a:spcPts val="0"/>
+              </a:spcBef>
+              <a:spcAft>
+                <a:spcPts val="400"/>
+              </a:spcAft>
+            </a:pPr>
+            <a:r>
+              <a:rPr sz="1300" b="0">
+                <a:solidFill>
+                  <a:srgbClr val="4A5766"/>
+                </a:solidFill>
+                <a:latin typeface="Calibri"/>
+                <a:ea typeface="Calibri"/>
+                <a:cs typeface="Calibri"/>
+              </a:rPr>
+              <a:t>last-scan.json</a:t>
+            </a:r>
+          </a:p>
+          <a:p>
+            <a:pPr algn="l">
+              <a:spcBef>
+                <a:spcPts val="0"/>
+              </a:spcBef>
+              <a:spcAft>
+                <a:spcPts val="400"/>
+              </a:spcAft>
+            </a:pPr>
+            <a:r>
+              <a:rPr sz="1300" b="0">
+                <a:solidFill>
+                  <a:srgbClr val="4A5766"/>
+                </a:solidFill>
+                <a:latin typeface="Calibri"/>
+                <a:ea typeface="Calibri"/>
+                <a:cs typeface="Calibri"/>
+              </a:rPr>
+              <a:t>UsageMetrics import</a:t>
+            </a:r>
+          </a:p>
+          <a:p>
+            <a:pPr algn="l">
+              <a:spcBef>
+                <a:spcPts val="0"/>
+              </a:spcBef>
+              <a:spcAft>
+                <a:spcPts val="400"/>
+              </a:spcAft>
+            </a:pPr>
+            <a:r>
+              <a:rPr sz="1300" b="0">
+                <a:solidFill>
+                  <a:srgbClr val="4A5766"/>
+                </a:solidFill>
+                <a:latin typeface="Calibri"/>
+                <a:ea typeface="Calibri"/>
+                <a:cs typeface="Calibri"/>
+              </a:rPr>
+              <a:t>File contract between surfaces.</a:t>
+            </a:r>
+          </a:p>
+        </p:txBody>
+      </p:sp>
+      <p:sp>
+        <p:nvSpPr>
+          <p:cNvPr id="16" name="Rectangle 15"/>
+          <p:cNvSpPr/>
+          <p:nvPr/>
+        </p:nvSpPr>
+        <p:spPr>
+          <a:xfrm>
+            <a:off x="8138160" y="1600200"/>
+            <a:ext cx="3383280" cy="3566160"/>
+          </a:xfrm>
+          <a:prstGeom prst="rect">
+            <a:avLst/>
+          </a:prstGeom>
+          <a:solidFill>
+            <a:srgbClr val="FFFFFF"/>
+          </a:solidFill>
+          <a:ln>
+            <a:noFill/>
+          </a:ln>
+        </p:spPr>
+        <p:style>
+          <a:lnRef idx="1">
+            <a:schemeClr val="accent1"/>
+          </a:lnRef>
+          <a:fillRef idx="3">
+            <a:schemeClr val="accent1"/>
+          </a:fillRef>
+          <a:effectRef idx="2">
+            <a:schemeClr val="accent1"/>
+          </a:effectRef>
+          <a:fontRef idx="minor">
+            <a:schemeClr val="lt1"/>
+          </a:fontRef>
+        </p:style>
+        <p:txBody>
+          <a:bodyPr rtlCol="0" anchor="ctr"/>
+          <a:lstStyle/>
+          <a:p>
+            <a:pPr algn="ctr"/>
+          </a:p>
+        </p:txBody>
+      </p:sp>
+      <p:sp>
+        <p:nvSpPr>
+          <p:cNvPr id="17" name="Rectangle 16"/>
+          <p:cNvSpPr/>
+          <p:nvPr/>
+        </p:nvSpPr>
+        <p:spPr>
+          <a:xfrm>
+            <a:off x="8138160" y="1600200"/>
+            <a:ext cx="73152" cy="3566160"/>
+          </a:xfrm>
+          <a:prstGeom prst="rect">
+            <a:avLst/>
+          </a:prstGeom>
+          <a:solidFill>
+            <a:srgbClr val="0B6E6A"/>
+          </a:solidFill>
+          <a:ln>
+            <a:noFill/>
+          </a:ln>
+        </p:spPr>
+        <p:style>
+          <a:lnRef idx="1">
+            <a:schemeClr val="accent1"/>
+          </a:lnRef>
+          <a:fillRef idx="3">
+            <a:schemeClr val="accent1"/>
+          </a:fillRef>
+          <a:effectRef idx="2">
+            <a:schemeClr val="accent1"/>
+          </a:effectRef>
+          <a:fontRef idx="minor">
+            <a:schemeClr val="lt1"/>
+          </a:fontRef>
+        </p:style>
+        <p:txBody>
+          <a:bodyPr rtlCol="0" anchor="ctr"/>
+          <a:lstStyle/>
+          <a:p>
+            <a:pPr algn="ctr"/>
+          </a:p>
+        </p:txBody>
+      </p:sp>
+      <p:sp>
+        <p:nvSpPr>
+          <p:cNvPr id="18" name="Rectangle 17"/>
+          <p:cNvSpPr/>
+          <p:nvPr/>
+        </p:nvSpPr>
+        <p:spPr>
+          <a:xfrm>
+            <a:off x="8138160" y="1600200"/>
+            <a:ext cx="3383280" cy="3566160"/>
+          </a:xfrm>
+          <a:prstGeom prst="rect">
+            <a:avLst/>
+          </a:prstGeom>
+          <a:noFill/>
+          <a:ln w="12700">
+            <a:solidFill>
+              <a:srgbClr val="D8DEE5"/>
+            </a:solidFill>
+          </a:ln>
+        </p:spPr>
+        <p:style>
+          <a:lnRef idx="1">
+            <a:schemeClr val="accent1"/>
+          </a:lnRef>
+          <a:fillRef idx="3">
+            <a:schemeClr val="accent1"/>
+          </a:fillRef>
+          <a:effectRef idx="2">
+            <a:schemeClr val="accent1"/>
+          </a:effectRef>
+          <a:fontRef idx="minor">
+            <a:schemeClr val="lt1"/>
+          </a:fontRef>
+        </p:style>
+        <p:txBody>
+          <a:bodyPr rtlCol="0" anchor="ctr"/>
+          <a:lstStyle/>
+          <a:p>
+            <a:pPr algn="ctr"/>
+          </a:p>
+        </p:txBody>
+      </p:sp>
+      <p:sp>
+        <p:nvSpPr>
+          <p:cNvPr id="19" name="TextBox 18"/>
+          <p:cNvSpPr txBox="1"/>
+          <p:nvPr/>
+        </p:nvSpPr>
+        <p:spPr>
+          <a:xfrm>
+            <a:off x="8339328" y="1764792"/>
+            <a:ext cx="2980944" cy="502920"/>
+          </a:xfrm>
+          <a:prstGeom prst="rect">
+            <a:avLst/>
+          </a:prstGeom>
+          <a:noFill/>
+        </p:spPr>
+        <p:txBody>
+          <a:bodyPr wrap="square"/>
+          <a:lstStyle/>
+          <a:p>
+            <a:pPr algn="l">
+              <a:spcBef>
+                <a:spcPts val="0"/>
+              </a:spcBef>
+              <a:spcAft>
+                <a:spcPts val="0"/>
+              </a:spcAft>
+            </a:pPr>
+            <a:r>
+              <a:rPr sz="1500" b="1">
+                <a:solidFill>
+                  <a:srgbClr val="141C24"/>
+                </a:solidFill>
+                <a:latin typeface="Calibri"/>
+                <a:ea typeface="Calibri"/>
+                <a:cs typeface="Calibri"/>
+              </a:rPr>
+              <a:t>Adapters</a:t>
+            </a:r>
+          </a:p>
+        </p:txBody>
+      </p:sp>
+      <p:sp>
+        <p:nvSpPr>
+          <p:cNvPr id="20" name="TextBox 19"/>
+          <p:cNvSpPr txBox="1"/>
+          <p:nvPr/>
+        </p:nvSpPr>
+        <p:spPr>
+          <a:xfrm>
+            <a:off x="8339328" y="2340864"/>
+            <a:ext cx="2980944" cy="2679192"/>
+          </a:xfrm>
+          <a:prstGeom prst="rect">
+            <a:avLst/>
+          </a:prstGeom>
+          <a:noFill/>
+        </p:spPr>
+        <p:txBody>
+          <a:bodyPr wrap="square">
+            <a:spAutoFit/>
+          </a:bodyPr>
+          <a:lstStyle/>
+          <a:p>
+            <a:pPr algn="l">
+              <a:spcBef>
+                <a:spcPts val="0"/>
+              </a:spcBef>
+              <a:spcAft>
+                <a:spcPts val="400"/>
+              </a:spcAft>
+            </a:pPr>
+            <a:r>
+              <a:rPr sz="1300" b="0">
+                <a:solidFill>
+                  <a:srgbClr val="4A5766"/>
+                </a:solidFill>
+                <a:latin typeface="Calibri"/>
+                <a:ea typeface="Calibri"/>
+                <a:cs typeface="Calibri"/>
+              </a:rPr>
+              <a:t>Extension — Detect (tabs)</a:t>
+            </a:r>
+          </a:p>
+          <a:p>
+            <a:pPr algn="l">
+              <a:spcBef>
+                <a:spcPts val="0"/>
+              </a:spcBef>
+              <a:spcAft>
+                <a:spcPts val="400"/>
+              </a:spcAft>
+            </a:pPr>
+            <a:r>
+              <a:rPr sz="1300" b="0">
+                <a:solidFill>
+                  <a:srgbClr val="4A5766"/>
+                </a:solidFill>
+                <a:latin typeface="Calibri"/>
+                <a:ea typeface="Calibri"/>
+                <a:cs typeface="Calibri"/>
+              </a:rPr>
+              <a:t>CLI — Fix + hybrid enrichers</a:t>
+            </a:r>
+          </a:p>
+          <a:p>
+            <a:pPr algn="l">
+              <a:spcBef>
+                <a:spcPts val="0"/>
+              </a:spcBef>
+              <a:spcAft>
+                <a:spcPts val="400"/>
+              </a:spcAft>
+            </a:pPr>
+            <a:r>
+              <a:rPr sz="1300" b="0">
+                <a:solidFill>
+                  <a:srgbClr val="4A5766"/>
+                </a:solidFill>
+                <a:latin typeface="Calibri"/>
+                <a:ea typeface="Calibri"/>
+                <a:cs typeface="Calibri"/>
+              </a:rPr>
+              <a:t>Dashboard — Prove / variance</a:t>
+            </a:r>
+          </a:p>
+        </p:txBody>
+      </p:sp>
+      <p:sp>
+        <p:nvSpPr>
+          <p:cNvPr id="21" name="TextBox 20"/>
+          <p:cNvSpPr txBox="1"/>
+          <p:nvPr/>
+        </p:nvSpPr>
+        <p:spPr>
+          <a:xfrm>
+            <a:off x="640080" y="5349240"/>
+            <a:ext cx="10972800" cy="502920"/>
+          </a:xfrm>
+          <a:prstGeom prst="rect">
+            <a:avLst/>
+          </a:prstGeom>
+          <a:noFill/>
+        </p:spPr>
+        <p:txBody>
+          <a:bodyPr wrap="square">
+            <a:spAutoFit/>
+          </a:bodyPr>
+          <a:lstStyle/>
+          <a:p>
+            <a:pPr algn="l">
+              <a:spcBef>
+                <a:spcPts val="0"/>
+              </a:spcBef>
+              <a:spcAft>
+                <a:spcPts val="0"/>
+              </a:spcAft>
+            </a:pPr>
+            <a:r>
+              <a:rPr sz="1400" b="1">
+                <a:solidFill>
+                  <a:srgbClr val="084C49"/>
+                </a:solidFill>
+                <a:latin typeface="Calibri"/>
+                <a:ea typeface="Calibri"/>
+                <a:cs typeface="Calibri"/>
+              </a:rPr>
+              <a:t>Provider adapters write Copilot / Cursor / Claude policy packs from the same findings.</a:t>
+            </a:r>
+          </a:p>
+        </p:txBody>
+      </p:sp>
+      <p:sp>
+        <p:nvSpPr>
+          <p:cNvPr id="22" name="TextBox 21"/>
+          <p:cNvSpPr txBox="1"/>
+          <p:nvPr/>
+        </p:nvSpPr>
+        <p:spPr>
+          <a:xfrm>
+            <a:off x="640080" y="6492240"/>
+            <a:ext cx="10972800" cy="256032"/>
+          </a:xfrm>
+          <a:prstGeom prst="rect">
+            <a:avLst/>
+          </a:prstGeom>
+          <a:noFill/>
+        </p:spPr>
+        <p:txBody>
+          <a:bodyPr wrap="square">
+            <a:spAutoFit/>
+          </a:bodyPr>
+          <a:lstStyle/>
+          <a:p>
+            <a:pPr algn="l">
+              <a:spcBef>
+                <a:spcPts val="0"/>
+              </a:spcBef>
+              <a:spcAft>
+                <a:spcPts val="0"/>
+              </a:spcAft>
+            </a:pPr>
+            <a:r>
+              <a:rPr sz="1100" b="0">
+                <a:solidFill>
+                  <a:srgbClr val="4A5766"/>
+                </a:solidFill>
+                <a:latin typeface="Calibri"/>
+                <a:ea typeface="Calibri"/>
+                <a:cs typeface="Calibri"/>
+              </a:rPr>
+              <a:t>TokenForge  ·  AI Coding FinOps  ·  Hackathon pitch  ·  10 / 11</a:t>
+            </a:r>
+          </a:p>
+        </p:txBody>
+      </p:sp>
+    </p:spTree>
+  </p:cSld>
+  <p:clrMapOvr>
+    <a:masterClrMapping/>
+  </p:clrMapOvr>
+</p:sld>
+</file>
+
+<file path=ppt/slides/slide11.xml><?xml version="1.0" encoding="utf-8"?>
+<p:sld xmlns:a="http://schemas.openxmlformats.org/drawingml/2006/main" xmlns:p="http://schemas.openxmlformats.org/presentationml/2006/main" xmlns:r="http://schemas.openxmlformats.org/officeDocument/2006/relationships">
+  <p:cSld>
+    <p:spTree>
+      <p:nvGrpSpPr>
+        <p:cNvPr id="1" name=""/>
+        <p:cNvGrpSpPr/>
+        <p:nvPr/>
+      </p:nvGrpSpPr>
+      <p:grpSpPr/>
+      <p:sp>
+        <p:nvSpPr>
+          <p:cNvPr id="2" name="Rectangle 1"/>
+          <p:cNvSpPr/>
+          <p:nvPr/>
+        </p:nvSpPr>
+        <p:spPr>
+          <a:xfrm>
+            <a:off x="0" y="0"/>
+            <a:ext cx="12191695" cy="6858000"/>
+          </a:xfrm>
+          <a:prstGeom prst="rect">
+            <a:avLst/>
+          </a:prstGeom>
+          <a:solidFill>
             <a:srgbClr val="141C24"/>
           </a:solidFill>
           <a:ln>
@@ -3997,7 +5505,7 @@
                 <a:ea typeface="Calibri"/>
                 <a:cs typeface="Calibri"/>
               </a:rPr>
-              <a:t>Low-value context inflates Chat/Agent workflows. There’s no clear loop to see → fix → prove savings.</a:t>
+              <a:t>Managers see the invoice — not the waste loop. Low-value context inflates every Agent turn.</a:t>
             </a:r>
           </a:p>
         </p:txBody>
@@ -4901,7 +6409,7 @@
                 <a:ea typeface="Calibri"/>
                 <a:cs typeface="Calibri"/>
               </a:rPr>
-              <a:t>TokenForge  ·  AI Coding FinOps  ·  Hackathon pitch  ·  2 / 10</a:t>
+              <a:t>TokenForge  ·  AI Coding FinOps  ·  Hackathon pitch  ·  2 / 11</a:t>
             </a:r>
           </a:p>
         </p:txBody>
@@ -5981,8 +7489,8 @@
         </p:nvSpPr>
         <p:spPr>
           <a:xfrm>
-            <a:off x="640080" y="6492240"/>
-            <a:ext cx="10972800" cy="256032"/>
+            <a:off x="640080" y="4892040"/>
+            <a:ext cx="10972800" cy="685800"/>
           </a:xfrm>
           <a:prstGeom prst="rect">
             <a:avLst/>
@@ -6004,15 +7512,59 @@
               </a:spcAft>
             </a:pPr>
             <a:r>
-              <a:rPr sz="1100" b="0">
-                <a:solidFill>
-                  <a:srgbClr val="4A5766"/>
+              <a:rPr sz="1400" b="1">
+                <a:solidFill>
+                  <a:srgbClr val="084C49"/>
                 </a:solidFill>
                 <a:latin typeface="Calibri"/>
                 <a:ea typeface="Calibri"/>
                 <a:cs typeface="Calibri"/>
               </a:rPr>
-              <a:t>TokenForge  ·  AI Coding FinOps  ·  Hackathon pitch  ·  3 / 10</a:t>
+              <a:t>TokenForge is the only loop that Detects IDE/repo context waste, Fixes via provider policy packs, and Proves $ to FinOps — provider-agnostic.</a:t>
+            </a:r>
+          </a:p>
+        </p:txBody>
+      </p:sp>
+      <p:sp>
+        <p:nvSpPr>
+          <p:cNvPr id="27" name="TextBox 26"/>
+          <p:cNvSpPr txBox="1"/>
+          <p:nvPr/>
+        </p:nvSpPr>
+        <p:spPr>
+          <a:xfrm>
+            <a:off x="640080" y="6492240"/>
+            <a:ext cx="10972800" cy="256032"/>
+          </a:xfrm>
+          <a:prstGeom prst="rect">
+            <a:avLst/>
+          </a:prstGeom>
+          <a:noFill/>
+        </p:spPr>
+        <p:txBody>
+          <a:bodyPr wrap="square">
+            <a:spAutoFit/>
+          </a:bodyPr>
+          <a:lstStyle/>
+          <a:p>
+            <a:pPr algn="l">
+              <a:spcBef>
+                <a:spcPts val="0"/>
+              </a:spcBef>
+              <a:spcAft>
+                <a:spcPts val="0"/>
+              </a:spcAft>
+            </a:pPr>
+            <a:r>
+              <a:rPr sz="1100" b="0">
+                <a:solidFill>
+                  <a:srgbClr val="4A5766"/>
+                </a:solidFill>
+                <a:latin typeface="Calibri"/>
+                <a:ea typeface="Calibri"/>
+                <a:cs typeface="Calibri"/>
+              </a:rPr>
+              <a:t>TokenForge  ·  AI Coding FinOps  ·  Hackathon pitch  ·  3 / 11</a:t>
             </a:r>
           </a:p>
         </p:txBody>
@@ -6160,7 +7712,7 @@
                 <a:ea typeface="Calibri"/>
                 <a:cs typeface="Calibri"/>
               </a:rPr>
-              <a:t>03  ·  COMPETITIVE DIFFERENTIATION</a:t>
+              <a:t>03  ·  DIFFERENTIATION &amp; UNIQUENESS</a:t>
             </a:r>
           </a:p>
         </p:txBody>
@@ -6174,7 +7726,7 @@
         <p:spPr>
           <a:xfrm>
             <a:off x="640080" y="777240"/>
-            <a:ext cx="10972800" cy="685800"/>
+            <a:ext cx="10972800" cy="594360"/>
           </a:xfrm>
           <a:prstGeom prst="rect">
             <a:avLst/>
@@ -6211,14 +7763,58 @@
       </p:sp>
       <p:sp>
         <p:nvSpPr>
-          <p:cNvPr id="6" name="Rectangle 5"/>
+          <p:cNvPr id="6" name="TextBox 5"/>
+          <p:cNvSpPr txBox="1"/>
+          <p:nvPr/>
+        </p:nvSpPr>
+        <p:spPr>
+          <a:xfrm>
+            <a:off x="640080" y="1417320"/>
+            <a:ext cx="10972800" cy="320040"/>
+          </a:xfrm>
+          <a:prstGeom prst="rect">
+            <a:avLst/>
+          </a:prstGeom>
+          <a:noFill/>
+        </p:spPr>
+        <p:txBody>
+          <a:bodyPr wrap="square">
+            <a:spAutoFit/>
+          </a:bodyPr>
+          <a:lstStyle/>
+          <a:p>
+            <a:pPr algn="l">
+              <a:spcBef>
+                <a:spcPts val="0"/>
+              </a:spcBef>
+              <a:spcAft>
+                <a:spcPts val="0"/>
+              </a:spcAft>
+            </a:pPr>
+            <a:r>
+              <a:rPr sz="1400" b="0">
+                <a:solidFill>
+                  <a:srgbClr val="4A5766"/>
+                </a:solidFill>
+                <a:latin typeface="Calibri"/>
+                <a:ea typeface="Calibri"/>
+                <a:cs typeface="Calibri"/>
+              </a:rPr>
+              <a:t>Slide 3 categories optimise spend or recall — none remove billable context waste and prove $.</a:t>
+            </a:r>
+          </a:p>
+        </p:txBody>
+      </p:sp>
+      <p:sp>
+        <p:nvSpPr>
+          <p:cNvPr id="7" name="Rectangle 6"/>
           <p:cNvSpPr/>
           <p:nvPr/>
         </p:nvSpPr>
         <p:spPr>
           <a:xfrm>
-            <a:off x="640080" y="1645920"/>
-            <a:ext cx="5212080" cy="3063240"/>
+            <a:off x="640080" y="1828800"/>
+            <a:ext cx="5212080" cy="1874519"/>
           </a:xfrm>
           <a:prstGeom prst="rect">
             <a:avLst/>
@@ -6254,14 +7850,14 @@
       </p:sp>
       <p:sp>
         <p:nvSpPr>
-          <p:cNvPr id="7" name="Rectangle 6"/>
+          <p:cNvPr id="8" name="Rectangle 7"/>
           <p:cNvSpPr/>
           <p:nvPr/>
         </p:nvSpPr>
         <p:spPr>
           <a:xfrm>
-            <a:off x="640080" y="1645920"/>
-            <a:ext cx="5212080" cy="502920"/>
+            <a:off x="640080" y="1828800"/>
+            <a:ext cx="5212080" cy="438912"/>
           </a:xfrm>
           <a:prstGeom prst="rect">
             <a:avLst/>
@@ -6297,14 +7893,14 @@
       </p:sp>
       <p:sp>
         <p:nvSpPr>
-          <p:cNvPr id="8" name="TextBox 7"/>
+          <p:cNvPr id="9" name="TextBox 8"/>
           <p:cNvSpPr txBox="1"/>
           <p:nvPr/>
         </p:nvSpPr>
         <p:spPr>
           <a:xfrm>
-            <a:off x="896112" y="1755648"/>
-            <a:ext cx="4754880" cy="320040"/>
+            <a:off x="896112" y="1920240"/>
+            <a:ext cx="4754880" cy="292608"/>
           </a:xfrm>
           <a:prstGeom prst="rect">
             <a:avLst/>
@@ -6326,7 +7922,7 @@
               </a:spcAft>
             </a:pPr>
             <a:r>
-              <a:rPr sz="1600" b="1">
+              <a:rPr sz="1500" b="1">
                 <a:solidFill>
                   <a:srgbClr val="FFFFFF"/>
                 </a:solidFill>
@@ -6341,14 +7937,14 @@
       </p:sp>
       <p:sp>
         <p:nvSpPr>
-          <p:cNvPr id="9" name="TextBox 8"/>
+          <p:cNvPr id="10" name="TextBox 9"/>
           <p:cNvSpPr txBox="1"/>
           <p:nvPr/>
         </p:nvSpPr>
         <p:spPr>
           <a:xfrm>
-            <a:off x="896112" y="2377440"/>
-            <a:ext cx="4754880" cy="2194560"/>
+            <a:off x="896112" y="2404872"/>
+            <a:ext cx="4754880" cy="1234440"/>
           </a:xfrm>
           <a:prstGeom prst="rect">
             <a:avLst/>
@@ -6366,11 +7962,11 @@
                 <a:spcPts val="0"/>
               </a:spcBef>
               <a:spcAft>
-                <a:spcPts val="1200"/>
+                <a:spcPts val="800"/>
               </a:spcAft>
             </a:pPr>
             <a:r>
-              <a:rPr sz="1500" b="0">
+              <a:rPr sz="1300" b="0">
                 <a:solidFill>
                   <a:srgbClr val="4A5766"/>
                 </a:solidFill>
@@ -6387,32 +7983,11 @@
                 <a:spcPts val="0"/>
               </a:spcBef>
               <a:spcAft>
-                <a:spcPts val="1200"/>
+                <a:spcPts val="0"/>
               </a:spcAft>
             </a:pPr>
             <a:r>
-              <a:rPr sz="1500" b="0">
-                <a:solidFill>
-                  <a:srgbClr val="4A5766"/>
-                </a:solidFill>
-                <a:latin typeface="Calibri"/>
-                <a:ea typeface="Calibri"/>
-                <a:cs typeface="Calibri"/>
-              </a:rPr>
-              <a:t>Enriches one agent’s continuity</a:t>
-            </a:r>
-          </a:p>
-          <a:p>
-            <a:pPr algn="l">
-              <a:spcBef>
-                <a:spcPts val="0"/>
-              </a:spcBef>
-              <a:spcAft>
-                <a:spcPts val="0"/>
-              </a:spcAft>
-            </a:pPr>
-            <a:r>
-              <a:rPr sz="1500" b="0">
+              <a:rPr sz="1300" b="0">
                 <a:solidFill>
                   <a:srgbClr val="4A5766"/>
                 </a:solidFill>
@@ -6427,14 +8002,14 @@
       </p:sp>
       <p:sp>
         <p:nvSpPr>
-          <p:cNvPr id="10" name="Rectangle 9"/>
+          <p:cNvPr id="11" name="Rectangle 10"/>
           <p:cNvSpPr/>
           <p:nvPr/>
         </p:nvSpPr>
         <p:spPr>
           <a:xfrm>
-            <a:off x="6309360" y="1645920"/>
-            <a:ext cx="5212080" cy="3063240"/>
+            <a:off x="6309360" y="1828800"/>
+            <a:ext cx="5212080" cy="1874519"/>
           </a:xfrm>
           <a:prstGeom prst="rect">
             <a:avLst/>
@@ -6470,14 +8045,14 @@
       </p:sp>
       <p:sp>
         <p:nvSpPr>
-          <p:cNvPr id="11" name="Rectangle 10"/>
+          <p:cNvPr id="12" name="Rectangle 11"/>
           <p:cNvSpPr/>
           <p:nvPr/>
         </p:nvSpPr>
         <p:spPr>
           <a:xfrm>
-            <a:off x="6309360" y="1645920"/>
-            <a:ext cx="5212080" cy="502920"/>
+            <a:off x="6309360" y="1828800"/>
+            <a:ext cx="5212080" cy="438912"/>
           </a:xfrm>
           <a:prstGeom prst="rect">
             <a:avLst/>
@@ -6513,14 +8088,14 @@
       </p:sp>
       <p:sp>
         <p:nvSpPr>
-          <p:cNvPr id="12" name="TextBox 11"/>
+          <p:cNvPr id="13" name="TextBox 12"/>
           <p:cNvSpPr txBox="1"/>
           <p:nvPr/>
         </p:nvSpPr>
         <p:spPr>
           <a:xfrm>
-            <a:off x="6565392" y="1755648"/>
-            <a:ext cx="4754880" cy="320040"/>
+            <a:off x="6565392" y="1920240"/>
+            <a:ext cx="4754880" cy="292608"/>
           </a:xfrm>
           <a:prstGeom prst="rect">
             <a:avLst/>
@@ -6542,7 +8117,7 @@
               </a:spcAft>
             </a:pPr>
             <a:r>
-              <a:rPr sz="1600" b="1">
+              <a:rPr sz="1500" b="1">
                 <a:solidFill>
                   <a:srgbClr val="FFFFFF"/>
                 </a:solidFill>
@@ -6557,14 +8132,14 @@
       </p:sp>
       <p:sp>
         <p:nvSpPr>
-          <p:cNvPr id="13" name="TextBox 12"/>
+          <p:cNvPr id="14" name="TextBox 13"/>
           <p:cNvSpPr txBox="1"/>
           <p:nvPr/>
         </p:nvSpPr>
         <p:spPr>
           <a:xfrm>
-            <a:off x="6565392" y="2377440"/>
-            <a:ext cx="4754880" cy="2194560"/>
+            <a:off x="6565392" y="2404872"/>
+            <a:ext cx="4754880" cy="1234440"/>
           </a:xfrm>
           <a:prstGeom prst="rect">
             <a:avLst/>
@@ -6582,11 +8157,11 @@
                 <a:spcPts val="0"/>
               </a:spcBef>
               <a:spcAft>
-                <a:spcPts val="1200"/>
+                <a:spcPts val="800"/>
               </a:spcAft>
             </a:pPr>
             <a:r>
-              <a:rPr sz="1500" b="1">
+              <a:rPr sz="1300" b="1">
                 <a:solidFill>
                   <a:srgbClr val="141C24"/>
                 </a:solidFill>
@@ -6603,32 +8178,11 @@
                 <a:spcPts val="0"/>
               </a:spcBef>
               <a:spcAft>
-                <a:spcPts val="1200"/>
+                <a:spcPts val="0"/>
               </a:spcAft>
             </a:pPr>
             <a:r>
-              <a:rPr sz="1500" b="1">
-                <a:solidFill>
-                  <a:srgbClr val="141C24"/>
-                </a:solidFill>
-                <a:latin typeface="Calibri"/>
-                <a:ea typeface="Calibri"/>
-                <a:cs typeface="Calibri"/>
-              </a:rPr>
-              <a:t>Cuts billable waste for the team</a:t>
-            </a:r>
-          </a:p>
-          <a:p>
-            <a:pPr algn="l">
-              <a:spcBef>
-                <a:spcPts val="0"/>
-              </a:spcBef>
-              <a:spcAft>
-                <a:spcPts val="0"/>
-              </a:spcAft>
-            </a:pPr>
-            <a:r>
-              <a:rPr sz="1500" b="1">
+              <a:rPr sz="1300" b="1">
                 <a:solidFill>
                   <a:srgbClr val="141C24"/>
                 </a:solidFill>
@@ -6643,14 +8197,57 @@
       </p:sp>
       <p:sp>
         <p:nvSpPr>
-          <p:cNvPr id="14" name="TextBox 13"/>
+          <p:cNvPr id="15" name="Rectangle 14"/>
+          <p:cNvSpPr/>
+          <p:nvPr/>
+        </p:nvSpPr>
+        <p:spPr>
+          <a:xfrm>
+            <a:off x="640080" y="3886200"/>
+            <a:ext cx="10972800" cy="1874519"/>
+          </a:xfrm>
+          <a:prstGeom prst="rect">
+            <a:avLst/>
+          </a:prstGeom>
+          <a:solidFill>
+            <a:srgbClr val="084C49"/>
+          </a:solidFill>
+          <a:ln>
+            <a:noFill/>
+          </a:ln>
+        </p:spPr>
+        <p:style>
+          <a:lnRef idx="1">
+            <a:schemeClr val="accent1"/>
+          </a:lnRef>
+          <a:fillRef idx="3">
+            <a:schemeClr val="accent1"/>
+          </a:fillRef>
+          <a:effectRef idx="2">
+            <a:schemeClr val="accent1"/>
+          </a:effectRef>
+          <a:fontRef idx="minor">
+            <a:schemeClr val="lt1"/>
+          </a:fontRef>
+        </p:style>
+        <p:txBody>
+          <a:bodyPr rtlCol="0" anchor="ctr"/>
+          <a:lstStyle/>
+          <a:p>
+            <a:pPr algn="ctr"/>
+          </a:p>
+        </p:txBody>
+      </p:sp>
+      <p:sp>
+        <p:nvSpPr>
+          <p:cNvPr id="16" name="TextBox 15"/>
           <p:cNvSpPr txBox="1"/>
           <p:nvPr/>
         </p:nvSpPr>
         <p:spPr>
           <a:xfrm>
-            <a:off x="640080" y="4983480"/>
-            <a:ext cx="10972800" cy="822960"/>
+            <a:off x="868680" y="3995928"/>
+            <a:ext cx="10515600" cy="320040"/>
           </a:xfrm>
           <a:prstGeom prst="rect">
             <a:avLst/>
@@ -6672,29 +8269,29 @@
               </a:spcAft>
             </a:pPr>
             <a:r>
-              <a:rPr sz="1500" b="1">
-                <a:solidFill>
-                  <a:srgbClr val="084C49"/>
+              <a:rPr sz="1600" b="1">
+                <a:solidFill>
+                  <a:srgbClr val="FFFFFF"/>
                 </a:solidFill>
                 <a:latin typeface="Calibri"/>
                 <a:ea typeface="Calibri"/>
                 <a:cs typeface="Calibri"/>
               </a:rPr>
-              <a:t>Unique wedge: Token Risk → provider policy pack → global + per-team $ proof.</a:t>
-            </a:r>
-          </a:p>
-        </p:txBody>
-      </p:sp>
-      <p:sp>
-        <p:nvSpPr>
-          <p:cNvPr id="15" name="TextBox 14"/>
+              <a:t>What makes us unique</a:t>
+            </a:r>
+          </a:p>
+        </p:txBody>
+      </p:sp>
+      <p:sp>
+        <p:nvSpPr>
+          <p:cNvPr id="17" name="TextBox 16"/>
           <p:cNvSpPr txBox="1"/>
           <p:nvPr/>
         </p:nvSpPr>
         <p:spPr>
           <a:xfrm>
-            <a:off x="640080" y="6492240"/>
-            <a:ext cx="10972800" cy="256032"/>
+            <a:off x="868680" y="4343400"/>
+            <a:ext cx="10515600" cy="1325880"/>
           </a:xfrm>
           <a:prstGeom prst="rect">
             <a:avLst/>
@@ -6712,19 +8309,126 @@
                 <a:spcPts val="0"/>
               </a:spcBef>
               <a:spcAft>
-                <a:spcPts val="0"/>
+                <a:spcPts val="600"/>
               </a:spcAft>
             </a:pPr>
             <a:r>
-              <a:rPr sz="1100" b="0">
-                <a:solidFill>
-                  <a:srgbClr val="4A5766"/>
+              <a:rPr sz="1300" b="0">
+                <a:solidFill>
+                  <a:srgbClr val="B7E0DC"/>
                 </a:solidFill>
                 <a:latin typeface="Calibri"/>
                 <a:ea typeface="Calibri"/>
                 <a:cs typeface="Calibri"/>
               </a:rPr>
-              <a:t>TokenForge  ·  AI Coding FinOps  ·  Hackathon pitch  ·  4 / 10</a:t>
+              <a:t>• Detect → Fix → Prove closed loop on billable context waste</a:t>
+            </a:r>
+          </a:p>
+          <a:p>
+            <a:pPr algn="l">
+              <a:spcBef>
+                <a:spcPts val="0"/>
+              </a:spcBef>
+              <a:spcAft>
+                <a:spcPts val="600"/>
+              </a:spcAft>
+            </a:pPr>
+            <a:r>
+              <a:rPr sz="1300" b="0">
+                <a:solidFill>
+                  <a:srgbClr val="B7E0DC"/>
+                </a:solidFill>
+                <a:latin typeface="Calibri"/>
+                <a:ea typeface="Calibri"/>
+                <a:cs typeface="Calibri"/>
+              </a:rPr>
+              <a:t>• Provider-agnostic kernel + pluggable Fix / LLM enricher adapters</a:t>
+            </a:r>
+          </a:p>
+          <a:p>
+            <a:pPr algn="l">
+              <a:spcBef>
+                <a:spcPts val="0"/>
+              </a:spcBef>
+              <a:spcAft>
+                <a:spcPts val="600"/>
+              </a:spcAft>
+            </a:pPr>
+            <a:r>
+              <a:rPr sz="1300" b="0">
+                <a:solidFill>
+                  <a:srgbClr val="B7E0DC"/>
+                </a:solidFill>
+                <a:latin typeface="Calibri"/>
+                <a:ea typeface="Calibri"/>
+                <a:cs typeface="Calibri"/>
+              </a:rPr>
+              <a:t>• Estimate vs imported bill reconciliation — not scan totals alone</a:t>
+            </a:r>
+          </a:p>
+          <a:p>
+            <a:pPr algn="l">
+              <a:spcBef>
+                <a:spcPts val="0"/>
+              </a:spcBef>
+              <a:spcAft>
+                <a:spcPts val="0"/>
+              </a:spcAft>
+            </a:pPr>
+            <a:r>
+              <a:rPr sz="1300" b="0">
+                <a:solidFill>
+                  <a:srgbClr val="B7E0DC"/>
+                </a:solidFill>
+                <a:latin typeface="Calibri"/>
+                <a:ea typeface="Calibri"/>
+                <a:cs typeface="Calibri"/>
+              </a:rPr>
+              <a:t>• Hybrid AI opt-in (cursor-cli:composer-2.5) on bounded candidates</a:t>
+            </a:r>
+          </a:p>
+        </p:txBody>
+      </p:sp>
+      <p:sp>
+        <p:nvSpPr>
+          <p:cNvPr id="18" name="TextBox 17"/>
+          <p:cNvSpPr txBox="1"/>
+          <p:nvPr/>
+        </p:nvSpPr>
+        <p:spPr>
+          <a:xfrm>
+            <a:off x="640080" y="6492240"/>
+            <a:ext cx="10972800" cy="256032"/>
+          </a:xfrm>
+          <a:prstGeom prst="rect">
+            <a:avLst/>
+          </a:prstGeom>
+          <a:noFill/>
+        </p:spPr>
+        <p:txBody>
+          <a:bodyPr wrap="square">
+            <a:spAutoFit/>
+          </a:bodyPr>
+          <a:lstStyle/>
+          <a:p>
+            <a:pPr algn="l">
+              <a:spcBef>
+                <a:spcPts val="0"/>
+              </a:spcBef>
+              <a:spcAft>
+                <a:spcPts val="0"/>
+              </a:spcAft>
+            </a:pPr>
+            <a:r>
+              <a:rPr sz="1100" b="0">
+                <a:solidFill>
+                  <a:srgbClr val="4A5766"/>
+                </a:solidFill>
+                <a:latin typeface="Calibri"/>
+                <a:ea typeface="Calibri"/>
+                <a:cs typeface="Calibri"/>
+              </a:rPr>
+              <a:t>TokenForge  ·  AI Coding FinOps  ·  Hackathon pitch  ·  4 / 11</a:t>
             </a:r>
           </a:p>
         </p:txBody>
@@ -7605,7 +9309,7 @@
                 <a:ea typeface="Calibri"/>
                 <a:cs typeface="Calibri"/>
               </a:rPr>
-              <a:t>TokenForge  ·  AI Coding FinOps  ·  Hackathon pitch  ·  5 / 10</a:t>
+              <a:t>TokenForge  ·  AI Coding FinOps  ·  Hackathon pitch  ·  5 / 11</a:t>
             </a:r>
           </a:p>
         </p:txBody>
@@ -8015,7 +9719,7 @@
                 <a:ea typeface="Calibri"/>
                 <a:cs typeface="Calibri"/>
               </a:rPr>
-              <a:t>Score risky tabs &amp; paths.</a:t>
+              <a:t>Heuristic default +</a:t>
             </a:r>
           </a:p>
           <a:p>
@@ -8036,7 +9740,7 @@
                 <a:ea typeface="Calibri"/>
                 <a:cs typeface="Calibri"/>
               </a:rPr>
-              <a:t>Provider-agnostic.</a:t>
+              <a:t>opt-in hybrid</a:t>
             </a:r>
           </a:p>
           <a:p>
@@ -8057,7 +9761,7 @@
                 <a:ea typeface="Calibri"/>
                 <a:cs typeface="Calibri"/>
               </a:rPr>
-              <a:t>Hybrid LLM optional.</a:t>
+              <a:t>(cursor-cli:composer-2.5).</a:t>
             </a:r>
           </a:p>
         </p:txBody>
@@ -8535,7 +10239,7 @@
                 <a:ea typeface="Calibri"/>
                 <a:cs typeface="Calibri"/>
               </a:rPr>
-              <a:t>Global BU dashboard +</a:t>
+              <a:t>Variance board +</a:t>
             </a:r>
           </a:p>
           <a:p>
@@ -8556,7 +10260,7 @@
                 <a:ea typeface="Calibri"/>
                 <a:cs typeface="Calibri"/>
               </a:rPr>
-              <a:t>per-team / per-repo views.</a:t>
+              <a:t>Assumptions + imported bill.</a:t>
             </a:r>
           </a:p>
           <a:p>
@@ -8621,7 +10325,7 @@
                 <a:ea typeface="Calibri"/>
                 <a:cs typeface="Calibri"/>
               </a:rPr>
-              <a:t>TokenForge  ·  AI Coding FinOps  ·  Hackathon pitch  ·  6 / 10</a:t>
+              <a:t>TokenForge  ·  AI Coding FinOps  ·  Hackathon pitch  ·  6 / 11</a:t>
             </a:r>
           </a:p>
         </p:txBody>
@@ -8769,7 +10473,7 @@
                 <a:ea typeface="Calibri"/>
                 <a:cs typeface="Calibri"/>
               </a:rPr>
-              <a:t>06  ·  LIVE DEMO</a:t>
+              <a:t>PRESENTER RUN-OF-SHOW  ·  DO NOT SHOW LIVE</a:t>
             </a:r>
           </a:p>
         </p:txBody>
@@ -8783,7 +10487,7 @@
         <p:spPr>
           <a:xfrm>
             <a:off x="640080" y="777240"/>
-            <a:ext cx="10972800" cy="640080"/>
+            <a:ext cx="10972800" cy="548640"/>
           </a:xfrm>
           <a:prstGeom prst="rect">
             <a:avLst/>
@@ -8805,7 +10509,7 @@
               </a:spcAft>
             </a:pPr>
             <a:r>
-              <a:rPr sz="3000" b="1">
+              <a:rPr sz="2800" b="1">
                 <a:solidFill>
                   <a:srgbClr val="141C24"/>
                 </a:solidFill>
@@ -8813,7 +10517,7 @@
                 <a:ea typeface="Calibri"/>
                 <a:cs typeface="Calibri"/>
               </a:rPr>
-              <a:t>Five minutes. Three surfaces. One loop.</a:t>
+              <a:t>Ten minutes. Four live beats.</a:t>
             </a:r>
           </a:p>
         </p:txBody>
@@ -8826,8 +10530,8 @@
         </p:nvSpPr>
         <p:spPr>
           <a:xfrm>
-            <a:off x="640080" y="1691640"/>
-            <a:ext cx="2606040" cy="3383280"/>
+            <a:off x="640080" y="1600200"/>
+            <a:ext cx="2148840" cy="3520440"/>
           </a:xfrm>
           <a:prstGeom prst="rect">
             <a:avLst/>
@@ -8869,8 +10573,8 @@
         </p:nvSpPr>
         <p:spPr>
           <a:xfrm>
-            <a:off x="640080" y="1691640"/>
-            <a:ext cx="73152" cy="3383280"/>
+            <a:off x="640080" y="1600200"/>
+            <a:ext cx="73152" cy="3520440"/>
           </a:xfrm>
           <a:prstGeom prst="rect">
             <a:avLst/>
@@ -8912,8 +10616,8 @@
         </p:nvSpPr>
         <p:spPr>
           <a:xfrm>
-            <a:off x="640080" y="1691640"/>
-            <a:ext cx="2606040" cy="3383280"/>
+            <a:off x="640080" y="1600200"/>
+            <a:ext cx="2148840" cy="3520440"/>
           </a:xfrm>
           <a:prstGeom prst="rect">
             <a:avLst/>
@@ -8955,8 +10659,8 @@
         </p:nvSpPr>
         <p:spPr>
           <a:xfrm>
-            <a:off x="841248" y="1856232"/>
-            <a:ext cx="2203704" cy="502920"/>
+            <a:off x="841248" y="1764792"/>
+            <a:ext cx="1746504" cy="502920"/>
           </a:xfrm>
           <a:prstGeom prst="rect">
             <a:avLst/>
@@ -8976,7 +10680,7 @@
               </a:spcAft>
             </a:pPr>
             <a:r>
-              <a:rPr sz="1500" b="1">
+              <a:rPr sz="1200" b="1">
                 <a:solidFill>
                   <a:srgbClr val="141C24"/>
                 </a:solidFill>
@@ -8984,7 +10688,7 @@
                 <a:ea typeface="Calibri"/>
                 <a:cs typeface="Calibri"/>
               </a:rPr>
-              <a:t>1. Detect</a:t>
+              <a:t>Open 0:00–2:15  [A]</a:t>
             </a:r>
           </a:p>
         </p:txBody>
@@ -8997,8 +10701,8 @@
         </p:nvSpPr>
         <p:spPr>
           <a:xfrm>
-            <a:off x="841248" y="2432304"/>
-            <a:ext cx="2203704" cy="2496312"/>
+            <a:off x="841248" y="2340864"/>
+            <a:ext cx="1746504" cy="2633472"/>
           </a:xfrm>
           <a:prstGeom prst="rect">
             <a:avLst/>
@@ -9020,7 +10724,7 @@
               </a:spcAft>
             </a:pPr>
             <a:r>
-              <a:rPr sz="1300" b="0">
+              <a:rPr sz="1200" b="0">
                 <a:solidFill>
                   <a:srgbClr val="4A5766"/>
                 </a:solidFill>
@@ -9028,7 +10732,7 @@
                 <a:ea typeface="Calibri"/>
                 <a:cs typeface="Calibri"/>
               </a:rPr>
-              <a:t>Context Guard on noisy tabs.</a:t>
+              <a:t>Slides 1–6</a:t>
             </a:r>
           </a:p>
           <a:p>
@@ -9041,7 +10745,7 @@
               </a:spcAft>
             </a:pPr>
             <a:r>
-              <a:rPr sz="1300" b="0">
+              <a:rPr sz="1200" b="0">
                 <a:solidFill>
                   <a:srgbClr val="4A5766"/>
                 </a:solidFill>
@@ -9049,7 +10753,7 @@
                 <a:ea typeface="Calibri"/>
                 <a:cs typeface="Calibri"/>
               </a:rPr>
-              <a:t>Filter lockfile → risk drops.</a:t>
+              <a:t>Competition + uniqueness</a:t>
             </a:r>
           </a:p>
         </p:txBody>
@@ -9062,8 +10766,8 @@
         </p:nvSpPr>
         <p:spPr>
           <a:xfrm>
-            <a:off x="3447288" y="1691640"/>
-            <a:ext cx="2606040" cy="3383280"/>
+            <a:off x="2953512" y="1600200"/>
+            <a:ext cx="2148840" cy="3520440"/>
           </a:xfrm>
           <a:prstGeom prst="rect">
             <a:avLst/>
@@ -9105,8 +10809,8 @@
         </p:nvSpPr>
         <p:spPr>
           <a:xfrm>
-            <a:off x="3447288" y="1691640"/>
-            <a:ext cx="73152" cy="3383280"/>
+            <a:off x="2953512" y="1600200"/>
+            <a:ext cx="73152" cy="3520440"/>
           </a:xfrm>
           <a:prstGeom prst="rect">
             <a:avLst/>
@@ -9148,8 +10852,8 @@
         </p:nvSpPr>
         <p:spPr>
           <a:xfrm>
-            <a:off x="3447288" y="1691640"/>
-            <a:ext cx="2606040" cy="3383280"/>
+            <a:off x="2953512" y="1600200"/>
+            <a:ext cx="2148840" cy="3520440"/>
           </a:xfrm>
           <a:prstGeom prst="rect">
             <a:avLst/>
@@ -9191,8 +10895,8 @@
         </p:nvSpPr>
         <p:spPr>
           <a:xfrm>
-            <a:off x="3648456" y="1856232"/>
-            <a:ext cx="2203704" cy="502920"/>
+            <a:off x="3154680" y="1764792"/>
+            <a:ext cx="1746504" cy="502920"/>
           </a:xfrm>
           <a:prstGeom prst="rect">
             <a:avLst/>
@@ -9212,7 +10916,7 @@
               </a:spcAft>
             </a:pPr>
             <a:r>
-              <a:rPr sz="1500" b="1">
+              <a:rPr sz="1200" b="1">
                 <a:solidFill>
                   <a:srgbClr val="141C24"/>
                 </a:solidFill>
@@ -9220,7 +10924,7 @@
                 <a:ea typeface="Calibri"/>
                 <a:cs typeface="Calibri"/>
               </a:rPr>
-              <a:t>2. Fix</a:t>
+              <a:t>Detect+Fix 2:15–4:45  [B]</a:t>
             </a:r>
           </a:p>
         </p:txBody>
@@ -9233,8 +10937,8 @@
         </p:nvSpPr>
         <p:spPr>
           <a:xfrm>
-            <a:off x="3648456" y="2432304"/>
-            <a:ext cx="2203704" cy="2496312"/>
+            <a:off x="3154680" y="2340864"/>
+            <a:ext cx="1746504" cy="2633472"/>
           </a:xfrm>
           <a:prstGeom prst="rect">
             <a:avLst/>
@@ -9256,7 +10960,7 @@
               </a:spcAft>
             </a:pPr>
             <a:r>
-              <a:rPr sz="1300" b="0">
+              <a:rPr sz="1200" b="0">
                 <a:solidFill>
                   <a:srgbClr val="4A5766"/>
                 </a:solidFill>
@@ -9264,28 +10968,7 @@
                 <a:ea typeface="Calibri"/>
                 <a:cs typeface="Calibri"/>
               </a:rPr>
-              <a:t>CLI scan → apply policy pack</a:t>
-            </a:r>
-          </a:p>
-          <a:p>
-            <a:pPr algn="l">
-              <a:spcBef>
-                <a:spcPts val="0"/>
-              </a:spcBef>
-              <a:spcAft>
-                <a:spcPts val="400"/>
-              </a:spcAft>
-            </a:pPr>
-            <a:r>
-              <a:rPr sz="1300" b="0">
-                <a:solidFill>
-                  <a:srgbClr val="4A5766"/>
-                </a:solidFill>
-                <a:latin typeface="Calibri"/>
-                <a:ea typeface="Calibri"/>
-                <a:cs typeface="Calibri"/>
-              </a:rPr>
-              <a:t>(or org-pack for the estate).</a:t>
+              <a:t>Extension → scan → apply --dry-run</a:t>
             </a:r>
           </a:p>
         </p:txBody>
@@ -9298,8 +10981,8 @@
         </p:nvSpPr>
         <p:spPr>
           <a:xfrm>
-            <a:off x="6254496" y="1691640"/>
-            <a:ext cx="2606040" cy="3383280"/>
+            <a:off x="5266944" y="1600200"/>
+            <a:ext cx="2148840" cy="3520440"/>
           </a:xfrm>
           <a:prstGeom prst="rect">
             <a:avLst/>
@@ -9341,8 +11024,8 @@
         </p:nvSpPr>
         <p:spPr>
           <a:xfrm>
-            <a:off x="6254496" y="1691640"/>
-            <a:ext cx="73152" cy="3383280"/>
+            <a:off x="5266944" y="1600200"/>
+            <a:ext cx="73152" cy="3520440"/>
           </a:xfrm>
           <a:prstGeom prst="rect">
             <a:avLst/>
@@ -9384,8 +11067,8 @@
         </p:nvSpPr>
         <p:spPr>
           <a:xfrm>
-            <a:off x="6254496" y="1691640"/>
-            <a:ext cx="2606040" cy="3383280"/>
+            <a:off x="5266944" y="1600200"/>
+            <a:ext cx="2148840" cy="3520440"/>
           </a:xfrm>
           <a:prstGeom prst="rect">
             <a:avLst/>
@@ -9427,8 +11110,8 @@
         </p:nvSpPr>
         <p:spPr>
           <a:xfrm>
-            <a:off x="6455664" y="1856232"/>
-            <a:ext cx="2203704" cy="502920"/>
+            <a:off x="5468112" y="1764792"/>
+            <a:ext cx="1746504" cy="502920"/>
           </a:xfrm>
           <a:prstGeom prst="rect">
             <a:avLst/>
@@ -9448,7 +11131,7 @@
               </a:spcAft>
             </a:pPr>
             <a:r>
-              <a:rPr sz="1500" b="1">
+              <a:rPr sz="1200" b="1">
                 <a:solidFill>
                   <a:srgbClr val="141C24"/>
                 </a:solidFill>
@@ -9456,7 +11139,7 @@
                 <a:ea typeface="Calibri"/>
                 <a:cs typeface="Calibri"/>
               </a:rPr>
-              <a:t>3. Prove</a:t>
+              <a:t>Prove 4:45–7:00  [C]</a:t>
             </a:r>
           </a:p>
         </p:txBody>
@@ -9469,8 +11152,8 @@
         </p:nvSpPr>
         <p:spPr>
           <a:xfrm>
-            <a:off x="6455664" y="2432304"/>
-            <a:ext cx="2203704" cy="2496312"/>
+            <a:off x="5468112" y="2340864"/>
+            <a:ext cx="1746504" cy="2633472"/>
           </a:xfrm>
           <a:prstGeom prst="rect">
             <a:avLst/>
@@ -9492,7 +11175,7 @@
               </a:spcAft>
             </a:pPr>
             <a:r>
-              <a:rPr sz="1300" b="0">
+              <a:rPr sz="1200" b="0">
                 <a:solidFill>
                   <a:srgbClr val="4A5766"/>
                 </a:solidFill>
@@ -9500,7 +11183,7 @@
                 <a:ea typeface="Calibri"/>
                 <a:cs typeface="Calibri"/>
               </a:rPr>
-              <a:t>Global Overview → team drill-down.</a:t>
+              <a:t>Assumptions ~30%</a:t>
             </a:r>
           </a:p>
           <a:p>
@@ -9513,7 +11196,7 @@
               </a:spcAft>
             </a:pPr>
             <a:r>
-              <a:rPr sz="1300" b="0">
+              <a:rPr sz="1200" b="0">
                 <a:solidFill>
                   <a:srgbClr val="4A5766"/>
                 </a:solidFill>
@@ -9521,7 +11204,7 @@
                 <a:ea typeface="Calibri"/>
                 <a:cs typeface="Calibri"/>
               </a:rPr>
-              <a:t>Architecture mix + usage import.</a:t>
+              <a:t>Variance 3 KPIs</a:t>
             </a:r>
           </a:p>
         </p:txBody>
@@ -9534,8 +11217,8 @@
         </p:nvSpPr>
         <p:spPr>
           <a:xfrm>
-            <a:off x="9061704" y="1691640"/>
-            <a:ext cx="2606040" cy="3383280"/>
+            <a:off x="7580376" y="1600200"/>
+            <a:ext cx="2148840" cy="3520440"/>
           </a:xfrm>
           <a:prstGeom prst="rect">
             <a:avLst/>
@@ -9577,8 +11260,244 @@
         </p:nvSpPr>
         <p:spPr>
           <a:xfrm>
-            <a:off x="9061704" y="1691640"/>
-            <a:ext cx="73152" cy="3383280"/>
+            <a:off x="7580376" y="1600200"/>
+            <a:ext cx="73152" cy="3520440"/>
+          </a:xfrm>
+          <a:prstGeom prst="rect">
+            <a:avLst/>
+          </a:prstGeom>
+          <a:solidFill>
+            <a:srgbClr val="0B6E6A"/>
+          </a:solidFill>
+          <a:ln>
+            <a:noFill/>
+          </a:ln>
+        </p:spPr>
+        <p:style>
+          <a:lnRef idx="1">
+            <a:schemeClr val="accent1"/>
+          </a:lnRef>
+          <a:fillRef idx="3">
+            <a:schemeClr val="accent1"/>
+          </a:fillRef>
+          <a:effectRef idx="2">
+            <a:schemeClr val="accent1"/>
+          </a:effectRef>
+          <a:fontRef idx="minor">
+            <a:schemeClr val="lt1"/>
+          </a:fontRef>
+        </p:style>
+        <p:txBody>
+          <a:bodyPr rtlCol="0" anchor="ctr"/>
+          <a:lstStyle/>
+          <a:p>
+            <a:pPr algn="ctr"/>
+          </a:p>
+        </p:txBody>
+      </p:sp>
+      <p:sp>
+        <p:nvSpPr>
+          <p:cNvPr id="23" name="Rectangle 22"/>
+          <p:cNvSpPr/>
+          <p:nvPr/>
+        </p:nvSpPr>
+        <p:spPr>
+          <a:xfrm>
+            <a:off x="7580376" y="1600200"/>
+            <a:ext cx="2148840" cy="3520440"/>
+          </a:xfrm>
+          <a:prstGeom prst="rect">
+            <a:avLst/>
+          </a:prstGeom>
+          <a:noFill/>
+          <a:ln w="12700">
+            <a:solidFill>
+              <a:srgbClr val="D8DEE5"/>
+            </a:solidFill>
+          </a:ln>
+        </p:spPr>
+        <p:style>
+          <a:lnRef idx="1">
+            <a:schemeClr val="accent1"/>
+          </a:lnRef>
+          <a:fillRef idx="3">
+            <a:schemeClr val="accent1"/>
+          </a:fillRef>
+          <a:effectRef idx="2">
+            <a:schemeClr val="accent1"/>
+          </a:effectRef>
+          <a:fontRef idx="minor">
+            <a:schemeClr val="lt1"/>
+          </a:fontRef>
+        </p:style>
+        <p:txBody>
+          <a:bodyPr rtlCol="0" anchor="ctr"/>
+          <a:lstStyle/>
+          <a:p>
+            <a:pPr algn="ctr"/>
+          </a:p>
+        </p:txBody>
+      </p:sp>
+      <p:sp>
+        <p:nvSpPr>
+          <p:cNvPr id="24" name="TextBox 23"/>
+          <p:cNvSpPr txBox="1"/>
+          <p:nvPr/>
+        </p:nvSpPr>
+        <p:spPr>
+          <a:xfrm>
+            <a:off x="7781544" y="1764792"/>
+            <a:ext cx="1746504" cy="502920"/>
+          </a:xfrm>
+          <a:prstGeom prst="rect">
+            <a:avLst/>
+          </a:prstGeom>
+          <a:noFill/>
+        </p:spPr>
+        <p:txBody>
+          <a:bodyPr wrap="square"/>
+          <a:lstStyle/>
+          <a:p>
+            <a:pPr algn="l">
+              <a:spcBef>
+                <a:spcPts val="0"/>
+              </a:spcBef>
+              <a:spcAft>
+                <a:spcPts val="0"/>
+              </a:spcAft>
+            </a:pPr>
+            <a:r>
+              <a:rPr sz="1200" b="1">
+                <a:solidFill>
+                  <a:srgbClr val="141C24"/>
+                </a:solidFill>
+                <a:latin typeface="Calibri"/>
+                <a:ea typeface="Calibri"/>
+                <a:cs typeface="Calibri"/>
+              </a:rPr>
+              <a:t>Hybrid 7:00–8:30  [D/B]</a:t>
+            </a:r>
+          </a:p>
+        </p:txBody>
+      </p:sp>
+      <p:sp>
+        <p:nvSpPr>
+          <p:cNvPr id="25" name="TextBox 24"/>
+          <p:cNvSpPr txBox="1"/>
+          <p:nvPr/>
+        </p:nvSpPr>
+        <p:spPr>
+          <a:xfrm>
+            <a:off x="7781544" y="2340864"/>
+            <a:ext cx="1746504" cy="2633472"/>
+          </a:xfrm>
+          <a:prstGeom prst="rect">
+            <a:avLst/>
+          </a:prstGeom>
+          <a:noFill/>
+        </p:spPr>
+        <p:txBody>
+          <a:bodyPr wrap="square">
+            <a:spAutoFit/>
+          </a:bodyPr>
+          <a:lstStyle/>
+          <a:p>
+            <a:pPr algn="l">
+              <a:spcBef>
+                <a:spcPts val="0"/>
+              </a:spcBef>
+              <a:spcAft>
+                <a:spcPts val="400"/>
+              </a:spcAft>
+            </a:pPr>
+            <a:r>
+              <a:rPr sz="1200" b="0">
+                <a:solidFill>
+                  <a:srgbClr val="4A5766"/>
+                </a:solidFill>
+                <a:latin typeface="Calibri"/>
+                <a:ea typeface="Calibri"/>
+                <a:cs typeface="Calibri"/>
+              </a:rPr>
+              <a:t>cursor-cli:composer-2.5</a:t>
+            </a:r>
+          </a:p>
+          <a:p>
+            <a:pPr algn="l">
+              <a:spcBef>
+                <a:spcPts val="0"/>
+              </a:spcBef>
+              <a:spcAft>
+                <a:spcPts val="400"/>
+              </a:spcAft>
+            </a:pPr>
+            <a:r>
+              <a:rPr sz="1200" b="0">
+                <a:solidFill>
+                  <a:srgbClr val="4A5766"/>
+                </a:solidFill>
+                <a:latin typeface="Calibri"/>
+                <a:ea typeface="Calibri"/>
+                <a:cs typeface="Calibri"/>
+              </a:rPr>
+              <a:t>instructions-app</a:t>
+            </a:r>
+          </a:p>
+        </p:txBody>
+      </p:sp>
+      <p:sp>
+        <p:nvSpPr>
+          <p:cNvPr id="26" name="Rectangle 25"/>
+          <p:cNvSpPr/>
+          <p:nvPr/>
+        </p:nvSpPr>
+        <p:spPr>
+          <a:xfrm>
+            <a:off x="9893808" y="1600200"/>
+            <a:ext cx="2148840" cy="3520440"/>
+          </a:xfrm>
+          <a:prstGeom prst="rect">
+            <a:avLst/>
+          </a:prstGeom>
+          <a:solidFill>
+            <a:srgbClr val="FFFFFF"/>
+          </a:solidFill>
+          <a:ln>
+            <a:noFill/>
+          </a:ln>
+        </p:spPr>
+        <p:style>
+          <a:lnRef idx="1">
+            <a:schemeClr val="accent1"/>
+          </a:lnRef>
+          <a:fillRef idx="3">
+            <a:schemeClr val="accent1"/>
+          </a:fillRef>
+          <a:effectRef idx="2">
+            <a:schemeClr val="accent1"/>
+          </a:effectRef>
+          <a:fontRef idx="minor">
+            <a:schemeClr val="lt1"/>
+          </a:fontRef>
+        </p:style>
+        <p:txBody>
+          <a:bodyPr rtlCol="0" anchor="ctr"/>
+          <a:lstStyle/>
+          <a:p>
+            <a:pPr algn="ctr"/>
+          </a:p>
+        </p:txBody>
+      </p:sp>
+      <p:sp>
+        <p:nvSpPr>
+          <p:cNvPr id="27" name="Rectangle 26"/>
+          <p:cNvSpPr/>
+          <p:nvPr/>
+        </p:nvSpPr>
+        <p:spPr>
+          <a:xfrm>
+            <a:off x="9893808" y="1600200"/>
+            <a:ext cx="73152" cy="3520440"/>
           </a:xfrm>
           <a:prstGeom prst="rect">
             <a:avLst/>
@@ -9614,14 +11533,14 @@
       </p:sp>
       <p:sp>
         <p:nvSpPr>
-          <p:cNvPr id="23" name="Rectangle 22"/>
+          <p:cNvPr id="28" name="Rectangle 27"/>
           <p:cNvSpPr/>
           <p:nvPr/>
         </p:nvSpPr>
         <p:spPr>
           <a:xfrm>
-            <a:off x="9061704" y="1691640"/>
-            <a:ext cx="2606040" cy="3383280"/>
+            <a:off x="9893808" y="1600200"/>
+            <a:ext cx="2148840" cy="3520440"/>
           </a:xfrm>
           <a:prstGeom prst="rect">
             <a:avLst/>
@@ -9657,14 +11576,14 @@
       </p:sp>
       <p:sp>
         <p:nvSpPr>
-          <p:cNvPr id="24" name="TextBox 23"/>
+          <p:cNvPr id="29" name="TextBox 28"/>
           <p:cNvSpPr txBox="1"/>
           <p:nvPr/>
         </p:nvSpPr>
         <p:spPr>
           <a:xfrm>
-            <a:off x="9262872" y="1856232"/>
-            <a:ext cx="2203704" cy="502920"/>
+            <a:off x="10094976" y="1764792"/>
+            <a:ext cx="1746504" cy="502920"/>
           </a:xfrm>
           <a:prstGeom prst="rect">
             <a:avLst/>
@@ -9684,7 +11603,7 @@
               </a:spcAft>
             </a:pPr>
             <a:r>
-              <a:rPr sz="1500" b="1">
+              <a:rPr sz="1200" b="1">
                 <a:solidFill>
                   <a:srgbClr val="141C24"/>
                 </a:solidFill>
@@ -9692,21 +11611,21 @@
                 <a:ea typeface="Calibri"/>
                 <a:cs typeface="Calibri"/>
               </a:rPr>
-              <a:t>4. Close</a:t>
-            </a:r>
-          </a:p>
-        </p:txBody>
-      </p:sp>
-      <p:sp>
-        <p:nvSpPr>
-          <p:cNvPr id="25" name="TextBox 24"/>
+              <a:t>Close 8:30–10:00  [A]</a:t>
+            </a:r>
+          </a:p>
+        </p:txBody>
+      </p:sp>
+      <p:sp>
+        <p:nvSpPr>
+          <p:cNvPr id="30" name="TextBox 29"/>
           <p:cNvSpPr txBox="1"/>
           <p:nvPr/>
         </p:nvSpPr>
         <p:spPr>
           <a:xfrm>
-            <a:off x="9262872" y="2432304"/>
-            <a:ext cx="2203704" cy="2496312"/>
+            <a:off x="10094976" y="2340864"/>
+            <a:ext cx="1746504" cy="2633472"/>
           </a:xfrm>
           <a:prstGeom prst="rect">
             <a:avLst/>
@@ -9728,7 +11647,7 @@
               </a:spcAft>
             </a:pPr>
             <a:r>
-              <a:rPr sz="1300" b="0">
+              <a:rPr sz="1200" b="0">
                 <a:solidFill>
                   <a:srgbClr val="4A5766"/>
                 </a:solidFill>
@@ -9736,20 +11655,43 @@
                 <a:ea typeface="Calibri"/>
                 <a:cs typeface="Calibri"/>
               </a:rPr>
-              <a:t>Assumptions → ~30% scenario.</a:t>
-            </a:r>
-          </a:p>
+              <a:t>Honesty → Architecture → Takeaway</a:t>
+            </a:r>
+          </a:p>
+        </p:txBody>
+      </p:sp>
+      <p:sp>
+        <p:nvSpPr>
+          <p:cNvPr id="31" name="TextBox 30"/>
+          <p:cNvSpPr txBox="1"/>
+          <p:nvPr/>
+        </p:nvSpPr>
+        <p:spPr>
+          <a:xfrm>
+            <a:off x="640080" y="6492240"/>
+            <a:ext cx="10972800" cy="256032"/>
+          </a:xfrm>
+          <a:prstGeom prst="rect">
+            <a:avLst/>
+          </a:prstGeom>
+          <a:noFill/>
+        </p:spPr>
+        <p:txBody>
+          <a:bodyPr wrap="square">
+            <a:spAutoFit/>
+          </a:bodyPr>
+          <a:lstStyle/>
           <a:p>
             <a:pPr algn="l">
               <a:spcBef>
                 <a:spcPts val="0"/>
               </a:spcBef>
               <a:spcAft>
-                <a:spcPts val="400"/>
+                <a:spcPts val="0"/>
               </a:spcAft>
             </a:pPr>
             <a:r>
-              <a:rPr sz="1300" b="0">
+              <a:rPr sz="1100" b="0">
                 <a:solidFill>
                   <a:srgbClr val="4A5766"/>
                 </a:solidFill>
@@ -9757,51 +11699,7 @@
                 <a:ea typeface="Calibri"/>
                 <a:cs typeface="Calibri"/>
               </a:rPr>
-              <a:t>Memory ≠ FinOps sound bite.</a:t>
-            </a:r>
-          </a:p>
-        </p:txBody>
-      </p:sp>
-      <p:sp>
-        <p:nvSpPr>
-          <p:cNvPr id="26" name="TextBox 25"/>
-          <p:cNvSpPr txBox="1"/>
-          <p:nvPr/>
-        </p:nvSpPr>
-        <p:spPr>
-          <a:xfrm>
-            <a:off x="640080" y="6492240"/>
-            <a:ext cx="10972800" cy="256032"/>
-          </a:xfrm>
-          <a:prstGeom prst="rect">
-            <a:avLst/>
-          </a:prstGeom>
-          <a:noFill/>
-        </p:spPr>
-        <p:txBody>
-          <a:bodyPr wrap="square">
-            <a:spAutoFit/>
-          </a:bodyPr>
-          <a:lstStyle/>
-          <a:p>
-            <a:pPr algn="l">
-              <a:spcBef>
-                <a:spcPts val="0"/>
-              </a:spcBef>
-              <a:spcAft>
-                <a:spcPts val="0"/>
-              </a:spcAft>
-            </a:pPr>
-            <a:r>
-              <a:rPr sz="1100" b="0">
-                <a:solidFill>
-                  <a:srgbClr val="4A5766"/>
-                </a:solidFill>
-                <a:latin typeface="Calibri"/>
-                <a:ea typeface="Calibri"/>
-                <a:cs typeface="Calibri"/>
-              </a:rPr>
-              <a:t>TokenForge  ·  AI Coding FinOps  ·  Hackathon pitch  ·  7 / 10</a:t>
+              <a:t>TokenForge  ·  AI Coding FinOps  ·  Hackathon pitch  ·  7 / 11</a:t>
             </a:r>
           </a:p>
         </p:txBody>
@@ -9949,7 +11847,7 @@
                 <a:ea typeface="Calibri"/>
                 <a:cs typeface="Calibri"/>
               </a:rPr>
-              <a:t>07  ·  HONESTY</a:t>
+              <a:t>08  ·  HONESTY</a:t>
             </a:r>
           </a:p>
         </p:txBody>
@@ -10007,7 +11905,7 @@
         <p:spPr>
           <a:xfrm>
             <a:off x="640080" y="1554480"/>
-            <a:ext cx="5349240" cy="1280160"/>
+            <a:ext cx="5349240" cy="1234440"/>
           </a:xfrm>
           <a:prstGeom prst="rect">
             <a:avLst/>
@@ -10050,7 +11948,7 @@
         <p:spPr>
           <a:xfrm>
             <a:off x="640080" y="1554480"/>
-            <a:ext cx="73152" cy="1280160"/>
+            <a:ext cx="73152" cy="1234440"/>
           </a:xfrm>
           <a:prstGeom prst="rect">
             <a:avLst/>
@@ -10093,7 +11991,7 @@
         <p:spPr>
           <a:xfrm>
             <a:off x="640080" y="1554480"/>
-            <a:ext cx="5349240" cy="1280160"/>
+            <a:ext cx="5349240" cy="1234440"/>
           </a:xfrm>
           <a:prstGeom prst="rect">
             <a:avLst/>
@@ -10178,7 +12076,7 @@
         <p:spPr>
           <a:xfrm>
             <a:off x="841248" y="2295144"/>
-            <a:ext cx="4946904" cy="393192"/>
+            <a:ext cx="4946904" cy="365760"/>
           </a:xfrm>
           <a:prstGeom prst="rect">
             <a:avLst/>
@@ -10208,7 +12106,7 @@
                 <a:ea typeface="Calibri"/>
                 <a:cs typeface="Calibri"/>
               </a:rPr>
-              <a:t>Advise, filter recommended context, write exclusion / instruction packs, prove with transparent assumptions.</a:t>
+              <a:t>Advise, filter context, write policy packs, prove with transparent assumptions + imported bills.</a:t>
             </a:r>
           </a:p>
         </p:txBody>
@@ -10222,7 +12120,7 @@
         <p:spPr>
           <a:xfrm>
             <a:off x="6172200" y="1554480"/>
-            <a:ext cx="5349240" cy="1280160"/>
+            <a:ext cx="5349240" cy="1234440"/>
           </a:xfrm>
           <a:prstGeom prst="rect">
             <a:avLst/>
@@ -10265,7 +12163,7 @@
         <p:spPr>
           <a:xfrm>
             <a:off x="6172200" y="1554480"/>
-            <a:ext cx="73152" cy="1280160"/>
+            <a:ext cx="73152" cy="1234440"/>
           </a:xfrm>
           <a:prstGeom prst="rect">
             <a:avLst/>
@@ -10308,7 +12206,7 @@
         <p:spPr>
           <a:xfrm>
             <a:off x="6172200" y="1554480"/>
-            <a:ext cx="5349240" cy="1280160"/>
+            <a:ext cx="5349240" cy="1234440"/>
           </a:xfrm>
           <a:prstGeom prst="rect">
             <a:avLst/>
@@ -10393,7 +12291,7 @@
         <p:spPr>
           <a:xfrm>
             <a:off x="6373368" y="2295144"/>
-            <a:ext cx="4946904" cy="393192"/>
+            <a:ext cx="4946904" cy="365760"/>
           </a:xfrm>
           <a:prstGeom prst="rect">
             <a:avLst/>
@@ -10436,8 +12334,8 @@
         </p:nvSpPr>
         <p:spPr>
           <a:xfrm>
-            <a:off x="640080" y="2971800"/>
-            <a:ext cx="5349240" cy="1280160"/>
+            <a:off x="640080" y="2926080"/>
+            <a:ext cx="5349240" cy="1234440"/>
           </a:xfrm>
           <a:prstGeom prst="rect">
             <a:avLst/>
@@ -10479,8 +12377,8 @@
         </p:nvSpPr>
         <p:spPr>
           <a:xfrm>
-            <a:off x="640080" y="2971800"/>
-            <a:ext cx="73152" cy="1280160"/>
+            <a:off x="640080" y="2926080"/>
+            <a:ext cx="73152" cy="1234440"/>
           </a:xfrm>
           <a:prstGeom prst="rect">
             <a:avLst/>
@@ -10522,8 +12420,8 @@
         </p:nvSpPr>
         <p:spPr>
           <a:xfrm>
-            <a:off x="640080" y="2971800"/>
-            <a:ext cx="5349240" cy="1280160"/>
+            <a:off x="640080" y="2926080"/>
+            <a:ext cx="5349240" cy="1234440"/>
           </a:xfrm>
           <a:prstGeom prst="rect">
             <a:avLst/>
@@ -10565,7 +12463,7 @@
         </p:nvSpPr>
         <p:spPr>
           <a:xfrm>
-            <a:off x="841248" y="3136392"/>
+            <a:off x="841248" y="3090672"/>
             <a:ext cx="4946904" cy="502920"/>
           </a:xfrm>
           <a:prstGeom prst="rect">
@@ -10594,7 +12492,7 @@
                 <a:ea typeface="Calibri"/>
                 <a:cs typeface="Calibri"/>
               </a:rPr>
-              <a:t>Default scan</a:t>
+              <a:t>Hybrid scan</a:t>
             </a:r>
           </a:p>
         </p:txBody>
@@ -10607,8 +12505,8 @@
         </p:nvSpPr>
         <p:spPr>
           <a:xfrm>
-            <a:off x="841248" y="3712464"/>
-            <a:ext cx="4946904" cy="393192"/>
+            <a:off x="841248" y="3666744"/>
+            <a:ext cx="4946904" cy="365760"/>
           </a:xfrm>
           <a:prstGeom prst="rect">
             <a:avLst/>
@@ -10638,7 +12536,7 @@
                 <a:ea typeface="Calibri"/>
                 <a:cs typeface="Calibri"/>
               </a:rPr>
-              <a:t>Heuristic only — no AI. Hybrid enrich is explicit and bounded.</a:t>
+              <a:t>Default: heuristic. Opt-in: cursor-cli:composer-2.5 on bounded candidates; --allow-external.</a:t>
             </a:r>
           </a:p>
         </p:txBody>
@@ -10651,8 +12549,8 @@
         </p:nvSpPr>
         <p:spPr>
           <a:xfrm>
-            <a:off x="6172200" y="2971800"/>
-            <a:ext cx="5349240" cy="1280160"/>
+            <a:off x="6172200" y="2926080"/>
+            <a:ext cx="5349240" cy="1234440"/>
           </a:xfrm>
           <a:prstGeom prst="rect">
             <a:avLst/>
@@ -10694,8 +12592,8 @@
         </p:nvSpPr>
         <p:spPr>
           <a:xfrm>
-            <a:off x="6172200" y="2971800"/>
-            <a:ext cx="73152" cy="1280160"/>
+            <a:off x="6172200" y="2926080"/>
+            <a:ext cx="73152" cy="1234440"/>
           </a:xfrm>
           <a:prstGeom prst="rect">
             <a:avLst/>
@@ -10737,8 +12635,8 @@
         </p:nvSpPr>
         <p:spPr>
           <a:xfrm>
-            <a:off x="6172200" y="2971800"/>
-            <a:ext cx="5349240" cy="1280160"/>
+            <a:off x="6172200" y="2926080"/>
+            <a:ext cx="5349240" cy="1234440"/>
           </a:xfrm>
           <a:prstGeom prst="rect">
             <a:avLst/>
@@ -10780,7 +12678,7 @@
         </p:nvSpPr>
         <p:spPr>
           <a:xfrm>
-            <a:off x="6373368" y="3136392"/>
+            <a:off x="6373368" y="3090672"/>
             <a:ext cx="4946904" cy="502920"/>
           </a:xfrm>
           <a:prstGeom prst="rect">
@@ -10809,7 +12707,7 @@
                 <a:ea typeface="Calibri"/>
                 <a:cs typeface="Calibri"/>
               </a:rPr>
-              <a:t>~30%</a:t>
+              <a:t>Uniqueness claims</a:t>
             </a:r>
           </a:p>
         </p:txBody>
@@ -10822,8 +12720,8 @@
         </p:nvSpPr>
         <p:spPr>
           <a:xfrm>
-            <a:off x="6373368" y="3712464"/>
-            <a:ext cx="4946904" cy="393192"/>
+            <a:off x="6373368" y="3666744"/>
+            <a:ext cx="4946904" cy="365760"/>
           </a:xfrm>
           <a:prstGeom prst="rect">
             <a:avLst/>
@@ -10853,7 +12751,7 @@
                 <a:ea typeface="Calibri"/>
                 <a:cs typeface="Calibri"/>
               </a:rPr>
-              <a:t>Scenario math on the demo seed — not a universal SLA.</a:t>
+              <a:t>Prove $ via assumptions + bill import — not vendor pipeline metering.</a:t>
             </a:r>
           </a:p>
         </p:txBody>
@@ -10866,8 +12764,8 @@
         </p:nvSpPr>
         <p:spPr>
           <a:xfrm>
-            <a:off x="640080" y="4389120"/>
-            <a:ext cx="5349240" cy="1280160"/>
+            <a:off x="640080" y="4297680"/>
+            <a:ext cx="5349240" cy="1234440"/>
           </a:xfrm>
           <a:prstGeom prst="rect">
             <a:avLst/>
@@ -10909,8 +12807,8 @@
         </p:nvSpPr>
         <p:spPr>
           <a:xfrm>
-            <a:off x="640080" y="4389120"/>
-            <a:ext cx="73152" cy="1280160"/>
+            <a:off x="640080" y="4297680"/>
+            <a:ext cx="73152" cy="1234440"/>
           </a:xfrm>
           <a:prstGeom prst="rect">
             <a:avLst/>
@@ -10952,8 +12850,8 @@
         </p:nvSpPr>
         <p:spPr>
           <a:xfrm>
-            <a:off x="640080" y="4389120"/>
-            <a:ext cx="5349240" cy="1280160"/>
+            <a:off x="640080" y="4297680"/>
+            <a:ext cx="5349240" cy="1234440"/>
           </a:xfrm>
           <a:prstGeom prst="rect">
             <a:avLst/>
@@ -10995,7 +12893,7 @@
         </p:nvSpPr>
         <p:spPr>
           <a:xfrm>
-            <a:off x="841248" y="4553712"/>
+            <a:off x="841248" y="4462272"/>
             <a:ext cx="4946904" cy="502920"/>
           </a:xfrm>
           <a:prstGeom prst="rect">
@@ -11024,7 +12922,7 @@
                 <a:ea typeface="Calibri"/>
                 <a:cs typeface="Calibri"/>
               </a:rPr>
-              <a:t>Usage</a:t>
+              <a:t>~30%</a:t>
             </a:r>
           </a:p>
         </p:txBody>
@@ -11037,8 +12935,8 @@
         </p:nvSpPr>
         <p:spPr>
           <a:xfrm>
-            <a:off x="841248" y="5129784"/>
-            <a:ext cx="4946904" cy="393192"/>
+            <a:off x="841248" y="5038344"/>
+            <a:ext cx="4946904" cy="365760"/>
           </a:xfrm>
           <a:prstGeom prst="rect">
             <a:avLst/>
@@ -11068,7 +12966,7 @@
                 <a:ea typeface="Calibri"/>
                 <a:cs typeface="Calibri"/>
               </a:rPr>
-              <a:t>Import or live sync into UsageMetrics. Estimate vs bill + cohort note.</a:t>
+              <a:t>Scenario math on Assumptions — not a universal SLA.</a:t>
             </a:r>
           </a:p>
         </p:txBody>
@@ -11081,8 +12979,8 @@
         </p:nvSpPr>
         <p:spPr>
           <a:xfrm>
-            <a:off x="6172200" y="4389120"/>
-            <a:ext cx="5349240" cy="1280160"/>
+            <a:off x="6172200" y="4297680"/>
+            <a:ext cx="5349240" cy="1234440"/>
           </a:xfrm>
           <a:prstGeom prst="rect">
             <a:avLst/>
@@ -11124,8 +13022,8 @@
         </p:nvSpPr>
         <p:spPr>
           <a:xfrm>
-            <a:off x="6172200" y="4389120"/>
-            <a:ext cx="73152" cy="1280160"/>
+            <a:off x="6172200" y="4297680"/>
+            <a:ext cx="73152" cy="1234440"/>
           </a:xfrm>
           <a:prstGeom prst="rect">
             <a:avLst/>
@@ -11167,8 +13065,8 @@
         </p:nvSpPr>
         <p:spPr>
           <a:xfrm>
-            <a:off x="6172200" y="4389120"/>
-            <a:ext cx="5349240" cy="1280160"/>
+            <a:off x="6172200" y="4297680"/>
+            <a:ext cx="5349240" cy="1234440"/>
           </a:xfrm>
           <a:prstGeom prst="rect">
             <a:avLst/>
@@ -11210,7 +13108,7 @@
         </p:nvSpPr>
         <p:spPr>
           <a:xfrm>
-            <a:off x="6373368" y="4553712"/>
+            <a:off x="6373368" y="4462272"/>
             <a:ext cx="4946904" cy="502920"/>
           </a:xfrm>
           <a:prstGeom prst="rect">
@@ -11239,7 +13137,7 @@
                 <a:ea typeface="Calibri"/>
                 <a:cs typeface="Calibri"/>
               </a:rPr>
-              <a:t>Metering</a:t>
+              <a:t>Usage</a:t>
             </a:r>
           </a:p>
         </p:txBody>
@@ -11252,8 +13150,8 @@
         </p:nvSpPr>
         <p:spPr>
           <a:xfrm>
-            <a:off x="6373368" y="5129784"/>
-            <a:ext cx="4946904" cy="393192"/>
+            <a:off x="6373368" y="5038344"/>
+            <a:ext cx="4946904" cy="365760"/>
           </a:xfrm>
           <a:prstGeom prst="rect">
             <a:avLst/>
@@ -11283,7 +13181,7 @@
                 <a:ea typeface="Calibri"/>
                 <a:cs typeface="Calibri"/>
               </a:rPr>
-              <a:t>Chat / Agent / AI credits — not unlimited completions.</a:t>
+              <a:t>Import or sync UsageMetrics. Estimate vs bill + variance board.</a:t>
             </a:r>
           </a:p>
         </p:txBody>
@@ -11327,7 +13225,7 @@
                 <a:ea typeface="Calibri"/>
                 <a:cs typeface="Calibri"/>
               </a:rPr>
-              <a:t>TokenForge  ·  AI Coding FinOps  ·  Hackathon pitch  ·  8 / 10</a:t>
+              <a:t>TokenForge  ·  AI Coding FinOps  ·  Hackathon pitch  ·  8 / 11</a:t>
             </a:r>
           </a:p>
         </p:txBody>
@@ -11734,7 +13632,7 @@
                 <a:ea typeface="Calibri"/>
                 <a:cs typeface="Calibri"/>
               </a:rPr>
-              <a:t>Per-team + global Prove</a:t>
+              <a:t>Hybrid enrichers (Cursor CLI, Ollama, …)</a:t>
             </a:r>
           </a:p>
           <a:p>
@@ -11755,7 +13653,7 @@
                 <a:ea typeface="Calibri"/>
                 <a:cs typeface="Calibri"/>
               </a:rPr>
-              <a:t>Architecture tags + usage import/sync</a:t>
+              <a:t>Variance board + honest savings tiers</a:t>
             </a:r>
           </a:p>
           <a:p>
@@ -11776,7 +13674,7 @@
                 <a:ea typeface="Calibri"/>
                 <a:cs typeface="Calibri"/>
               </a:rPr>
-              <a:t>Variance board + change markers + cohort</a:t>
+              <a:t>Per-team + global Prove + usage import</a:t>
             </a:r>
           </a:p>
           <a:p>
@@ -12119,7 +14017,7 @@
                 <a:ea typeface="Calibri"/>
                 <a:cs typeface="Calibri"/>
               </a:rPr>
-              <a:t>TokenForge  ·  AI Coding FinOps  ·  Hackathon pitch  ·  9 / 10</a:t>
+              <a:t>TokenForge  ·  AI Coding FinOps  ·  Hackathon pitch  ·  9 / 11</a:t>
             </a:r>
           </a:p>
         </p:txBody>
@@ -12450,4 +14348,324 @@
   </a:objectDefaults>
   <a:extraClrSchemeLst/>
 </a:theme>
+</file>
+
+<file path=ppt/theme/theme2.xml><?xml version="1.0" encoding="utf-8"?>
+<a:theme xmlns:a="http://schemas.openxmlformats.org/drawingml/2006/main" name="Office Theme">
+  <a:themeElements>
+    <a:clrScheme name="Office">
+      <a:dk1>
+        <a:sysClr val="windowText" lastClr="000000"/>
+      </a:dk1>
+      <a:lt1>
+        <a:sysClr val="window" lastClr="FFFFFF"/>
+      </a:lt1>
+      <a:dk2>
+        <a:srgbClr val="1F497D"/>
+      </a:dk2>
+      <a:lt2>
+        <a:srgbClr val="EEECE1"/>
+      </a:lt2>
+      <a:accent1>
+        <a:srgbClr val="4F81BD"/>
+      </a:accent1>
+      <a:accent2>
+        <a:srgbClr val="C0504D"/>
+      </a:accent2>
+      <a:accent3>
+        <a:srgbClr val="9BBB59"/>
+      </a:accent3>
+      <a:accent4>
+        <a:srgbClr val="8064A2"/>
+      </a:accent4>
+      <a:accent5>
+        <a:srgbClr val="4BACC6"/>
+      </a:accent5>
+      <a:accent6>
+        <a:srgbClr val="F79646"/>
+      </a:accent6>
+      <a:hlink>
+        <a:srgbClr val="0000FF"/>
+      </a:hlink>
+      <a:folHlink>
+        <a:srgbClr val="800080"/>
+      </a:folHlink>
+    </a:clrScheme>
+    <a:fontScheme name="Office">
+      <a:majorFont>
+        <a:latin typeface="Calibri"/>
+        <a:ea typeface=""/>
+        <a:cs typeface=""/>
+        <a:font script="Jpan" typeface="ＭＳ Ｐゴシック"/>
+        <a:font script="Hang" typeface="맑은 고딕"/>
+        <a:font script="Hans" typeface="宋体"/>
+        <a:font script="Hant" typeface="新細明體"/>
+        <a:font script="Arab" typeface="Times New Roman"/>
+        <a:font script="Hebr" typeface="Times New Roman"/>
+        <a:font script="Thai" typeface="Angsana New"/>
+        <a:font script="Ethi" typeface="Nyala"/>
+        <a:font script="Beng" typeface="Vrinda"/>
+        <a:font script="Gujr" typeface="Shruti"/>
+        <a:font script="Khmr" typeface="MoolBoran"/>
+        <a:font script="Knda" typeface="Tunga"/>
+        <a:font script="Guru" typeface="Raavi"/>
+        <a:font script="Cans" typeface="Euphemia"/>
+        <a:font script="Cher" typeface="Plantagenet Cherokee"/>
+        <a:font script="Yiii" typeface="Microsoft Yi Baiti"/>
+        <a:font script="Tibt" typeface="Microsoft Himalaya"/>
+        <a:font script="Thaa" typeface="MV Boli"/>
+        <a:font script="Deva" typeface="Mangal"/>
+        <a:font script="Telu" typeface="Gautami"/>
+        <a:font script="Taml" typeface="Latha"/>
+        <a:font script="Syrc" typeface="Estrangelo Edessa"/>
+        <a:font script="Orya" typeface="Kalinga"/>
+        <a:font script="Mlym" typeface="Kartika"/>
+        <a:font script="Laoo" typeface="DokChampa"/>
+        <a:font script="Sinh" typeface="Iskoola Pota"/>
+        <a:font script="Mong" typeface="Mongolian Baiti"/>
+        <a:font script="Viet" typeface="Times New Roman"/>
+        <a:font script="Uigh" typeface="Microsoft Uighur"/>
+        <a:font script="Geor" typeface="Sylfaen"/>
+      </a:majorFont>
+      <a:minorFont>
+        <a:latin typeface="Calibri"/>
+        <a:ea typeface=""/>
+        <a:cs typeface=""/>
+        <a:font script="Jpan" typeface="ＭＳ Ｐゴシック"/>
+        <a:font script="Hang" typeface="맑은 고딕"/>
+        <a:font script="Hans" typeface="宋体"/>
+        <a:font script="Hant" typeface="新細明體"/>
+        <a:font script="Arab" typeface="Arial"/>
+        <a:font script="Hebr" typeface="Arial"/>
+        <a:font script="Thai" typeface="Cordia New"/>
+        <a:font script="Ethi" typeface="Nyala"/>
+        <a:font script="Beng" typeface="Vrinda"/>
+        <a:font script="Gujr" typeface="Shruti"/>
+        <a:font script="Khmr" typeface="DaunPenh"/>
+        <a:font script="Knda" typeface="Tunga"/>
+        <a:font script="Guru" typeface="Raavi"/>
+        <a:font script="Cans" typeface="Euphemia"/>
+        <a:font script="Cher" typeface="Plantagenet Cherokee"/>
+        <a:font script="Yiii" typeface="Microsoft Yi Baiti"/>
+        <a:font script="Tibt" typeface="Microsoft Himalaya"/>
+        <a:font script="Thaa" typeface="MV Boli"/>
+        <a:font script="Deva" typeface="Mangal"/>
+        <a:font script="Telu" typeface="Gautami"/>
+        <a:font script="Taml" typeface="Latha"/>
+        <a:font script="Syrc" typeface="Estrangelo Edessa"/>
+        <a:font script="Orya" typeface="Kalinga"/>
+        <a:font script="Mlym" typeface="Kartika"/>
+        <a:font script="Laoo" typeface="DokChampa"/>
+        <a:font script="Sinh" typeface="Iskoola Pota"/>
+        <a:font script="Mong" typeface="Mongolian Baiti"/>
+        <a:font script="Viet" typeface="Arial"/>
+        <a:font script="Uigh" typeface="Microsoft Uighur"/>
+        <a:font script="Geor" typeface="Sylfaen"/>
+      </a:minorFont>
+    </a:fontScheme>
+    <a:fmtScheme name="Office">
+      <a:fillStyleLst>
+        <a:solidFill>
+          <a:schemeClr val="phClr"/>
+        </a:solidFill>
+        <a:gradFill rotWithShape="1">
+          <a:gsLst>
+            <a:gs pos="0">
+              <a:schemeClr val="phClr">
+                <a:tint val="50000"/>
+                <a:satMod val="300000"/>
+              </a:schemeClr>
+            </a:gs>
+            <a:gs pos="35000">
+              <a:schemeClr val="phClr">
+                <a:tint val="37000"/>
+                <a:satMod val="300000"/>
+              </a:schemeClr>
+            </a:gs>
+            <a:gs pos="100000">
+              <a:schemeClr val="phClr">
+                <a:tint val="15000"/>
+                <a:satMod val="350000"/>
+              </a:schemeClr>
+            </a:gs>
+          </a:gsLst>
+          <a:lin ang="16200000" scaled="1"/>
+        </a:gradFill>
+        <a:gradFill rotWithShape="1">
+          <a:gsLst>
+            <a:gs pos="0">
+              <a:schemeClr val="phClr">
+                <a:tint val="100000"/>
+                <a:shade val="100000"/>
+                <a:satMod val="130000"/>
+              </a:schemeClr>
+            </a:gs>
+            <a:gs pos="100000">
+              <a:schemeClr val="phClr">
+                <a:tint val="50000"/>
+                <a:shade val="100000"/>
+                <a:satMod val="350000"/>
+              </a:schemeClr>
+            </a:gs>
+          </a:gsLst>
+          <a:lin ang="16200000" scaled="0"/>
+        </a:gradFill>
+      </a:fillStyleLst>
+      <a:lnStyleLst>
+        <a:ln w="9525" cap="flat" cmpd="sng" algn="ctr">
+          <a:solidFill>
+            <a:schemeClr val="phClr">
+              <a:shade val="95000"/>
+              <a:satMod val="105000"/>
+            </a:schemeClr>
+          </a:solidFill>
+          <a:prstDash val="solid"/>
+        </a:ln>
+        <a:ln w="25400" cap="flat" cmpd="sng" algn="ctr">
+          <a:solidFill>
+            <a:schemeClr val="phClr"/>
+          </a:solidFill>
+          <a:prstDash val="solid"/>
+        </a:ln>
+        <a:ln w="38100" cap="flat" cmpd="sng" algn="ctr">
+          <a:solidFill>
+            <a:schemeClr val="phClr"/>
+          </a:solidFill>
+          <a:prstDash val="solid"/>
+        </a:ln>
+      </a:lnStyleLst>
+      <a:effectStyleLst>
+        <a:effectStyle>
+          <a:effectLst>
+            <a:outerShdw blurRad="40000" dist="20000" dir="5400000" rotWithShape="0">
+              <a:srgbClr val="000000">
+                <a:alpha val="38000"/>
+              </a:srgbClr>
+            </a:outerShdw>
+          </a:effectLst>
+        </a:effectStyle>
+        <a:effectStyle>
+          <a:effectLst>
+            <a:outerShdw blurRad="40000" dist="23000" dir="5400000" rotWithShape="0">
+              <a:srgbClr val="000000">
+                <a:alpha val="35000"/>
+              </a:srgbClr>
+            </a:outerShdw>
+          </a:effectLst>
+        </a:effectStyle>
+        <a:effectStyle>
+          <a:effectLst>
+            <a:outerShdw blurRad="40000" dist="23000" dir="5400000" rotWithShape="0">
+              <a:srgbClr val="000000">
+                <a:alpha val="35000"/>
+              </a:srgbClr>
+            </a:outerShdw>
+          </a:effectLst>
+          <a:scene3d>
+            <a:camera prst="orthographicFront">
+              <a:rot lat="0" lon="0" rev="0"/>
+            </a:camera>
+            <a:lightRig rig="threePt" dir="t">
+              <a:rot lat="0" lon="0" rev="1200000"/>
+            </a:lightRig>
+          </a:scene3d>
+          <a:sp3d>
+            <a:bevelT w="63500" h="25400"/>
+          </a:sp3d>
+        </a:effectStyle>
+      </a:effectStyleLst>
+      <a:bgFillStyleLst>
+        <a:solidFill>
+          <a:schemeClr val="phClr"/>
+        </a:solidFill>
+        <a:gradFill rotWithShape="1">
+          <a:gsLst>
+            <a:gs pos="0">
+              <a:schemeClr val="phClr">
+                <a:tint val="40000"/>
+                <a:satMod val="350000"/>
+              </a:schemeClr>
+            </a:gs>
+            <a:gs pos="40000">
+              <a:schemeClr val="phClr">
+                <a:tint val="45000"/>
+                <a:shade val="99000"/>
+                <a:satMod val="350000"/>
+              </a:schemeClr>
+            </a:gs>
+            <a:gs pos="100000">
+              <a:schemeClr val="phClr">
+                <a:shade val="20000"/>
+                <a:satMod val="255000"/>
+              </a:schemeClr>
+            </a:gs>
+          </a:gsLst>
+          <a:path path="circle">
+            <a:fillToRect l="50000" t="-80000" r="50000" b="180000"/>
+          </a:path>
+        </a:gradFill>
+        <a:gradFill rotWithShape="1">
+          <a:gsLst>
+            <a:gs pos="0">
+              <a:schemeClr val="phClr">
+                <a:tint val="80000"/>
+                <a:satMod val="300000"/>
+              </a:schemeClr>
+            </a:gs>
+            <a:gs pos="100000">
+              <a:schemeClr val="phClr">
+                <a:shade val="30000"/>
+                <a:satMod val="200000"/>
+              </a:schemeClr>
+            </a:gs>
+          </a:gsLst>
+          <a:path path="circle">
+            <a:fillToRect l="50000" t="50000" r="50000" b="50000"/>
+          </a:path>
+        </a:gradFill>
+      </a:bgFillStyleLst>
+    </a:fmtScheme>
+  </a:themeElements>
+  <a:objectDefaults>
+    <a:spDef>
+      <a:spPr/>
+      <a:bodyPr/>
+      <a:lstStyle/>
+      <a:style>
+        <a:lnRef idx="1">
+          <a:schemeClr val="accent1"/>
+        </a:lnRef>
+        <a:fillRef idx="3">
+          <a:schemeClr val="accent1"/>
+        </a:fillRef>
+        <a:effectRef idx="2">
+          <a:schemeClr val="accent1"/>
+        </a:effectRef>
+        <a:fontRef idx="minor">
+          <a:schemeClr val="lt1"/>
+        </a:fontRef>
+      </a:style>
+    </a:spDef>
+    <a:lnDef>
+      <a:spPr/>
+      <a:bodyPr/>
+      <a:lstStyle/>
+      <a:style>
+        <a:lnRef idx="2">
+          <a:schemeClr val="accent1"/>
+        </a:lnRef>
+        <a:fillRef idx="0">
+          <a:schemeClr val="accent1"/>
+        </a:fillRef>
+        <a:effectRef idx="1">
+          <a:schemeClr val="accent1"/>
+        </a:effectRef>
+        <a:fontRef idx="minor">
+          <a:schemeClr val="tx1"/>
+        </a:fontRef>
+      </a:style>
+    </a:lnDef>
+  </a:objectDefaults>
+  <a:extraClrSchemeLst/>
+</a:theme>
 </file>
</xml_diff>